<commit_message>
Created chapters 1-4 full
</commit_message>
<xml_diff>
--- a/input/AI Transformation framework for European CEO’s.pptx
+++ b/input/AI Transformation framework for European CEO’s.pptx
@@ -5,10 +5,12 @@
     <p:sldMasterId id="2147483648" r:id="rId1"/>
   </p:sldMasterIdLst>
   <p:notesMasterIdLst>
-    <p:notesMasterId r:id="rId3"/>
+    <p:notesMasterId r:id="rId5"/>
   </p:notesMasterIdLst>
   <p:sldIdLst>
     <p:sldId id="2147480366" r:id="rId2"/>
+    <p:sldId id="2147480367" r:id="rId3"/>
+    <p:sldId id="2147480368" r:id="rId4"/>
   </p:sldIdLst>
   <p:sldSz cx="12192000" cy="6858000"/>
   <p:notesSz cx="6858000" cy="9144000"/>
@@ -668,6 +670,222 @@
     <p:extLst>
       <p:ext uri="{BB962C8B-B14F-4D97-AF65-F5344CB8AC3E}">
         <p14:creationId xmlns:p14="http://schemas.microsoft.com/office/powerpoint/2010/main" val="985529434"/>
+      </p:ext>
+    </p:extLst>
+  </p:cSld>
+  <p:clrMapOvr>
+    <a:masterClrMapping/>
+  </p:clrMapOvr>
+</p:notes>
+</file>
+
+<file path=ppt/notesSlides/notesSlide2.xml><?xml version="1.0" encoding="utf-8"?>
+<p:notes xmlns:a="http://schemas.openxmlformats.org/drawingml/2006/main" xmlns:r="http://schemas.openxmlformats.org/officeDocument/2006/relationships" xmlns:p="http://schemas.openxmlformats.org/presentationml/2006/main">
+  <p:cSld>
+    <p:spTree>
+      <p:nvGrpSpPr>
+        <p:cNvPr id="1" name="">
+          <a:extLst>
+            <a:ext uri="{FF2B5EF4-FFF2-40B4-BE49-F238E27FC236}">
+              <a16:creationId xmlns:a16="http://schemas.microsoft.com/office/drawing/2014/main" id="{2243DBEA-249C-C242-148C-48F701862517}"/>
+            </a:ext>
+          </a:extLst>
+        </p:cNvPr>
+        <p:cNvGrpSpPr/>
+        <p:nvPr/>
+      </p:nvGrpSpPr>
+      <p:grpSpPr>
+        <a:xfrm>
+          <a:off x="0" y="0"/>
+          <a:ext cx="0" cy="0"/>
+          <a:chOff x="0" y="0"/>
+          <a:chExt cx="0" cy="0"/>
+        </a:xfrm>
+      </p:grpSpPr>
+      <p:sp>
+        <p:nvSpPr>
+          <p:cNvPr id="2" name="Slide Image Placeholder 1">
+            <a:extLst>
+              <a:ext uri="{FF2B5EF4-FFF2-40B4-BE49-F238E27FC236}">
+                <a16:creationId xmlns:a16="http://schemas.microsoft.com/office/drawing/2014/main" id="{15F22EEB-C303-C2A5-8D9D-1A69098FCD3C}"/>
+              </a:ext>
+            </a:extLst>
+          </p:cNvPr>
+          <p:cNvSpPr>
+            <a:spLocks noGrp="1" noRot="1" noChangeAspect="1"/>
+          </p:cNvSpPr>
+          <p:nvPr>
+            <p:ph type="sldImg"/>
+          </p:nvPr>
+        </p:nvSpPr>
+        <p:spPr/>
+      </p:sp>
+      <p:sp>
+        <p:nvSpPr>
+          <p:cNvPr id="3" name="Notes Placeholder 2">
+            <a:extLst>
+              <a:ext uri="{FF2B5EF4-FFF2-40B4-BE49-F238E27FC236}">
+                <a16:creationId xmlns:a16="http://schemas.microsoft.com/office/drawing/2014/main" id="{B3854394-2E02-F59C-3637-C4FD90296000}"/>
+              </a:ext>
+            </a:extLst>
+          </p:cNvPr>
+          <p:cNvSpPr>
+            <a:spLocks noGrp="1"/>
+          </p:cNvSpPr>
+          <p:nvPr>
+            <p:ph type="body" idx="1"/>
+          </p:nvPr>
+        </p:nvSpPr>
+        <p:spPr/>
+        <p:txBody>
+          <a:bodyPr/>
+          <a:lstStyle/>
+          <a:p>
+            <a:endParaRPr lang="en-GB"/>
+          </a:p>
+        </p:txBody>
+      </p:sp>
+      <p:sp>
+        <p:nvSpPr>
+          <p:cNvPr id="4" name="Slide Number Placeholder 3">
+            <a:extLst>
+              <a:ext uri="{FF2B5EF4-FFF2-40B4-BE49-F238E27FC236}">
+                <a16:creationId xmlns:a16="http://schemas.microsoft.com/office/drawing/2014/main" id="{98D901B4-4B31-A81F-86D7-37D4F9F19EA1}"/>
+              </a:ext>
+            </a:extLst>
+          </p:cNvPr>
+          <p:cNvSpPr>
+            <a:spLocks noGrp="1"/>
+          </p:cNvSpPr>
+          <p:nvPr>
+            <p:ph type="sldNum" sz="quarter" idx="5"/>
+          </p:nvPr>
+        </p:nvSpPr>
+        <p:spPr/>
+        <p:txBody>
+          <a:bodyPr/>
+          <a:lstStyle/>
+          <a:p>
+            <a:fld id="{BA1AFD66-2597-4960-86E3-D00E2B43A69D}" type="slidenum">
+              <a:rPr lang="en-GB" smtClean="0"/>
+              <a:t>2</a:t>
+            </a:fld>
+            <a:endParaRPr lang="en-GB"/>
+          </a:p>
+        </p:txBody>
+      </p:sp>
+    </p:spTree>
+    <p:extLst>
+      <p:ext uri="{BB962C8B-B14F-4D97-AF65-F5344CB8AC3E}">
+        <p14:creationId xmlns:p14="http://schemas.microsoft.com/office/powerpoint/2010/main" val="2171862513"/>
+      </p:ext>
+    </p:extLst>
+  </p:cSld>
+  <p:clrMapOvr>
+    <a:masterClrMapping/>
+  </p:clrMapOvr>
+</p:notes>
+</file>
+
+<file path=ppt/notesSlides/notesSlide3.xml><?xml version="1.0" encoding="utf-8"?>
+<p:notes xmlns:a="http://schemas.openxmlformats.org/drawingml/2006/main" xmlns:r="http://schemas.openxmlformats.org/officeDocument/2006/relationships" xmlns:p="http://schemas.openxmlformats.org/presentationml/2006/main">
+  <p:cSld>
+    <p:spTree>
+      <p:nvGrpSpPr>
+        <p:cNvPr id="1" name="">
+          <a:extLst>
+            <a:ext uri="{FF2B5EF4-FFF2-40B4-BE49-F238E27FC236}">
+              <a16:creationId xmlns:a16="http://schemas.microsoft.com/office/drawing/2014/main" id="{2215450A-C4D7-1430-C644-50F3F198E548}"/>
+            </a:ext>
+          </a:extLst>
+        </p:cNvPr>
+        <p:cNvGrpSpPr/>
+        <p:nvPr/>
+      </p:nvGrpSpPr>
+      <p:grpSpPr>
+        <a:xfrm>
+          <a:off x="0" y="0"/>
+          <a:ext cx="0" cy="0"/>
+          <a:chOff x="0" y="0"/>
+          <a:chExt cx="0" cy="0"/>
+        </a:xfrm>
+      </p:grpSpPr>
+      <p:sp>
+        <p:nvSpPr>
+          <p:cNvPr id="2" name="Slide Image Placeholder 1">
+            <a:extLst>
+              <a:ext uri="{FF2B5EF4-FFF2-40B4-BE49-F238E27FC236}">
+                <a16:creationId xmlns:a16="http://schemas.microsoft.com/office/drawing/2014/main" id="{ED792276-1454-3270-B3A5-C743FFF3DAB5}"/>
+              </a:ext>
+            </a:extLst>
+          </p:cNvPr>
+          <p:cNvSpPr>
+            <a:spLocks noGrp="1" noRot="1" noChangeAspect="1"/>
+          </p:cNvSpPr>
+          <p:nvPr>
+            <p:ph type="sldImg"/>
+          </p:nvPr>
+        </p:nvSpPr>
+        <p:spPr/>
+      </p:sp>
+      <p:sp>
+        <p:nvSpPr>
+          <p:cNvPr id="3" name="Notes Placeholder 2">
+            <a:extLst>
+              <a:ext uri="{FF2B5EF4-FFF2-40B4-BE49-F238E27FC236}">
+                <a16:creationId xmlns:a16="http://schemas.microsoft.com/office/drawing/2014/main" id="{6B3543F5-304A-1D65-0A71-730E5FE78022}"/>
+              </a:ext>
+            </a:extLst>
+          </p:cNvPr>
+          <p:cNvSpPr>
+            <a:spLocks noGrp="1"/>
+          </p:cNvSpPr>
+          <p:nvPr>
+            <p:ph type="body" idx="1"/>
+          </p:nvPr>
+        </p:nvSpPr>
+        <p:spPr/>
+        <p:txBody>
+          <a:bodyPr/>
+          <a:lstStyle/>
+          <a:p>
+            <a:endParaRPr lang="en-GB"/>
+          </a:p>
+        </p:txBody>
+      </p:sp>
+      <p:sp>
+        <p:nvSpPr>
+          <p:cNvPr id="4" name="Slide Number Placeholder 3">
+            <a:extLst>
+              <a:ext uri="{FF2B5EF4-FFF2-40B4-BE49-F238E27FC236}">
+                <a16:creationId xmlns:a16="http://schemas.microsoft.com/office/drawing/2014/main" id="{9BBB26A6-51FB-0ED0-1F61-4CA82ADDFC51}"/>
+              </a:ext>
+            </a:extLst>
+          </p:cNvPr>
+          <p:cNvSpPr>
+            <a:spLocks noGrp="1"/>
+          </p:cNvSpPr>
+          <p:nvPr>
+            <p:ph type="sldNum" sz="quarter" idx="5"/>
+          </p:nvPr>
+        </p:nvSpPr>
+        <p:spPr/>
+        <p:txBody>
+          <a:bodyPr/>
+          <a:lstStyle/>
+          <a:p>
+            <a:fld id="{BA1AFD66-2597-4960-86E3-D00E2B43A69D}" type="slidenum">
+              <a:rPr lang="en-GB" smtClean="0"/>
+              <a:t>3</a:t>
+            </a:fld>
+            <a:endParaRPr lang="en-GB"/>
+          </a:p>
+        </p:txBody>
+      </p:sp>
+    </p:spTree>
+    <p:extLst>
+      <p:ext uri="{BB962C8B-B14F-4D97-AF65-F5344CB8AC3E}">
+        <p14:creationId xmlns:p14="http://schemas.microsoft.com/office/powerpoint/2010/main" val="2057813625"/>
       </p:ext>
     </p:extLst>
   </p:cSld>
@@ -4402,10 +4620,10 @@
       </p:sp>
       <p:grpSp>
         <p:nvGrpSpPr>
-          <p:cNvPr id="2" name="Groep 1">
-            <a:extLst>
-              <a:ext uri="{FF2B5EF4-FFF2-40B4-BE49-F238E27FC236}">
-                <a16:creationId xmlns:a16="http://schemas.microsoft.com/office/drawing/2014/main" id="{1D45816F-C7A2-85B7-42BA-A22F5841366E}"/>
+          <p:cNvPr id="16" name="Groep 15">
+            <a:extLst>
+              <a:ext uri="{FF2B5EF4-FFF2-40B4-BE49-F238E27FC236}">
+                <a16:creationId xmlns:a16="http://schemas.microsoft.com/office/drawing/2014/main" id="{7C86CE1E-3BCE-3EB1-F051-207618DE23E4}"/>
               </a:ext>
             </a:extLst>
           </p:cNvPr>
@@ -4414,131 +4632,1316 @@
         </p:nvGrpSpPr>
         <p:grpSpPr>
           <a:xfrm>
-            <a:off x="1869888" y="1137706"/>
-            <a:ext cx="7037527" cy="569848"/>
+            <a:off x="1869888" y="1788635"/>
+            <a:ext cx="7039850" cy="3658850"/>
             <a:chOff x="1869888" y="1137706"/>
-            <a:chExt cx="7037527" cy="569848"/>
+            <a:chExt cx="7039850" cy="3658850"/>
           </a:xfrm>
         </p:grpSpPr>
-        <p:sp>
-          <p:nvSpPr>
-            <p:cNvPr id="17" name="Rectangle 16">
+        <p:grpSp>
+          <p:nvGrpSpPr>
+            <p:cNvPr id="2" name="Groep 1">
               <a:extLst>
                 <a:ext uri="{FF2B5EF4-FFF2-40B4-BE49-F238E27FC236}">
-                  <a16:creationId xmlns:a16="http://schemas.microsoft.com/office/drawing/2014/main" id="{4DC9BA65-02F5-9778-D996-0E43F5050B58}"/>
+                  <a16:creationId xmlns:a16="http://schemas.microsoft.com/office/drawing/2014/main" id="{1D45816F-C7A2-85B7-42BA-A22F5841366E}"/>
                 </a:ext>
               </a:extLst>
             </p:cNvPr>
-            <p:cNvSpPr/>
+            <p:cNvGrpSpPr/>
             <p:nvPr/>
-          </p:nvSpPr>
-          <p:spPr>
+          </p:nvGrpSpPr>
+          <p:grpSpPr>
             <a:xfrm>
               <a:off x="1869888" y="1137706"/>
               <a:ext cx="7037527" cy="569848"/>
+              <a:chOff x="1869888" y="1137706"/>
+              <a:chExt cx="7037527" cy="569848"/>
             </a:xfrm>
-            <a:prstGeom prst="rect">
-              <a:avLst/>
-            </a:prstGeom>
-            <a:solidFill>
-              <a:schemeClr val="accent1">
-                <a:lumMod val="20000"/>
-                <a:lumOff val="80000"/>
-              </a:schemeClr>
-            </a:solidFill>
-            <a:ln>
+          </p:grpSpPr>
+          <p:sp>
+            <p:nvSpPr>
+              <p:cNvPr id="17" name="Rectangle 16">
+                <a:extLst>
+                  <a:ext uri="{FF2B5EF4-FFF2-40B4-BE49-F238E27FC236}">
+                    <a16:creationId xmlns:a16="http://schemas.microsoft.com/office/drawing/2014/main" id="{4DC9BA65-02F5-9778-D996-0E43F5050B58}"/>
+                  </a:ext>
+                </a:extLst>
+              </p:cNvPr>
+              <p:cNvSpPr/>
+              <p:nvPr/>
+            </p:nvSpPr>
+            <p:spPr>
+              <a:xfrm>
+                <a:off x="1869888" y="1137706"/>
+                <a:ext cx="7037527" cy="569848"/>
+              </a:xfrm>
+              <a:prstGeom prst="rect">
+                <a:avLst/>
+              </a:prstGeom>
+              <a:solidFill>
+                <a:schemeClr val="accent1">
+                  <a:lumMod val="20000"/>
+                  <a:lumOff val="80000"/>
+                </a:schemeClr>
+              </a:solidFill>
+              <a:ln>
+                <a:noFill/>
+              </a:ln>
+            </p:spPr>
+            <p:style>
+              <a:lnRef idx="2">
+                <a:schemeClr val="accent1">
+                  <a:shade val="15000"/>
+                </a:schemeClr>
+              </a:lnRef>
+              <a:fillRef idx="1">
+                <a:schemeClr val="accent1"/>
+              </a:fillRef>
+              <a:effectRef idx="0">
+                <a:schemeClr val="accent1"/>
+              </a:effectRef>
+              <a:fontRef idx="minor">
+                <a:schemeClr val="lt1"/>
+              </a:fontRef>
+            </p:style>
+            <p:txBody>
+              <a:bodyPr rtlCol="0" anchor="ctr"/>
+              <a:lstStyle/>
+              <a:p>
+                <a:pPr algn="ctr"/>
+                <a:endParaRPr lang="LID4096"/>
+              </a:p>
+            </p:txBody>
+          </p:sp>
+          <p:sp>
+            <p:nvSpPr>
+              <p:cNvPr id="20" name="TextBox 19">
+                <a:extLst>
+                  <a:ext uri="{FF2B5EF4-FFF2-40B4-BE49-F238E27FC236}">
+                    <a16:creationId xmlns:a16="http://schemas.microsoft.com/office/drawing/2014/main" id="{1C285D34-3103-3FC5-CA90-096D3DDE0E6B}"/>
+                  </a:ext>
+                </a:extLst>
+              </p:cNvPr>
+              <p:cNvSpPr txBox="1"/>
+              <p:nvPr/>
+            </p:nvSpPr>
+            <p:spPr>
+              <a:xfrm>
+                <a:off x="2010738" y="1207612"/>
+                <a:ext cx="3560350" cy="369332"/>
+              </a:xfrm>
+              <a:prstGeom prst="rect">
+                <a:avLst/>
+              </a:prstGeom>
               <a:noFill/>
-            </a:ln>
-          </p:spPr>
-          <p:style>
-            <a:lnRef idx="2">
-              <a:schemeClr val="accent1">
-                <a:shade val="15000"/>
-              </a:schemeClr>
-            </a:lnRef>
-            <a:fillRef idx="1">
-              <a:schemeClr val="accent1"/>
-            </a:fillRef>
-            <a:effectRef idx="0">
-              <a:schemeClr val="accent1"/>
-            </a:effectRef>
-            <a:fontRef idx="minor">
-              <a:schemeClr val="lt1"/>
-            </a:fontRef>
-          </p:style>
-          <p:txBody>
-            <a:bodyPr rtlCol="0" anchor="ctr"/>
-            <a:lstStyle/>
-            <a:p>
-              <a:pPr algn="ctr"/>
-              <a:endParaRPr lang="LID4096"/>
-            </a:p>
-          </p:txBody>
-        </p:sp>
-        <p:sp>
-          <p:nvSpPr>
-            <p:cNvPr id="20" name="TextBox 19">
+            </p:spPr>
+            <p:txBody>
+              <a:bodyPr wrap="square" lIns="0" tIns="0" rIns="0" bIns="0" rtlCol="0">
+                <a:spAutoFit/>
+              </a:bodyPr>
+              <a:lstStyle/>
+              <a:p>
+                <a:pPr>
+                  <a:buSzPct val="100000"/>
+                </a:pPr>
+                <a:r>
+                  <a:rPr lang="en-US" sz="1200" b="1" dirty="0">
+                    <a:latin typeface="DM Sans" pitchFamily="2" charset="0"/>
+                  </a:rPr>
+                  <a:t>Vision</a:t>
+                </a:r>
+              </a:p>
+              <a:p>
+                <a:pPr>
+                  <a:buSzPct val="100000"/>
+                </a:pPr>
+                <a:r>
+                  <a:rPr lang="en-US" sz="1200" dirty="0">
+                    <a:solidFill>
+                      <a:schemeClr val="tx1">
+                        <a:lumMod val="75000"/>
+                        <a:lumOff val="25000"/>
+                      </a:schemeClr>
+                    </a:solidFill>
+                    <a:latin typeface="+mj-lt"/>
+                  </a:rPr>
+                  <a:t>Vision</a:t>
+                </a:r>
+                <a:r>
+                  <a:rPr lang="en-US" sz="1200" b="1" dirty="0">
+                    <a:solidFill>
+                      <a:schemeClr val="tx1">
+                        <a:lumMod val="75000"/>
+                        <a:lumOff val="25000"/>
+                      </a:schemeClr>
+                    </a:solidFill>
+                    <a:latin typeface="+mj-lt"/>
+                  </a:rPr>
+                  <a:t>, </a:t>
+                </a:r>
+                <a:r>
+                  <a:rPr lang="en-US" sz="1200" dirty="0">
+                    <a:solidFill>
+                      <a:schemeClr val="tx1">
+                        <a:lumMod val="75000"/>
+                        <a:lumOff val="25000"/>
+                      </a:schemeClr>
+                    </a:solidFill>
+                    <a:latin typeface="+mj-lt"/>
+                  </a:rPr>
+                  <a:t>strategy, values, objectives</a:t>
+                </a:r>
+              </a:p>
+            </p:txBody>
+          </p:sp>
+        </p:grpSp>
+        <p:grpSp>
+          <p:nvGrpSpPr>
+            <p:cNvPr id="9" name="Groep 8">
               <a:extLst>
                 <a:ext uri="{FF2B5EF4-FFF2-40B4-BE49-F238E27FC236}">
-                  <a16:creationId xmlns:a16="http://schemas.microsoft.com/office/drawing/2014/main" id="{1C285D34-3103-3FC5-CA90-096D3DDE0E6B}"/>
+                  <a16:creationId xmlns:a16="http://schemas.microsoft.com/office/drawing/2014/main" id="{ED531BDA-D9E1-B250-6381-7DFF6243F863}"/>
                 </a:ext>
               </a:extLst>
             </p:cNvPr>
-            <p:cNvSpPr txBox="1"/>
+            <p:cNvGrpSpPr/>
             <p:nvPr/>
-          </p:nvSpPr>
-          <p:spPr>
+          </p:nvGrpSpPr>
+          <p:grpSpPr>
             <a:xfrm>
-              <a:off x="2010738" y="1207612"/>
-              <a:ext cx="3560350" cy="369332"/>
+              <a:off x="1875658" y="3887682"/>
+              <a:ext cx="7034080" cy="908874"/>
+              <a:chOff x="1875658" y="2895090"/>
+              <a:chExt cx="7034080" cy="908874"/>
             </a:xfrm>
-            <a:prstGeom prst="rect">
-              <a:avLst/>
-            </a:prstGeom>
-            <a:noFill/>
-          </p:spPr>
-          <p:txBody>
-            <a:bodyPr wrap="square" lIns="0" tIns="0" rIns="0" bIns="0" rtlCol="0">
-              <a:spAutoFit/>
-            </a:bodyPr>
-            <a:lstStyle/>
-            <a:p>
-              <a:pPr>
-                <a:buSzPct val="100000"/>
-              </a:pPr>
-              <a:r>
-                <a:rPr lang="en-US" sz="1200" b="1" dirty="0">
+          </p:grpSpPr>
+          <p:grpSp>
+            <p:nvGrpSpPr>
+              <p:cNvPr id="6" name="Groep 5">
+                <a:extLst>
+                  <a:ext uri="{FF2B5EF4-FFF2-40B4-BE49-F238E27FC236}">
+                    <a16:creationId xmlns:a16="http://schemas.microsoft.com/office/drawing/2014/main" id="{2A1038EE-D6B3-1076-10A0-7EDB04F89669}"/>
+                  </a:ext>
+                </a:extLst>
+              </p:cNvPr>
+              <p:cNvGrpSpPr/>
+              <p:nvPr/>
+            </p:nvGrpSpPr>
+            <p:grpSpPr>
+              <a:xfrm>
+                <a:off x="1875658" y="2895090"/>
+                <a:ext cx="7034080" cy="908874"/>
+                <a:chOff x="1875658" y="2895090"/>
+                <a:chExt cx="7034080" cy="908874"/>
+              </a:xfrm>
+            </p:grpSpPr>
+            <p:sp>
+              <p:nvSpPr>
+                <p:cNvPr id="151" name="Rectangle 150">
+                  <a:extLst>
+                    <a:ext uri="{FF2B5EF4-FFF2-40B4-BE49-F238E27FC236}">
+                      <a16:creationId xmlns:a16="http://schemas.microsoft.com/office/drawing/2014/main" id="{DA84A920-84E4-D38E-DFB7-5C496D13FC0A}"/>
+                    </a:ext>
+                  </a:extLst>
+                </p:cNvPr>
+                <p:cNvSpPr/>
+                <p:nvPr/>
+              </p:nvSpPr>
+              <p:spPr>
+                <a:xfrm>
+                  <a:off x="1875658" y="2895090"/>
+                  <a:ext cx="2279565" cy="908874"/>
+                </a:xfrm>
+                <a:prstGeom prst="rect">
+                  <a:avLst/>
+                </a:prstGeom>
+                <a:solidFill>
+                  <a:schemeClr val="accent1">
+                    <a:lumMod val="20000"/>
+                    <a:lumOff val="80000"/>
+                  </a:schemeClr>
+                </a:solidFill>
+                <a:ln>
+                  <a:noFill/>
+                </a:ln>
+              </p:spPr>
+              <p:style>
+                <a:lnRef idx="2">
+                  <a:schemeClr val="accent1">
+                    <a:shade val="15000"/>
+                  </a:schemeClr>
+                </a:lnRef>
+                <a:fillRef idx="1">
+                  <a:schemeClr val="accent1"/>
+                </a:fillRef>
+                <a:effectRef idx="0">
+                  <a:schemeClr val="accent1"/>
+                </a:effectRef>
+                <a:fontRef idx="minor">
+                  <a:schemeClr val="lt1"/>
+                </a:fontRef>
+              </p:style>
+              <p:txBody>
+                <a:bodyPr rtlCol="0" anchor="ctr"/>
+                <a:lstStyle/>
+                <a:p>
+                  <a:pPr algn="ctr"/>
+                  <a:endParaRPr lang="LID4096"/>
+                </a:p>
+              </p:txBody>
+            </p:sp>
+            <p:sp>
+              <p:nvSpPr>
+                <p:cNvPr id="154" name="Rectangle 153">
+                  <a:extLst>
+                    <a:ext uri="{FF2B5EF4-FFF2-40B4-BE49-F238E27FC236}">
+                      <a16:creationId xmlns:a16="http://schemas.microsoft.com/office/drawing/2014/main" id="{55D2C2E2-60C1-A4D8-155A-29C4AE9102DC}"/>
+                    </a:ext>
+                  </a:extLst>
+                </p:cNvPr>
+                <p:cNvSpPr/>
+                <p:nvPr/>
+              </p:nvSpPr>
+              <p:spPr>
+                <a:xfrm>
+                  <a:off x="4252915" y="2895090"/>
+                  <a:ext cx="2279565" cy="908874"/>
+                </a:xfrm>
+                <a:prstGeom prst="rect">
+                  <a:avLst/>
+                </a:prstGeom>
+                <a:solidFill>
+                  <a:schemeClr val="accent1">
+                    <a:lumMod val="20000"/>
+                    <a:lumOff val="80000"/>
+                  </a:schemeClr>
+                </a:solidFill>
+                <a:ln>
+                  <a:noFill/>
+                </a:ln>
+              </p:spPr>
+              <p:style>
+                <a:lnRef idx="2">
+                  <a:schemeClr val="accent1">
+                    <a:shade val="15000"/>
+                  </a:schemeClr>
+                </a:lnRef>
+                <a:fillRef idx="1">
+                  <a:schemeClr val="accent1"/>
+                </a:fillRef>
+                <a:effectRef idx="0">
+                  <a:schemeClr val="accent1"/>
+                </a:effectRef>
+                <a:fontRef idx="minor">
+                  <a:schemeClr val="lt1"/>
+                </a:fontRef>
+              </p:style>
+              <p:txBody>
+                <a:bodyPr rtlCol="0" anchor="ctr"/>
+                <a:lstStyle/>
+                <a:p>
+                  <a:pPr algn="ctr"/>
+                  <a:endParaRPr lang="LID4096"/>
+                </a:p>
+              </p:txBody>
+            </p:sp>
+            <p:sp>
+              <p:nvSpPr>
+                <p:cNvPr id="156" name="Rectangle 155">
+                  <a:extLst>
+                    <a:ext uri="{FF2B5EF4-FFF2-40B4-BE49-F238E27FC236}">
+                      <a16:creationId xmlns:a16="http://schemas.microsoft.com/office/drawing/2014/main" id="{DD197C6D-A1CA-B22B-ECAC-F110C43F9350}"/>
+                    </a:ext>
+                  </a:extLst>
+                </p:cNvPr>
+                <p:cNvSpPr/>
+                <p:nvPr/>
+              </p:nvSpPr>
+              <p:spPr>
+                <a:xfrm>
+                  <a:off x="6630173" y="2895090"/>
+                  <a:ext cx="2279565" cy="908874"/>
+                </a:xfrm>
+                <a:prstGeom prst="rect">
+                  <a:avLst/>
+                </a:prstGeom>
+                <a:solidFill>
+                  <a:schemeClr val="accent1">
+                    <a:lumMod val="20000"/>
+                    <a:lumOff val="80000"/>
+                  </a:schemeClr>
+                </a:solidFill>
+                <a:ln>
+                  <a:noFill/>
+                </a:ln>
+              </p:spPr>
+              <p:style>
+                <a:lnRef idx="2">
+                  <a:schemeClr val="accent1">
+                    <a:shade val="15000"/>
+                  </a:schemeClr>
+                </a:lnRef>
+                <a:fillRef idx="1">
+                  <a:schemeClr val="accent1"/>
+                </a:fillRef>
+                <a:effectRef idx="0">
+                  <a:schemeClr val="accent1"/>
+                </a:effectRef>
+                <a:fontRef idx="minor">
+                  <a:schemeClr val="lt1"/>
+                </a:fontRef>
+              </p:style>
+              <p:txBody>
+                <a:bodyPr rtlCol="0" anchor="ctr"/>
+                <a:lstStyle/>
+                <a:p>
+                  <a:pPr algn="ctr"/>
+                  <a:endParaRPr lang="LID4096"/>
+                </a:p>
+              </p:txBody>
+            </p:sp>
+          </p:grpSp>
+          <p:sp>
+            <p:nvSpPr>
+              <p:cNvPr id="152" name="TextBox 151">
+                <a:extLst>
+                  <a:ext uri="{FF2B5EF4-FFF2-40B4-BE49-F238E27FC236}">
+                    <a16:creationId xmlns:a16="http://schemas.microsoft.com/office/drawing/2014/main" id="{30FBF885-B703-4E76-E0CE-D11230D74F72}"/>
+                  </a:ext>
+                </a:extLst>
+              </p:cNvPr>
+              <p:cNvSpPr txBox="1"/>
+              <p:nvPr/>
+            </p:nvSpPr>
+            <p:spPr>
+              <a:xfrm>
+                <a:off x="2010737" y="2961596"/>
+                <a:ext cx="2239199" cy="553998"/>
+              </a:xfrm>
+              <a:prstGeom prst="rect">
+                <a:avLst/>
+              </a:prstGeom>
+              <a:noFill/>
+            </p:spPr>
+            <p:txBody>
+              <a:bodyPr wrap="square" lIns="0" tIns="0" rIns="0" bIns="0" rtlCol="0">
+                <a:spAutoFit/>
+              </a:bodyPr>
+              <a:lstStyle/>
+              <a:p>
+                <a:pPr>
+                  <a:buSzPct val="100000"/>
+                </a:pPr>
+                <a:r>
+                  <a:rPr lang="en-US" sz="1200" b="1" dirty="0">
+                    <a:latin typeface="DM Sans" pitchFamily="2" charset="0"/>
+                  </a:rPr>
+                  <a:t>Data</a:t>
+                </a:r>
+              </a:p>
+              <a:p>
+                <a:pPr>
+                  <a:buSzPct val="100000"/>
+                </a:pPr>
+                <a:r>
+                  <a:rPr lang="en-US" sz="1200" dirty="0">
+                    <a:solidFill>
+                      <a:schemeClr val="tx1">
+                        <a:lumMod val="75000"/>
+                        <a:lumOff val="25000"/>
+                      </a:schemeClr>
+                    </a:solidFill>
+                    <a:latin typeface="+mj-lt"/>
+                  </a:rPr>
+                  <a:t>Reusable data products, analytics, architecture, monetization</a:t>
+                </a:r>
+              </a:p>
+            </p:txBody>
+          </p:sp>
+          <p:sp>
+            <p:nvSpPr>
+              <p:cNvPr id="155" name="TextBox 154">
+                <a:extLst>
+                  <a:ext uri="{FF2B5EF4-FFF2-40B4-BE49-F238E27FC236}">
+                    <a16:creationId xmlns:a16="http://schemas.microsoft.com/office/drawing/2014/main" id="{2F26F3B8-CA9A-3660-D416-56970DACBC05}"/>
+                  </a:ext>
+                </a:extLst>
+              </p:cNvPr>
+              <p:cNvSpPr txBox="1"/>
+              <p:nvPr/>
+            </p:nvSpPr>
+            <p:spPr>
+              <a:xfrm>
+                <a:off x="4391989" y="2961596"/>
+                <a:ext cx="1878739" cy="553998"/>
+              </a:xfrm>
+              <a:prstGeom prst="rect">
+                <a:avLst/>
+              </a:prstGeom>
+              <a:noFill/>
+            </p:spPr>
+            <p:txBody>
+              <a:bodyPr wrap="square" lIns="0" tIns="0" rIns="0" bIns="0" rtlCol="0">
+                <a:spAutoFit/>
+              </a:bodyPr>
+              <a:lstStyle/>
+              <a:p>
+                <a:pPr>
+                  <a:buSzPct val="100000"/>
+                </a:pPr>
+                <a:r>
+                  <a:rPr lang="en-US" sz="1200" b="1" dirty="0">
+                    <a:latin typeface="DM Sans" pitchFamily="2" charset="0"/>
+                  </a:rPr>
+                  <a:t>Technology</a:t>
+                </a:r>
+              </a:p>
+              <a:p>
+                <a:pPr>
+                  <a:buSzPct val="100000"/>
+                </a:pPr>
+                <a:r>
+                  <a:rPr lang="en-US" sz="1200" dirty="0">
+                    <a:solidFill>
+                      <a:schemeClr val="tx1">
+                        <a:lumMod val="75000"/>
+                        <a:lumOff val="25000"/>
+                      </a:schemeClr>
+                    </a:solidFill>
+                    <a:latin typeface="+mj-lt"/>
+                  </a:rPr>
+                  <a:t>Target architecture, platforms &amp; solutions, integration </a:t>
+                </a:r>
+              </a:p>
+            </p:txBody>
+          </p:sp>
+          <p:sp>
+            <p:nvSpPr>
+              <p:cNvPr id="157" name="TextBox 156">
+                <a:extLst>
+                  <a:ext uri="{FF2B5EF4-FFF2-40B4-BE49-F238E27FC236}">
+                    <a16:creationId xmlns:a16="http://schemas.microsoft.com/office/drawing/2014/main" id="{3AA9ACAD-2309-6695-05C5-A00E27FC3BF5}"/>
+                  </a:ext>
+                </a:extLst>
+              </p:cNvPr>
+              <p:cNvSpPr txBox="1"/>
+              <p:nvPr/>
+            </p:nvSpPr>
+            <p:spPr>
+              <a:xfrm>
+                <a:off x="6763057" y="2961596"/>
+                <a:ext cx="1884734" cy="738664"/>
+              </a:xfrm>
+              <a:prstGeom prst="rect">
+                <a:avLst/>
+              </a:prstGeom>
+              <a:noFill/>
+            </p:spPr>
+            <p:txBody>
+              <a:bodyPr wrap="square" lIns="0" tIns="0" rIns="0" bIns="0" rtlCol="0">
+                <a:spAutoFit/>
+              </a:bodyPr>
+              <a:lstStyle/>
+              <a:p>
+                <a:pPr>
+                  <a:buSzPct val="100000"/>
+                </a:pPr>
+                <a:r>
+                  <a:rPr lang="en-US" sz="1200" b="1" dirty="0">
+                    <a:latin typeface="DM Sans" pitchFamily="2" charset="0"/>
+                  </a:rPr>
+                  <a:t>Enablement</a:t>
+                </a:r>
+              </a:p>
+              <a:p>
+                <a:pPr>
+                  <a:buSzPct val="100000"/>
+                </a:pPr>
+                <a:r>
+                  <a:rPr lang="en-US" sz="1200" dirty="0">
+                    <a:solidFill>
+                      <a:schemeClr val="tx1">
+                        <a:lumMod val="75000"/>
+                        <a:lumOff val="25000"/>
+                      </a:schemeClr>
+                    </a:solidFill>
+                    <a:latin typeface="+mj-lt"/>
+                  </a:rPr>
+                  <a:t>Culture, AI &amp; engineering toolbox, automation, agents, skills</a:t>
+                </a:r>
+              </a:p>
+            </p:txBody>
+          </p:sp>
+        </p:grpSp>
+        <p:grpSp>
+          <p:nvGrpSpPr>
+            <p:cNvPr id="11" name="Groep 10">
+              <a:extLst>
+                <a:ext uri="{FF2B5EF4-FFF2-40B4-BE49-F238E27FC236}">
+                  <a16:creationId xmlns:a16="http://schemas.microsoft.com/office/drawing/2014/main" id="{B7CF1138-4C4E-266E-D6C0-860E7EEBF20D}"/>
+                </a:ext>
+              </a:extLst>
+            </p:cNvPr>
+            <p:cNvGrpSpPr/>
+            <p:nvPr/>
+          </p:nvGrpSpPr>
+          <p:grpSpPr>
+            <a:xfrm>
+              <a:off x="1875658" y="2896545"/>
+              <a:ext cx="7031757" cy="908874"/>
+              <a:chOff x="1875658" y="3934756"/>
+              <a:chExt cx="7031757" cy="908874"/>
+            </a:xfrm>
+          </p:grpSpPr>
+          <p:grpSp>
+            <p:nvGrpSpPr>
+              <p:cNvPr id="7" name="Groep 6">
+                <a:extLst>
+                  <a:ext uri="{FF2B5EF4-FFF2-40B4-BE49-F238E27FC236}">
+                    <a16:creationId xmlns:a16="http://schemas.microsoft.com/office/drawing/2014/main" id="{FA87857C-EE64-83B6-1558-C834EDD82F05}"/>
+                  </a:ext>
+                </a:extLst>
+              </p:cNvPr>
+              <p:cNvGrpSpPr/>
+              <p:nvPr/>
+            </p:nvGrpSpPr>
+            <p:grpSpPr>
+              <a:xfrm>
+                <a:off x="1875658" y="3934756"/>
+                <a:ext cx="7031757" cy="908874"/>
+                <a:chOff x="1875658" y="3934756"/>
+                <a:chExt cx="7031757" cy="908874"/>
+              </a:xfrm>
+            </p:grpSpPr>
+            <p:sp>
+              <p:nvSpPr>
+                <p:cNvPr id="162" name="Rectangle 161">
+                  <a:extLst>
+                    <a:ext uri="{FF2B5EF4-FFF2-40B4-BE49-F238E27FC236}">
+                      <a16:creationId xmlns:a16="http://schemas.microsoft.com/office/drawing/2014/main" id="{72576AB9-B02D-3B55-BF90-C23F1A867704}"/>
+                    </a:ext>
+                  </a:extLst>
+                </p:cNvPr>
+                <p:cNvSpPr/>
+                <p:nvPr/>
+              </p:nvSpPr>
+              <p:spPr>
+                <a:xfrm>
+                  <a:off x="1875658" y="3934756"/>
+                  <a:ext cx="3466168" cy="908874"/>
+                </a:xfrm>
+                <a:prstGeom prst="rect">
+                  <a:avLst/>
+                </a:prstGeom>
+                <a:solidFill>
+                  <a:schemeClr val="accent1">
+                    <a:lumMod val="20000"/>
+                    <a:lumOff val="80000"/>
+                  </a:schemeClr>
+                </a:solidFill>
+                <a:ln>
+                  <a:noFill/>
+                </a:ln>
+              </p:spPr>
+              <p:style>
+                <a:lnRef idx="2">
+                  <a:schemeClr val="accent1">
+                    <a:shade val="15000"/>
+                  </a:schemeClr>
+                </a:lnRef>
+                <a:fillRef idx="1">
+                  <a:schemeClr val="accent1"/>
+                </a:fillRef>
+                <a:effectRef idx="0">
+                  <a:schemeClr val="accent1"/>
+                </a:effectRef>
+                <a:fontRef idx="minor">
+                  <a:schemeClr val="lt1"/>
+                </a:fontRef>
+              </p:style>
+              <p:txBody>
+                <a:bodyPr rtlCol="0" anchor="ctr"/>
+                <a:lstStyle/>
+                <a:p>
+                  <a:pPr algn="ctr"/>
+                  <a:endParaRPr lang="LID4096"/>
+                </a:p>
+              </p:txBody>
+            </p:sp>
+            <p:sp>
+              <p:nvSpPr>
+                <p:cNvPr id="165" name="Rectangle 164">
+                  <a:extLst>
+                    <a:ext uri="{FF2B5EF4-FFF2-40B4-BE49-F238E27FC236}">
+                      <a16:creationId xmlns:a16="http://schemas.microsoft.com/office/drawing/2014/main" id="{C8B0295D-55E0-BE71-18DC-D49D90CE7050}"/>
+                    </a:ext>
+                  </a:extLst>
+                </p:cNvPr>
+                <p:cNvSpPr/>
+                <p:nvPr/>
+              </p:nvSpPr>
+              <p:spPr>
+                <a:xfrm>
+                  <a:off x="5441247" y="3934756"/>
+                  <a:ext cx="3466168" cy="908874"/>
+                </a:xfrm>
+                <a:prstGeom prst="rect">
+                  <a:avLst/>
+                </a:prstGeom>
+                <a:solidFill>
+                  <a:schemeClr val="accent1">
+                    <a:lumMod val="20000"/>
+                    <a:lumOff val="80000"/>
+                  </a:schemeClr>
+                </a:solidFill>
+                <a:ln>
+                  <a:noFill/>
+                </a:ln>
+              </p:spPr>
+              <p:style>
+                <a:lnRef idx="2">
+                  <a:schemeClr val="accent1">
+                    <a:shade val="15000"/>
+                  </a:schemeClr>
+                </a:lnRef>
+                <a:fillRef idx="1">
+                  <a:schemeClr val="accent1"/>
+                </a:fillRef>
+                <a:effectRef idx="0">
+                  <a:schemeClr val="accent1"/>
+                </a:effectRef>
+                <a:fontRef idx="minor">
+                  <a:schemeClr val="lt1"/>
+                </a:fontRef>
+              </p:style>
+              <p:txBody>
+                <a:bodyPr rtlCol="0" anchor="ctr"/>
+                <a:lstStyle/>
+                <a:p>
+                  <a:pPr algn="ctr"/>
+                  <a:endParaRPr lang="LID4096"/>
+                </a:p>
+              </p:txBody>
+            </p:sp>
+          </p:grpSp>
+          <p:sp>
+            <p:nvSpPr>
+              <p:cNvPr id="163" name="TextBox 162">
+                <a:extLst>
+                  <a:ext uri="{FF2B5EF4-FFF2-40B4-BE49-F238E27FC236}">
+                    <a16:creationId xmlns:a16="http://schemas.microsoft.com/office/drawing/2014/main" id="{5062C2DE-E635-12D3-2B1A-52C3839E99E0}"/>
+                  </a:ext>
+                </a:extLst>
+              </p:cNvPr>
+              <p:cNvSpPr txBox="1"/>
+              <p:nvPr/>
+            </p:nvSpPr>
+            <p:spPr>
+              <a:xfrm>
+                <a:off x="2010739" y="4001262"/>
+                <a:ext cx="2827304" cy="553998"/>
+              </a:xfrm>
+              <a:prstGeom prst="rect">
+                <a:avLst/>
+              </a:prstGeom>
+              <a:noFill/>
+            </p:spPr>
+            <p:txBody>
+              <a:bodyPr wrap="square" lIns="0" tIns="0" rIns="0" bIns="0" rtlCol="0">
+                <a:spAutoFit/>
+              </a:bodyPr>
+              <a:lstStyle/>
+              <a:p>
+                <a:pPr>
+                  <a:buSzPct val="100000"/>
+                </a:pPr>
+                <a:r>
+                  <a:rPr lang="en-US" sz="1200" b="1" dirty="0">
+                    <a:latin typeface="DM Sans" pitchFamily="2" charset="0"/>
+                  </a:rPr>
+                  <a:t>People</a:t>
+                </a:r>
+              </a:p>
+              <a:p>
+                <a:pPr>
+                  <a:buSzPct val="100000"/>
+                </a:pPr>
+                <a:r>
+                  <a:rPr lang="en-US" sz="1200" dirty="0">
+                    <a:solidFill>
+                      <a:schemeClr val="tx1">
+                        <a:lumMod val="75000"/>
+                        <a:lumOff val="25000"/>
+                      </a:schemeClr>
+                    </a:solidFill>
+                    <a:latin typeface="+mj-lt"/>
+                  </a:rPr>
+                  <a:t>Roles, target skills &amp; gaps, org sizing, talent journey, training, team incentives</a:t>
+                </a:r>
+              </a:p>
+            </p:txBody>
+          </p:sp>
+          <p:sp>
+            <p:nvSpPr>
+              <p:cNvPr id="166" name="TextBox 165">
+                <a:extLst>
+                  <a:ext uri="{FF2B5EF4-FFF2-40B4-BE49-F238E27FC236}">
+                    <a16:creationId xmlns:a16="http://schemas.microsoft.com/office/drawing/2014/main" id="{3C502B40-5DAD-8077-0D3C-B23D768C371B}"/>
+                  </a:ext>
+                </a:extLst>
+              </p:cNvPr>
+              <p:cNvSpPr txBox="1"/>
+              <p:nvPr/>
+            </p:nvSpPr>
+            <p:spPr>
+              <a:xfrm>
+                <a:off x="5571088" y="4001262"/>
+                <a:ext cx="2341828" cy="553998"/>
+              </a:xfrm>
+              <a:prstGeom prst="rect">
+                <a:avLst/>
+              </a:prstGeom>
+              <a:noFill/>
+            </p:spPr>
+            <p:txBody>
+              <a:bodyPr wrap="square" lIns="0" tIns="0" rIns="0" bIns="0" rtlCol="0">
+                <a:spAutoFit/>
+              </a:bodyPr>
+              <a:lstStyle/>
+              <a:p>
+                <a:pPr>
+                  <a:buSzPct val="100000"/>
+                </a:pPr>
+                <a:r>
+                  <a:rPr lang="en-US" sz="1200" b="1" dirty="0">
+                    <a:latin typeface="DM Sans" pitchFamily="2" charset="0"/>
+                  </a:rPr>
+                  <a:t>Process</a:t>
+                </a:r>
+              </a:p>
+              <a:p>
+                <a:pPr>
+                  <a:buSzPct val="100000"/>
+                </a:pPr>
+                <a:r>
+                  <a:rPr lang="en-US" sz="1200" dirty="0">
+                    <a:solidFill>
+                      <a:schemeClr val="tx1">
+                        <a:lumMod val="75000"/>
+                        <a:lumOff val="25000"/>
+                      </a:schemeClr>
+                    </a:solidFill>
+                    <a:latin typeface="+mj-lt"/>
+                  </a:rPr>
+                  <a:t>Org. design, cross-functional teams, product way-of-working</a:t>
+                </a:r>
+              </a:p>
+            </p:txBody>
+          </p:sp>
+        </p:grpSp>
+        <p:grpSp>
+          <p:nvGrpSpPr>
+            <p:cNvPr id="5" name="Groep 4">
+              <a:extLst>
+                <a:ext uri="{FF2B5EF4-FFF2-40B4-BE49-F238E27FC236}">
+                  <a16:creationId xmlns:a16="http://schemas.microsoft.com/office/drawing/2014/main" id="{494DD1AA-4D45-71F0-9314-8C1607F0A66C}"/>
+                </a:ext>
+              </a:extLst>
+            </p:cNvPr>
+            <p:cNvGrpSpPr/>
+            <p:nvPr/>
+          </p:nvGrpSpPr>
+          <p:grpSpPr>
+            <a:xfrm>
+              <a:off x="1875657" y="1845667"/>
+              <a:ext cx="7031758" cy="908874"/>
+              <a:chOff x="1875657" y="1856048"/>
+              <a:chExt cx="7031758" cy="908874"/>
+            </a:xfrm>
+          </p:grpSpPr>
+          <p:sp>
+            <p:nvSpPr>
+              <p:cNvPr id="140" name="Rectangle 139">
+                <a:extLst>
+                  <a:ext uri="{FF2B5EF4-FFF2-40B4-BE49-F238E27FC236}">
+                    <a16:creationId xmlns:a16="http://schemas.microsoft.com/office/drawing/2014/main" id="{803139DD-F140-2E13-C535-DBA32BD2249E}"/>
+                  </a:ext>
+                </a:extLst>
+              </p:cNvPr>
+              <p:cNvSpPr/>
+              <p:nvPr/>
+            </p:nvSpPr>
+            <p:spPr>
+              <a:xfrm>
+                <a:off x="1875657" y="1856048"/>
+                <a:ext cx="7031758" cy="908874"/>
+              </a:xfrm>
+              <a:prstGeom prst="rect">
+                <a:avLst/>
+              </a:prstGeom>
+              <a:solidFill>
+                <a:schemeClr val="accent1">
+                  <a:lumMod val="20000"/>
+                  <a:lumOff val="80000"/>
+                </a:schemeClr>
+              </a:solidFill>
+              <a:ln>
+                <a:noFill/>
+              </a:ln>
+            </p:spPr>
+            <p:style>
+              <a:lnRef idx="2">
+                <a:schemeClr val="accent1">
+                  <a:shade val="15000"/>
+                </a:schemeClr>
+              </a:lnRef>
+              <a:fillRef idx="1">
+                <a:schemeClr val="accent1"/>
+              </a:fillRef>
+              <a:effectRef idx="0">
+                <a:schemeClr val="accent1"/>
+              </a:effectRef>
+              <a:fontRef idx="minor">
+                <a:schemeClr val="lt1"/>
+              </a:fontRef>
+            </p:style>
+            <p:txBody>
+              <a:bodyPr rtlCol="0" anchor="ctr"/>
+              <a:lstStyle/>
+              <a:p>
+                <a:pPr algn="ctr"/>
+                <a:endParaRPr lang="LID4096"/>
+              </a:p>
+            </p:txBody>
+          </p:sp>
+          <p:sp>
+            <p:nvSpPr>
+              <p:cNvPr id="141" name="TextBox 140">
+                <a:extLst>
+                  <a:ext uri="{FF2B5EF4-FFF2-40B4-BE49-F238E27FC236}">
+                    <a16:creationId xmlns:a16="http://schemas.microsoft.com/office/drawing/2014/main" id="{AE8C815B-7E18-CE74-1D37-2454B20069A0}"/>
+                  </a:ext>
+                </a:extLst>
+              </p:cNvPr>
+              <p:cNvSpPr txBox="1"/>
+              <p:nvPr/>
+            </p:nvSpPr>
+            <p:spPr>
+              <a:xfrm>
+                <a:off x="2010738" y="1922554"/>
+                <a:ext cx="2959845" cy="553998"/>
+              </a:xfrm>
+              <a:prstGeom prst="rect">
+                <a:avLst/>
+              </a:prstGeom>
+              <a:noFill/>
+            </p:spPr>
+            <p:txBody>
+              <a:bodyPr wrap="square" lIns="0" tIns="0" rIns="0" bIns="0" rtlCol="0">
+                <a:spAutoFit/>
+              </a:bodyPr>
+              <a:lstStyle/>
+              <a:p>
+                <a:pPr>
+                  <a:buSzPct val="100000"/>
+                </a:pPr>
+                <a:r>
+                  <a:rPr lang="en-US" sz="1200" b="1" dirty="0">
+                    <a:latin typeface="DM Sans" pitchFamily="2" charset="0"/>
+                  </a:rPr>
+                  <a:t>Products</a:t>
+                </a:r>
+                <a:r>
+                  <a:rPr lang="en-US" sz="1200" dirty="0">
+                    <a:latin typeface="DM Sans" pitchFamily="2" charset="0"/>
+                  </a:rPr>
+                  <a:t> -  by platform or business unit</a:t>
+                </a:r>
+              </a:p>
+              <a:p>
+                <a:pPr>
+                  <a:buSzPct val="100000"/>
+                </a:pPr>
+                <a:r>
+                  <a:rPr lang="en-US" sz="1200" dirty="0">
+                    <a:solidFill>
+                      <a:schemeClr val="tx1">
+                        <a:lumMod val="75000"/>
+                        <a:lumOff val="25000"/>
+                      </a:schemeClr>
+                    </a:solidFill>
+                    <a:latin typeface="+mj-lt"/>
+                  </a:rPr>
+                  <a:t>Product vision &amp; objectives, products, persona’s, customer journeys, frictions</a:t>
+                </a:r>
+              </a:p>
+            </p:txBody>
+          </p:sp>
+          <p:sp>
+            <p:nvSpPr>
+              <p:cNvPr id="43" name="Rectangle 42">
+                <a:extLst>
+                  <a:ext uri="{FF2B5EF4-FFF2-40B4-BE49-F238E27FC236}">
+                    <a16:creationId xmlns:a16="http://schemas.microsoft.com/office/drawing/2014/main" id="{77F83771-69DC-DE58-F493-65CEDB545E5C}"/>
+                  </a:ext>
+                </a:extLst>
+              </p:cNvPr>
+              <p:cNvSpPr/>
+              <p:nvPr/>
+            </p:nvSpPr>
+            <p:spPr>
+              <a:xfrm>
+                <a:off x="6089213" y="1959390"/>
+                <a:ext cx="557171" cy="697758"/>
+              </a:xfrm>
+              <a:prstGeom prst="rect">
+                <a:avLst/>
+              </a:prstGeom>
+              <a:solidFill>
+                <a:schemeClr val="bg1"/>
+              </a:solidFill>
+              <a:ln>
+                <a:noFill/>
+              </a:ln>
+            </p:spPr>
+            <p:style>
+              <a:lnRef idx="2">
+                <a:schemeClr val="accent1">
+                  <a:shade val="15000"/>
+                </a:schemeClr>
+              </a:lnRef>
+              <a:fillRef idx="1">
+                <a:schemeClr val="accent1"/>
+              </a:fillRef>
+              <a:effectRef idx="0">
+                <a:schemeClr val="accent1"/>
+              </a:effectRef>
+              <a:fontRef idx="minor">
+                <a:schemeClr val="lt1"/>
+              </a:fontRef>
+            </p:style>
+            <p:txBody>
+              <a:bodyPr rtlCol="0" anchor="ctr"/>
+              <a:lstStyle/>
+              <a:p>
+                <a:pPr algn="ctr"/>
+                <a:r>
+                  <a:rPr lang="nl-NL" sz="1100" dirty="0">
+                    <a:solidFill>
+                      <a:schemeClr val="tx1"/>
+                    </a:solidFill>
+                    <a:latin typeface="DM Sans" pitchFamily="2" charset="0"/>
+                  </a:rPr>
+                  <a:t>BU 1</a:t>
+                </a:r>
+                <a:endParaRPr lang="LID4096" sz="1100" dirty="0">
+                  <a:solidFill>
+                    <a:schemeClr val="tx1"/>
+                  </a:solidFill>
                   <a:latin typeface="DM Sans" pitchFamily="2" charset="0"/>
-                </a:rPr>
-                <a:t>Vision</a:t>
-              </a:r>
-            </a:p>
-            <a:p>
-              <a:pPr>
-                <a:buSzPct val="100000"/>
-              </a:pPr>
-              <a:r>
-                <a:rPr lang="en-US" sz="1200" dirty="0">
-                  <a:latin typeface="+mj-lt"/>
-                </a:rPr>
-                <a:t>Vision</a:t>
-              </a:r>
-              <a:r>
-                <a:rPr lang="en-US" sz="1200" b="1" dirty="0">
-                  <a:latin typeface="+mj-lt"/>
-                </a:rPr>
-                <a:t>, </a:t>
-              </a:r>
-              <a:r>
-                <a:rPr lang="en-US" sz="1200" dirty="0">
-                  <a:latin typeface="+mj-lt"/>
-                </a:rPr>
-                <a:t>strategy, values, objectives</a:t>
-              </a:r>
-            </a:p>
-          </p:txBody>
-        </p:sp>
+                </a:endParaRPr>
+              </a:p>
+            </p:txBody>
+          </p:sp>
+          <p:sp>
+            <p:nvSpPr>
+              <p:cNvPr id="44" name="Rectangle 43">
+                <a:extLst>
+                  <a:ext uri="{FF2B5EF4-FFF2-40B4-BE49-F238E27FC236}">
+                    <a16:creationId xmlns:a16="http://schemas.microsoft.com/office/drawing/2014/main" id="{E95E7BBB-0795-3FA3-F052-AA3D1DD6498B}"/>
+                  </a:ext>
+                </a:extLst>
+              </p:cNvPr>
+              <p:cNvSpPr/>
+              <p:nvPr/>
+            </p:nvSpPr>
+            <p:spPr>
+              <a:xfrm>
+                <a:off x="6720157" y="1959390"/>
+                <a:ext cx="557171" cy="697758"/>
+              </a:xfrm>
+              <a:prstGeom prst="rect">
+                <a:avLst/>
+              </a:prstGeom>
+              <a:solidFill>
+                <a:schemeClr val="bg1"/>
+              </a:solidFill>
+              <a:ln>
+                <a:noFill/>
+              </a:ln>
+            </p:spPr>
+            <p:style>
+              <a:lnRef idx="2">
+                <a:schemeClr val="accent1">
+                  <a:shade val="15000"/>
+                </a:schemeClr>
+              </a:lnRef>
+              <a:fillRef idx="1">
+                <a:schemeClr val="accent1"/>
+              </a:fillRef>
+              <a:effectRef idx="0">
+                <a:schemeClr val="accent1"/>
+              </a:effectRef>
+              <a:fontRef idx="minor">
+                <a:schemeClr val="lt1"/>
+              </a:fontRef>
+            </p:style>
+            <p:txBody>
+              <a:bodyPr rtlCol="0" anchor="ctr"/>
+              <a:lstStyle/>
+              <a:p>
+                <a:pPr algn="ctr"/>
+                <a:r>
+                  <a:rPr lang="nl-NL" sz="1100" dirty="0">
+                    <a:solidFill>
+                      <a:schemeClr val="tx1"/>
+                    </a:solidFill>
+                    <a:latin typeface="DM Sans" pitchFamily="2" charset="0"/>
+                  </a:rPr>
+                  <a:t>BU 2</a:t>
+                </a:r>
+                <a:endParaRPr lang="LID4096" sz="1100" dirty="0">
+                  <a:solidFill>
+                    <a:schemeClr val="tx1"/>
+                  </a:solidFill>
+                  <a:latin typeface="DM Sans" pitchFamily="2" charset="0"/>
+                </a:endParaRPr>
+              </a:p>
+            </p:txBody>
+          </p:sp>
+          <p:sp>
+            <p:nvSpPr>
+              <p:cNvPr id="30" name="Rectangle 42">
+                <a:extLst>
+                  <a:ext uri="{FF2B5EF4-FFF2-40B4-BE49-F238E27FC236}">
+                    <a16:creationId xmlns:a16="http://schemas.microsoft.com/office/drawing/2014/main" id="{66F9516B-8552-CDAF-75C4-8A281C36B6F8}"/>
+                  </a:ext>
+                </a:extLst>
+              </p:cNvPr>
+              <p:cNvSpPr/>
+              <p:nvPr/>
+            </p:nvSpPr>
+            <p:spPr>
+              <a:xfrm>
+                <a:off x="7351101" y="1959390"/>
+                <a:ext cx="557171" cy="697758"/>
+              </a:xfrm>
+              <a:prstGeom prst="rect">
+                <a:avLst/>
+              </a:prstGeom>
+              <a:solidFill>
+                <a:schemeClr val="bg1"/>
+              </a:solidFill>
+              <a:ln>
+                <a:noFill/>
+              </a:ln>
+            </p:spPr>
+            <p:style>
+              <a:lnRef idx="2">
+                <a:schemeClr val="accent1">
+                  <a:shade val="15000"/>
+                </a:schemeClr>
+              </a:lnRef>
+              <a:fillRef idx="1">
+                <a:schemeClr val="accent1"/>
+              </a:fillRef>
+              <a:effectRef idx="0">
+                <a:schemeClr val="accent1"/>
+              </a:effectRef>
+              <a:fontRef idx="minor">
+                <a:schemeClr val="lt1"/>
+              </a:fontRef>
+            </p:style>
+            <p:txBody>
+              <a:bodyPr rtlCol="0" anchor="ctr"/>
+              <a:lstStyle/>
+              <a:p>
+                <a:pPr algn="ctr"/>
+                <a:r>
+                  <a:rPr lang="nl-NL" sz="1100" dirty="0">
+                    <a:solidFill>
+                      <a:schemeClr val="tx1"/>
+                    </a:solidFill>
+                    <a:latin typeface="DM Sans" pitchFamily="2" charset="0"/>
+                  </a:rPr>
+                  <a:t>BU 3</a:t>
+                </a:r>
+                <a:endParaRPr lang="LID4096" sz="1100" dirty="0">
+                  <a:solidFill>
+                    <a:schemeClr val="tx1"/>
+                  </a:solidFill>
+                  <a:latin typeface="DM Sans" pitchFamily="2" charset="0"/>
+                </a:endParaRPr>
+              </a:p>
+            </p:txBody>
+          </p:sp>
+          <p:sp>
+            <p:nvSpPr>
+              <p:cNvPr id="32" name="Rectangle 43">
+                <a:extLst>
+                  <a:ext uri="{FF2B5EF4-FFF2-40B4-BE49-F238E27FC236}">
+                    <a16:creationId xmlns:a16="http://schemas.microsoft.com/office/drawing/2014/main" id="{005EA54E-A05B-E9A5-FE26-09518F608969}"/>
+                  </a:ext>
+                </a:extLst>
+              </p:cNvPr>
+              <p:cNvSpPr/>
+              <p:nvPr/>
+            </p:nvSpPr>
+            <p:spPr>
+              <a:xfrm>
+                <a:off x="7982046" y="1959390"/>
+                <a:ext cx="557171" cy="697758"/>
+              </a:xfrm>
+              <a:prstGeom prst="rect">
+                <a:avLst/>
+              </a:prstGeom>
+              <a:solidFill>
+                <a:schemeClr val="bg1"/>
+              </a:solidFill>
+              <a:ln>
+                <a:noFill/>
+              </a:ln>
+            </p:spPr>
+            <p:style>
+              <a:lnRef idx="2">
+                <a:schemeClr val="accent1">
+                  <a:shade val="15000"/>
+                </a:schemeClr>
+              </a:lnRef>
+              <a:fillRef idx="1">
+                <a:schemeClr val="accent1"/>
+              </a:fillRef>
+              <a:effectRef idx="0">
+                <a:schemeClr val="accent1"/>
+              </a:effectRef>
+              <a:fontRef idx="minor">
+                <a:schemeClr val="lt1"/>
+              </a:fontRef>
+            </p:style>
+            <p:txBody>
+              <a:bodyPr rtlCol="0" anchor="ctr"/>
+              <a:lstStyle/>
+              <a:p>
+                <a:pPr algn="ctr"/>
+                <a:r>
+                  <a:rPr lang="nl-NL" sz="1100" dirty="0">
+                    <a:solidFill>
+                      <a:schemeClr val="tx1"/>
+                    </a:solidFill>
+                    <a:latin typeface="DM Sans" pitchFamily="2" charset="0"/>
+                  </a:rPr>
+                  <a:t>BU 4</a:t>
+                </a:r>
+                <a:endParaRPr lang="LID4096" sz="1100" dirty="0">
+                  <a:solidFill>
+                    <a:schemeClr val="tx1"/>
+                  </a:solidFill>
+                  <a:latin typeface="DM Sans" pitchFamily="2" charset="0"/>
+                </a:endParaRPr>
+              </a:p>
+            </p:txBody>
+          </p:sp>
+        </p:grpSp>
       </p:grpSp>
+    </p:spTree>
+    <p:extLst>
+      <p:ext uri="{BB962C8B-B14F-4D97-AF65-F5344CB8AC3E}">
+        <p14:creationId xmlns:p14="http://schemas.microsoft.com/office/powerpoint/2010/main" val="3155234622"/>
+      </p:ext>
+    </p:extLst>
+  </p:cSld>
+  <p:clrMapOvr>
+    <a:masterClrMapping/>
+  </p:clrMapOvr>
+</p:sld>
+</file>
+
+<file path=ppt/slides/slide2.xml><?xml version="1.0" encoding="utf-8"?>
+<p:sld xmlns:a="http://schemas.openxmlformats.org/drawingml/2006/main" xmlns:r="http://schemas.openxmlformats.org/officeDocument/2006/relationships" xmlns:p="http://schemas.openxmlformats.org/presentationml/2006/main">
+  <p:cSld>
+    <p:spTree>
+      <p:nvGrpSpPr>
+        <p:cNvPr id="1" name="">
+          <a:extLst>
+            <a:ext uri="{FF2B5EF4-FFF2-40B4-BE49-F238E27FC236}">
+              <a16:creationId xmlns:a16="http://schemas.microsoft.com/office/drawing/2014/main" id="{FE02BF3D-FE41-717C-33E1-78FB61410191}"/>
+            </a:ext>
+          </a:extLst>
+        </p:cNvPr>
+        <p:cNvGrpSpPr/>
+        <p:nvPr/>
+      </p:nvGrpSpPr>
+      <p:grpSpPr>
+        <a:xfrm>
+          <a:off x="0" y="0"/>
+          <a:ext cx="0" cy="0"/>
+          <a:chOff x="0" y="0"/>
+          <a:chExt cx="0" cy="0"/>
+        </a:xfrm>
+      </p:grpSpPr>
+      <p:sp>
+        <p:nvSpPr>
+          <p:cNvPr id="3" name="Title 2">
+            <a:extLst>
+              <a:ext uri="{FF2B5EF4-FFF2-40B4-BE49-F238E27FC236}">
+                <a16:creationId xmlns:a16="http://schemas.microsoft.com/office/drawing/2014/main" id="{D1C8DFE4-22E2-2B56-23FE-10A83A8E3238}"/>
+              </a:ext>
+            </a:extLst>
+          </p:cNvPr>
+          <p:cNvSpPr>
+            <a:spLocks noGrp="1"/>
+          </p:cNvSpPr>
+          <p:nvPr>
+            <p:ph type="title"/>
+          </p:nvPr>
+        </p:nvSpPr>
+        <p:spPr/>
+        <p:txBody>
+          <a:bodyPr>
+            <a:normAutofit/>
+          </a:bodyPr>
+          <a:lstStyle/>
+          <a:p>
+            <a:r>
+              <a:rPr lang="en-US" dirty="0"/>
+              <a:t>AI Transformation framework for European CEO’s – not used</a:t>
+            </a:r>
+          </a:p>
+        </p:txBody>
+      </p:sp>
+      <p:sp>
+        <p:nvSpPr>
+          <p:cNvPr id="4" name="Text Placeholder 3">
+            <a:extLst>
+              <a:ext uri="{FF2B5EF4-FFF2-40B4-BE49-F238E27FC236}">
+                <a16:creationId xmlns:a16="http://schemas.microsoft.com/office/drawing/2014/main" id="{934FD04A-9782-DFEE-47DD-6E1AAA12FCC2}"/>
+              </a:ext>
+            </a:extLst>
+          </p:cNvPr>
+          <p:cNvSpPr>
+            <a:spLocks noGrp="1"/>
+          </p:cNvSpPr>
+          <p:nvPr>
+            <p:ph type="body" sz="quarter" idx="10"/>
+          </p:nvPr>
+        </p:nvSpPr>
+        <p:spPr/>
+        <p:txBody>
+          <a:bodyPr/>
+          <a:lstStyle/>
+          <a:p>
+            <a:r>
+              <a:rPr lang="en-US" dirty="0"/>
+              <a:t>The Agentic </a:t>
+            </a:r>
+            <a:r>
+              <a:rPr lang="en-US" dirty="0" err="1"/>
+              <a:t>Organisation</a:t>
+            </a:r>
+            <a:endParaRPr lang="en-US" dirty="0"/>
+          </a:p>
+        </p:txBody>
+      </p:sp>
       <p:grpSp>
         <p:nvGrpSpPr>
           <p:cNvPr id="8" name="Groep 7">
@@ -4788,6 +6191,12 @@
                 </a:pPr>
                 <a:r>
                   <a:rPr lang="en-US" sz="1200" dirty="0">
+                    <a:solidFill>
+                      <a:schemeClr val="tx1">
+                        <a:lumMod val="75000"/>
+                        <a:lumOff val="25000"/>
+                      </a:schemeClr>
+                    </a:solidFill>
                     <a:latin typeface="+mj-lt"/>
                   </a:rPr>
                   <a:t>Roadmap, big decisions, change management</a:t>
@@ -4839,6 +6248,12 @@
                 </a:pPr>
                 <a:r>
                   <a:rPr lang="en-US" sz="1200" dirty="0">
+                    <a:solidFill>
+                      <a:schemeClr val="tx1">
+                        <a:lumMod val="75000"/>
+                        <a:lumOff val="25000"/>
+                      </a:schemeClr>
+                    </a:solidFill>
                     <a:latin typeface="+mj-lt"/>
                   </a:rPr>
                   <a:t>Definitions, targets, monitoring, steering</a:t>
@@ -4890,6 +6305,12 @@
                 </a:pPr>
                 <a:r>
                   <a:rPr lang="en-US" sz="1200" dirty="0">
+                    <a:solidFill>
+                      <a:schemeClr val="tx1">
+                        <a:lumMod val="75000"/>
+                        <a:lumOff val="25000"/>
+                      </a:schemeClr>
+                    </a:solidFill>
                     <a:latin typeface="+mj-lt"/>
                   </a:rPr>
                   <a:t>ROI, cost analysis &amp; optimization, tracking</a:t>
@@ -4898,1007 +6319,6 @@
             </p:txBody>
           </p:sp>
         </p:grpSp>
-      </p:grpSp>
-      <p:grpSp>
-        <p:nvGrpSpPr>
-          <p:cNvPr id="9" name="Groep 8">
-            <a:extLst>
-              <a:ext uri="{FF2B5EF4-FFF2-40B4-BE49-F238E27FC236}">
-                <a16:creationId xmlns:a16="http://schemas.microsoft.com/office/drawing/2014/main" id="{ED531BDA-D9E1-B250-6381-7DFF6243F863}"/>
-              </a:ext>
-            </a:extLst>
-          </p:cNvPr>
-          <p:cNvGrpSpPr/>
-          <p:nvPr/>
-        </p:nvGrpSpPr>
-        <p:grpSpPr>
-          <a:xfrm>
-            <a:off x="1875658" y="3887682"/>
-            <a:ext cx="7034080" cy="908874"/>
-            <a:chOff x="1875658" y="2895090"/>
-            <a:chExt cx="7034080" cy="908874"/>
-          </a:xfrm>
-        </p:grpSpPr>
-        <p:grpSp>
-          <p:nvGrpSpPr>
-            <p:cNvPr id="6" name="Groep 5">
-              <a:extLst>
-                <a:ext uri="{FF2B5EF4-FFF2-40B4-BE49-F238E27FC236}">
-                  <a16:creationId xmlns:a16="http://schemas.microsoft.com/office/drawing/2014/main" id="{2A1038EE-D6B3-1076-10A0-7EDB04F89669}"/>
-                </a:ext>
-              </a:extLst>
-            </p:cNvPr>
-            <p:cNvGrpSpPr/>
-            <p:nvPr/>
-          </p:nvGrpSpPr>
-          <p:grpSpPr>
-            <a:xfrm>
-              <a:off x="1875658" y="2895090"/>
-              <a:ext cx="7034080" cy="908874"/>
-              <a:chOff x="1875658" y="2895090"/>
-              <a:chExt cx="7034080" cy="908874"/>
-            </a:xfrm>
-          </p:grpSpPr>
-          <p:sp>
-            <p:nvSpPr>
-              <p:cNvPr id="151" name="Rectangle 150">
-                <a:extLst>
-                  <a:ext uri="{FF2B5EF4-FFF2-40B4-BE49-F238E27FC236}">
-                    <a16:creationId xmlns:a16="http://schemas.microsoft.com/office/drawing/2014/main" id="{DA84A920-84E4-D38E-DFB7-5C496D13FC0A}"/>
-                  </a:ext>
-                </a:extLst>
-              </p:cNvPr>
-              <p:cNvSpPr/>
-              <p:nvPr/>
-            </p:nvSpPr>
-            <p:spPr>
-              <a:xfrm>
-                <a:off x="1875658" y="2895090"/>
-                <a:ext cx="2279565" cy="908874"/>
-              </a:xfrm>
-              <a:prstGeom prst="rect">
-                <a:avLst/>
-              </a:prstGeom>
-              <a:solidFill>
-                <a:schemeClr val="accent1">
-                  <a:lumMod val="20000"/>
-                  <a:lumOff val="80000"/>
-                </a:schemeClr>
-              </a:solidFill>
-              <a:ln>
-                <a:noFill/>
-              </a:ln>
-            </p:spPr>
-            <p:style>
-              <a:lnRef idx="2">
-                <a:schemeClr val="accent1">
-                  <a:shade val="15000"/>
-                </a:schemeClr>
-              </a:lnRef>
-              <a:fillRef idx="1">
-                <a:schemeClr val="accent1"/>
-              </a:fillRef>
-              <a:effectRef idx="0">
-                <a:schemeClr val="accent1"/>
-              </a:effectRef>
-              <a:fontRef idx="minor">
-                <a:schemeClr val="lt1"/>
-              </a:fontRef>
-            </p:style>
-            <p:txBody>
-              <a:bodyPr rtlCol="0" anchor="ctr"/>
-              <a:lstStyle/>
-              <a:p>
-                <a:pPr algn="ctr"/>
-                <a:endParaRPr lang="LID4096"/>
-              </a:p>
-            </p:txBody>
-          </p:sp>
-          <p:sp>
-            <p:nvSpPr>
-              <p:cNvPr id="154" name="Rectangle 153">
-                <a:extLst>
-                  <a:ext uri="{FF2B5EF4-FFF2-40B4-BE49-F238E27FC236}">
-                    <a16:creationId xmlns:a16="http://schemas.microsoft.com/office/drawing/2014/main" id="{55D2C2E2-60C1-A4D8-155A-29C4AE9102DC}"/>
-                  </a:ext>
-                </a:extLst>
-              </p:cNvPr>
-              <p:cNvSpPr/>
-              <p:nvPr/>
-            </p:nvSpPr>
-            <p:spPr>
-              <a:xfrm>
-                <a:off x="4252915" y="2895090"/>
-                <a:ext cx="2279565" cy="908874"/>
-              </a:xfrm>
-              <a:prstGeom prst="rect">
-                <a:avLst/>
-              </a:prstGeom>
-              <a:solidFill>
-                <a:schemeClr val="accent1">
-                  <a:lumMod val="20000"/>
-                  <a:lumOff val="80000"/>
-                </a:schemeClr>
-              </a:solidFill>
-              <a:ln>
-                <a:noFill/>
-              </a:ln>
-            </p:spPr>
-            <p:style>
-              <a:lnRef idx="2">
-                <a:schemeClr val="accent1">
-                  <a:shade val="15000"/>
-                </a:schemeClr>
-              </a:lnRef>
-              <a:fillRef idx="1">
-                <a:schemeClr val="accent1"/>
-              </a:fillRef>
-              <a:effectRef idx="0">
-                <a:schemeClr val="accent1"/>
-              </a:effectRef>
-              <a:fontRef idx="minor">
-                <a:schemeClr val="lt1"/>
-              </a:fontRef>
-            </p:style>
-            <p:txBody>
-              <a:bodyPr rtlCol="0" anchor="ctr"/>
-              <a:lstStyle/>
-              <a:p>
-                <a:pPr algn="ctr"/>
-                <a:endParaRPr lang="LID4096"/>
-              </a:p>
-            </p:txBody>
-          </p:sp>
-          <p:sp>
-            <p:nvSpPr>
-              <p:cNvPr id="156" name="Rectangle 155">
-                <a:extLst>
-                  <a:ext uri="{FF2B5EF4-FFF2-40B4-BE49-F238E27FC236}">
-                    <a16:creationId xmlns:a16="http://schemas.microsoft.com/office/drawing/2014/main" id="{DD197C6D-A1CA-B22B-ECAC-F110C43F9350}"/>
-                  </a:ext>
-                </a:extLst>
-              </p:cNvPr>
-              <p:cNvSpPr/>
-              <p:nvPr/>
-            </p:nvSpPr>
-            <p:spPr>
-              <a:xfrm>
-                <a:off x="6630173" y="2895090"/>
-                <a:ext cx="2279565" cy="908874"/>
-              </a:xfrm>
-              <a:prstGeom prst="rect">
-                <a:avLst/>
-              </a:prstGeom>
-              <a:solidFill>
-                <a:schemeClr val="accent1">
-                  <a:lumMod val="20000"/>
-                  <a:lumOff val="80000"/>
-                </a:schemeClr>
-              </a:solidFill>
-              <a:ln>
-                <a:noFill/>
-              </a:ln>
-            </p:spPr>
-            <p:style>
-              <a:lnRef idx="2">
-                <a:schemeClr val="accent1">
-                  <a:shade val="15000"/>
-                </a:schemeClr>
-              </a:lnRef>
-              <a:fillRef idx="1">
-                <a:schemeClr val="accent1"/>
-              </a:fillRef>
-              <a:effectRef idx="0">
-                <a:schemeClr val="accent1"/>
-              </a:effectRef>
-              <a:fontRef idx="minor">
-                <a:schemeClr val="lt1"/>
-              </a:fontRef>
-            </p:style>
-            <p:txBody>
-              <a:bodyPr rtlCol="0" anchor="ctr"/>
-              <a:lstStyle/>
-              <a:p>
-                <a:pPr algn="ctr"/>
-                <a:endParaRPr lang="LID4096"/>
-              </a:p>
-            </p:txBody>
-          </p:sp>
-        </p:grpSp>
-        <p:sp>
-          <p:nvSpPr>
-            <p:cNvPr id="152" name="TextBox 151">
-              <a:extLst>
-                <a:ext uri="{FF2B5EF4-FFF2-40B4-BE49-F238E27FC236}">
-                  <a16:creationId xmlns:a16="http://schemas.microsoft.com/office/drawing/2014/main" id="{30FBF885-B703-4E76-E0CE-D11230D74F72}"/>
-                </a:ext>
-              </a:extLst>
-            </p:cNvPr>
-            <p:cNvSpPr txBox="1"/>
-            <p:nvPr/>
-          </p:nvSpPr>
-          <p:spPr>
-            <a:xfrm>
-              <a:off x="2010737" y="2961596"/>
-              <a:ext cx="2239199" cy="738664"/>
-            </a:xfrm>
-            <a:prstGeom prst="rect">
-              <a:avLst/>
-            </a:prstGeom>
-            <a:noFill/>
-          </p:spPr>
-          <p:txBody>
-            <a:bodyPr wrap="square" lIns="0" tIns="0" rIns="0" bIns="0" rtlCol="0">
-              <a:spAutoFit/>
-            </a:bodyPr>
-            <a:lstStyle/>
-            <a:p>
-              <a:pPr>
-                <a:buSzPct val="100000"/>
-              </a:pPr>
-              <a:r>
-                <a:rPr lang="en-US" sz="1200" b="1" dirty="0">
-                  <a:latin typeface="DM Sans" pitchFamily="2" charset="0"/>
-                </a:rPr>
-                <a:t>Data</a:t>
-              </a:r>
-            </a:p>
-            <a:p>
-              <a:pPr>
-                <a:buSzPct val="100000"/>
-              </a:pPr>
-              <a:r>
-                <a:rPr lang="en-US" sz="1200" dirty="0"/>
-                <a:t>Reusable data products, analytics, architecture, monetization</a:t>
-              </a:r>
-            </a:p>
-          </p:txBody>
-        </p:sp>
-        <p:sp>
-          <p:nvSpPr>
-            <p:cNvPr id="155" name="TextBox 154">
-              <a:extLst>
-                <a:ext uri="{FF2B5EF4-FFF2-40B4-BE49-F238E27FC236}">
-                  <a16:creationId xmlns:a16="http://schemas.microsoft.com/office/drawing/2014/main" id="{2F26F3B8-CA9A-3660-D416-56970DACBC05}"/>
-                </a:ext>
-              </a:extLst>
-            </p:cNvPr>
-            <p:cNvSpPr txBox="1"/>
-            <p:nvPr/>
-          </p:nvSpPr>
-          <p:spPr>
-            <a:xfrm>
-              <a:off x="4391989" y="2961596"/>
-              <a:ext cx="1878739" cy="738664"/>
-            </a:xfrm>
-            <a:prstGeom prst="rect">
-              <a:avLst/>
-            </a:prstGeom>
-            <a:noFill/>
-          </p:spPr>
-          <p:txBody>
-            <a:bodyPr wrap="square" lIns="0" tIns="0" rIns="0" bIns="0" rtlCol="0">
-              <a:spAutoFit/>
-            </a:bodyPr>
-            <a:lstStyle/>
-            <a:p>
-              <a:pPr>
-                <a:buSzPct val="100000"/>
-              </a:pPr>
-              <a:r>
-                <a:rPr lang="en-US" sz="1200" b="1" dirty="0">
-                  <a:latin typeface="DM Sans" pitchFamily="2" charset="0"/>
-                </a:rPr>
-                <a:t>Technology</a:t>
-              </a:r>
-            </a:p>
-            <a:p>
-              <a:pPr>
-                <a:buSzPct val="100000"/>
-              </a:pPr>
-              <a:r>
-                <a:rPr lang="en-US" sz="1200" dirty="0"/>
-                <a:t>Target architecture, platforms &amp; solutions, integration </a:t>
-              </a:r>
-            </a:p>
-          </p:txBody>
-        </p:sp>
-        <p:sp>
-          <p:nvSpPr>
-            <p:cNvPr id="157" name="TextBox 156">
-              <a:extLst>
-                <a:ext uri="{FF2B5EF4-FFF2-40B4-BE49-F238E27FC236}">
-                  <a16:creationId xmlns:a16="http://schemas.microsoft.com/office/drawing/2014/main" id="{3AA9ACAD-2309-6695-05C5-A00E27FC3BF5}"/>
-                </a:ext>
-              </a:extLst>
-            </p:cNvPr>
-            <p:cNvSpPr txBox="1"/>
-            <p:nvPr/>
-          </p:nvSpPr>
-          <p:spPr>
-            <a:xfrm>
-              <a:off x="6763057" y="2961596"/>
-              <a:ext cx="1884734" cy="738664"/>
-            </a:xfrm>
-            <a:prstGeom prst="rect">
-              <a:avLst/>
-            </a:prstGeom>
-            <a:noFill/>
-          </p:spPr>
-          <p:txBody>
-            <a:bodyPr wrap="square" lIns="0" tIns="0" rIns="0" bIns="0" rtlCol="0">
-              <a:spAutoFit/>
-            </a:bodyPr>
-            <a:lstStyle/>
-            <a:p>
-              <a:pPr>
-                <a:buSzPct val="100000"/>
-              </a:pPr>
-              <a:r>
-                <a:rPr lang="en-US" sz="1200" b="1" dirty="0">
-                  <a:latin typeface="DM Sans" pitchFamily="2" charset="0"/>
-                </a:rPr>
-                <a:t>Enablement</a:t>
-              </a:r>
-            </a:p>
-            <a:p>
-              <a:pPr>
-                <a:buSzPct val="100000"/>
-              </a:pPr>
-              <a:r>
-                <a:rPr lang="en-US" sz="1200" dirty="0"/>
-                <a:t>Culture, AI &amp; engineering toolbox, automation, agents, skills</a:t>
-              </a:r>
-            </a:p>
-          </p:txBody>
-        </p:sp>
-      </p:grpSp>
-      <p:grpSp>
-        <p:nvGrpSpPr>
-          <p:cNvPr id="11" name="Groep 10">
-            <a:extLst>
-              <a:ext uri="{FF2B5EF4-FFF2-40B4-BE49-F238E27FC236}">
-                <a16:creationId xmlns:a16="http://schemas.microsoft.com/office/drawing/2014/main" id="{B7CF1138-4C4E-266E-D6C0-860E7EEBF20D}"/>
-              </a:ext>
-            </a:extLst>
-          </p:cNvPr>
-          <p:cNvGrpSpPr/>
-          <p:nvPr/>
-        </p:nvGrpSpPr>
-        <p:grpSpPr>
-          <a:xfrm>
-            <a:off x="1875658" y="2896545"/>
-            <a:ext cx="7031757" cy="908874"/>
-            <a:chOff x="1875658" y="3934756"/>
-            <a:chExt cx="7031757" cy="908874"/>
-          </a:xfrm>
-        </p:grpSpPr>
-        <p:grpSp>
-          <p:nvGrpSpPr>
-            <p:cNvPr id="7" name="Groep 6">
-              <a:extLst>
-                <a:ext uri="{FF2B5EF4-FFF2-40B4-BE49-F238E27FC236}">
-                  <a16:creationId xmlns:a16="http://schemas.microsoft.com/office/drawing/2014/main" id="{FA87857C-EE64-83B6-1558-C834EDD82F05}"/>
-                </a:ext>
-              </a:extLst>
-            </p:cNvPr>
-            <p:cNvGrpSpPr/>
-            <p:nvPr/>
-          </p:nvGrpSpPr>
-          <p:grpSpPr>
-            <a:xfrm>
-              <a:off x="1875658" y="3934756"/>
-              <a:ext cx="7031757" cy="908874"/>
-              <a:chOff x="1875658" y="3934756"/>
-              <a:chExt cx="7031757" cy="908874"/>
-            </a:xfrm>
-          </p:grpSpPr>
-          <p:sp>
-            <p:nvSpPr>
-              <p:cNvPr id="162" name="Rectangle 161">
-                <a:extLst>
-                  <a:ext uri="{FF2B5EF4-FFF2-40B4-BE49-F238E27FC236}">
-                    <a16:creationId xmlns:a16="http://schemas.microsoft.com/office/drawing/2014/main" id="{72576AB9-B02D-3B55-BF90-C23F1A867704}"/>
-                  </a:ext>
-                </a:extLst>
-              </p:cNvPr>
-              <p:cNvSpPr/>
-              <p:nvPr/>
-            </p:nvSpPr>
-            <p:spPr>
-              <a:xfrm>
-                <a:off x="1875658" y="3934756"/>
-                <a:ext cx="3466168" cy="908874"/>
-              </a:xfrm>
-              <a:prstGeom prst="rect">
-                <a:avLst/>
-              </a:prstGeom>
-              <a:solidFill>
-                <a:schemeClr val="accent1">
-                  <a:lumMod val="20000"/>
-                  <a:lumOff val="80000"/>
-                </a:schemeClr>
-              </a:solidFill>
-              <a:ln>
-                <a:noFill/>
-              </a:ln>
-            </p:spPr>
-            <p:style>
-              <a:lnRef idx="2">
-                <a:schemeClr val="accent1">
-                  <a:shade val="15000"/>
-                </a:schemeClr>
-              </a:lnRef>
-              <a:fillRef idx="1">
-                <a:schemeClr val="accent1"/>
-              </a:fillRef>
-              <a:effectRef idx="0">
-                <a:schemeClr val="accent1"/>
-              </a:effectRef>
-              <a:fontRef idx="minor">
-                <a:schemeClr val="lt1"/>
-              </a:fontRef>
-            </p:style>
-            <p:txBody>
-              <a:bodyPr rtlCol="0" anchor="ctr"/>
-              <a:lstStyle/>
-              <a:p>
-                <a:pPr algn="ctr"/>
-                <a:endParaRPr lang="LID4096"/>
-              </a:p>
-            </p:txBody>
-          </p:sp>
-          <p:sp>
-            <p:nvSpPr>
-              <p:cNvPr id="165" name="Rectangle 164">
-                <a:extLst>
-                  <a:ext uri="{FF2B5EF4-FFF2-40B4-BE49-F238E27FC236}">
-                    <a16:creationId xmlns:a16="http://schemas.microsoft.com/office/drawing/2014/main" id="{C8B0295D-55E0-BE71-18DC-D49D90CE7050}"/>
-                  </a:ext>
-                </a:extLst>
-              </p:cNvPr>
-              <p:cNvSpPr/>
-              <p:nvPr/>
-            </p:nvSpPr>
-            <p:spPr>
-              <a:xfrm>
-                <a:off x="5441247" y="3934756"/>
-                <a:ext cx="3466168" cy="908874"/>
-              </a:xfrm>
-              <a:prstGeom prst="rect">
-                <a:avLst/>
-              </a:prstGeom>
-              <a:solidFill>
-                <a:schemeClr val="accent1">
-                  <a:lumMod val="20000"/>
-                  <a:lumOff val="80000"/>
-                </a:schemeClr>
-              </a:solidFill>
-              <a:ln>
-                <a:noFill/>
-              </a:ln>
-            </p:spPr>
-            <p:style>
-              <a:lnRef idx="2">
-                <a:schemeClr val="accent1">
-                  <a:shade val="15000"/>
-                </a:schemeClr>
-              </a:lnRef>
-              <a:fillRef idx="1">
-                <a:schemeClr val="accent1"/>
-              </a:fillRef>
-              <a:effectRef idx="0">
-                <a:schemeClr val="accent1"/>
-              </a:effectRef>
-              <a:fontRef idx="minor">
-                <a:schemeClr val="lt1"/>
-              </a:fontRef>
-            </p:style>
-            <p:txBody>
-              <a:bodyPr rtlCol="0" anchor="ctr"/>
-              <a:lstStyle/>
-              <a:p>
-                <a:pPr algn="ctr"/>
-                <a:endParaRPr lang="LID4096"/>
-              </a:p>
-            </p:txBody>
-          </p:sp>
-        </p:grpSp>
-        <p:sp>
-          <p:nvSpPr>
-            <p:cNvPr id="163" name="TextBox 162">
-              <a:extLst>
-                <a:ext uri="{FF2B5EF4-FFF2-40B4-BE49-F238E27FC236}">
-                  <a16:creationId xmlns:a16="http://schemas.microsoft.com/office/drawing/2014/main" id="{5062C2DE-E635-12D3-2B1A-52C3839E99E0}"/>
-                </a:ext>
-              </a:extLst>
-            </p:cNvPr>
-            <p:cNvSpPr txBox="1"/>
-            <p:nvPr/>
-          </p:nvSpPr>
-          <p:spPr>
-            <a:xfrm>
-              <a:off x="2010739" y="4001262"/>
-              <a:ext cx="2827304" cy="553998"/>
-            </a:xfrm>
-            <a:prstGeom prst="rect">
-              <a:avLst/>
-            </a:prstGeom>
-            <a:noFill/>
-          </p:spPr>
-          <p:txBody>
-            <a:bodyPr wrap="square" lIns="0" tIns="0" rIns="0" bIns="0" rtlCol="0">
-              <a:spAutoFit/>
-            </a:bodyPr>
-            <a:lstStyle/>
-            <a:p>
-              <a:pPr>
-                <a:buSzPct val="100000"/>
-              </a:pPr>
-              <a:r>
-                <a:rPr lang="en-US" sz="1200" b="1" dirty="0">
-                  <a:latin typeface="DM Sans" pitchFamily="2" charset="0"/>
-                </a:rPr>
-                <a:t>People</a:t>
-              </a:r>
-            </a:p>
-            <a:p>
-              <a:pPr>
-                <a:buSzPct val="100000"/>
-              </a:pPr>
-              <a:r>
-                <a:rPr lang="en-US" sz="1200" dirty="0"/>
-                <a:t>Roles, target skills &amp; gaps, org sizing, talent journey, training, team incentives</a:t>
-              </a:r>
-            </a:p>
-          </p:txBody>
-        </p:sp>
-        <p:sp>
-          <p:nvSpPr>
-            <p:cNvPr id="166" name="TextBox 165">
-              <a:extLst>
-                <a:ext uri="{FF2B5EF4-FFF2-40B4-BE49-F238E27FC236}">
-                  <a16:creationId xmlns:a16="http://schemas.microsoft.com/office/drawing/2014/main" id="{3C502B40-5DAD-8077-0D3C-B23D768C371B}"/>
-                </a:ext>
-              </a:extLst>
-            </p:cNvPr>
-            <p:cNvSpPr txBox="1"/>
-            <p:nvPr/>
-          </p:nvSpPr>
-          <p:spPr>
-            <a:xfrm>
-              <a:off x="5571088" y="4001262"/>
-              <a:ext cx="2341828" cy="553998"/>
-            </a:xfrm>
-            <a:prstGeom prst="rect">
-              <a:avLst/>
-            </a:prstGeom>
-            <a:noFill/>
-          </p:spPr>
-          <p:txBody>
-            <a:bodyPr wrap="square" lIns="0" tIns="0" rIns="0" bIns="0" rtlCol="0">
-              <a:spAutoFit/>
-            </a:bodyPr>
-            <a:lstStyle/>
-            <a:p>
-              <a:pPr>
-                <a:buSzPct val="100000"/>
-              </a:pPr>
-              <a:r>
-                <a:rPr lang="en-US" sz="1200" b="1" dirty="0">
-                  <a:latin typeface="DM Sans" pitchFamily="2" charset="0"/>
-                </a:rPr>
-                <a:t>Process</a:t>
-              </a:r>
-            </a:p>
-            <a:p>
-              <a:pPr>
-                <a:buSzPct val="100000"/>
-              </a:pPr>
-              <a:r>
-                <a:rPr lang="en-US" sz="1200" dirty="0"/>
-                <a:t>Org. design, cross-functional teams, product way-of-working</a:t>
-              </a:r>
-            </a:p>
-          </p:txBody>
-        </p:sp>
-      </p:grpSp>
-      <p:grpSp>
-        <p:nvGrpSpPr>
-          <p:cNvPr id="5" name="Groep 4">
-            <a:extLst>
-              <a:ext uri="{FF2B5EF4-FFF2-40B4-BE49-F238E27FC236}">
-                <a16:creationId xmlns:a16="http://schemas.microsoft.com/office/drawing/2014/main" id="{494DD1AA-4D45-71F0-9314-8C1607F0A66C}"/>
-              </a:ext>
-            </a:extLst>
-          </p:cNvPr>
-          <p:cNvGrpSpPr/>
-          <p:nvPr/>
-        </p:nvGrpSpPr>
-        <p:grpSpPr>
-          <a:xfrm>
-            <a:off x="1875657" y="1845667"/>
-            <a:ext cx="7031758" cy="908874"/>
-            <a:chOff x="1875657" y="1856048"/>
-            <a:chExt cx="7031758" cy="908874"/>
-          </a:xfrm>
-        </p:grpSpPr>
-        <p:sp>
-          <p:nvSpPr>
-            <p:cNvPr id="140" name="Rectangle 139">
-              <a:extLst>
-                <a:ext uri="{FF2B5EF4-FFF2-40B4-BE49-F238E27FC236}">
-                  <a16:creationId xmlns:a16="http://schemas.microsoft.com/office/drawing/2014/main" id="{803139DD-F140-2E13-C535-DBA32BD2249E}"/>
-                </a:ext>
-              </a:extLst>
-            </p:cNvPr>
-            <p:cNvSpPr/>
-            <p:nvPr/>
-          </p:nvSpPr>
-          <p:spPr>
-            <a:xfrm>
-              <a:off x="1875657" y="1856048"/>
-              <a:ext cx="7031758" cy="908874"/>
-            </a:xfrm>
-            <a:prstGeom prst="rect">
-              <a:avLst/>
-            </a:prstGeom>
-            <a:solidFill>
-              <a:schemeClr val="accent1">
-                <a:lumMod val="20000"/>
-                <a:lumOff val="80000"/>
-              </a:schemeClr>
-            </a:solidFill>
-            <a:ln>
-              <a:noFill/>
-            </a:ln>
-          </p:spPr>
-          <p:style>
-            <a:lnRef idx="2">
-              <a:schemeClr val="accent1">
-                <a:shade val="15000"/>
-              </a:schemeClr>
-            </a:lnRef>
-            <a:fillRef idx="1">
-              <a:schemeClr val="accent1"/>
-            </a:fillRef>
-            <a:effectRef idx="0">
-              <a:schemeClr val="accent1"/>
-            </a:effectRef>
-            <a:fontRef idx="minor">
-              <a:schemeClr val="lt1"/>
-            </a:fontRef>
-          </p:style>
-          <p:txBody>
-            <a:bodyPr rtlCol="0" anchor="ctr"/>
-            <a:lstStyle/>
-            <a:p>
-              <a:pPr algn="ctr"/>
-              <a:endParaRPr lang="LID4096"/>
-            </a:p>
-          </p:txBody>
-        </p:sp>
-        <p:sp>
-          <p:nvSpPr>
-            <p:cNvPr id="141" name="TextBox 140">
-              <a:extLst>
-                <a:ext uri="{FF2B5EF4-FFF2-40B4-BE49-F238E27FC236}">
-                  <a16:creationId xmlns:a16="http://schemas.microsoft.com/office/drawing/2014/main" id="{AE8C815B-7E18-CE74-1D37-2454B20069A0}"/>
-                </a:ext>
-              </a:extLst>
-            </p:cNvPr>
-            <p:cNvSpPr txBox="1"/>
-            <p:nvPr/>
-          </p:nvSpPr>
-          <p:spPr>
-            <a:xfrm>
-              <a:off x="2010738" y="1922554"/>
-              <a:ext cx="2959845" cy="553998"/>
-            </a:xfrm>
-            <a:prstGeom prst="rect">
-              <a:avLst/>
-            </a:prstGeom>
-            <a:noFill/>
-          </p:spPr>
-          <p:txBody>
-            <a:bodyPr wrap="square" lIns="0" tIns="0" rIns="0" bIns="0" rtlCol="0">
-              <a:spAutoFit/>
-            </a:bodyPr>
-            <a:lstStyle/>
-            <a:p>
-              <a:pPr>
-                <a:buSzPct val="100000"/>
-              </a:pPr>
-              <a:r>
-                <a:rPr lang="en-US" sz="1200" b="1" dirty="0">
-                  <a:latin typeface="DM Sans" pitchFamily="2" charset="0"/>
-                </a:rPr>
-                <a:t>Products</a:t>
-              </a:r>
-              <a:r>
-                <a:rPr lang="en-US" sz="1200" dirty="0">
-                  <a:latin typeface="DM Sans" pitchFamily="2" charset="0"/>
-                </a:rPr>
-                <a:t> -  by business units</a:t>
-              </a:r>
-            </a:p>
-            <a:p>
-              <a:pPr>
-                <a:buSzPct val="100000"/>
-              </a:pPr>
-              <a:r>
-                <a:rPr lang="en-US" sz="1200" dirty="0">
-                  <a:latin typeface="+mj-lt"/>
-                </a:rPr>
-                <a:t>Product vision &amp; objectives, products, persona’s, customer journeys, frictions</a:t>
-              </a:r>
-            </a:p>
-          </p:txBody>
-        </p:sp>
-        <p:sp>
-          <p:nvSpPr>
-            <p:cNvPr id="43" name="Rectangle 42">
-              <a:extLst>
-                <a:ext uri="{FF2B5EF4-FFF2-40B4-BE49-F238E27FC236}">
-                  <a16:creationId xmlns:a16="http://schemas.microsoft.com/office/drawing/2014/main" id="{77F83771-69DC-DE58-F493-65CEDB545E5C}"/>
-                </a:ext>
-              </a:extLst>
-            </p:cNvPr>
-            <p:cNvSpPr/>
-            <p:nvPr/>
-          </p:nvSpPr>
-          <p:spPr>
-            <a:xfrm>
-              <a:off x="6089213" y="1959390"/>
-              <a:ext cx="557171" cy="697758"/>
-            </a:xfrm>
-            <a:prstGeom prst="rect">
-              <a:avLst/>
-            </a:prstGeom>
-            <a:solidFill>
-              <a:schemeClr val="bg1"/>
-            </a:solidFill>
-            <a:ln>
-              <a:noFill/>
-            </a:ln>
-          </p:spPr>
-          <p:style>
-            <a:lnRef idx="2">
-              <a:schemeClr val="accent1">
-                <a:shade val="15000"/>
-              </a:schemeClr>
-            </a:lnRef>
-            <a:fillRef idx="1">
-              <a:schemeClr val="accent1"/>
-            </a:fillRef>
-            <a:effectRef idx="0">
-              <a:schemeClr val="accent1"/>
-            </a:effectRef>
-            <a:fontRef idx="minor">
-              <a:schemeClr val="lt1"/>
-            </a:fontRef>
-          </p:style>
-          <p:txBody>
-            <a:bodyPr rtlCol="0" anchor="ctr"/>
-            <a:lstStyle/>
-            <a:p>
-              <a:pPr algn="ctr"/>
-              <a:r>
-                <a:rPr lang="nl-NL" sz="1100" dirty="0">
-                  <a:solidFill>
-                    <a:schemeClr val="tx1"/>
-                  </a:solidFill>
-                  <a:latin typeface="+mj-lt"/>
-                </a:rPr>
-                <a:t>BU 1</a:t>
-              </a:r>
-              <a:endParaRPr lang="LID4096" sz="1100" dirty="0">
-                <a:solidFill>
-                  <a:schemeClr val="tx1"/>
-                </a:solidFill>
-                <a:latin typeface="+mj-lt"/>
-              </a:endParaRPr>
-            </a:p>
-          </p:txBody>
-        </p:sp>
-        <p:sp>
-          <p:nvSpPr>
-            <p:cNvPr id="44" name="Rectangle 43">
-              <a:extLst>
-                <a:ext uri="{FF2B5EF4-FFF2-40B4-BE49-F238E27FC236}">
-                  <a16:creationId xmlns:a16="http://schemas.microsoft.com/office/drawing/2014/main" id="{E95E7BBB-0795-3FA3-F052-AA3D1DD6498B}"/>
-                </a:ext>
-              </a:extLst>
-            </p:cNvPr>
-            <p:cNvSpPr/>
-            <p:nvPr/>
-          </p:nvSpPr>
-          <p:spPr>
-            <a:xfrm>
-              <a:off x="6720157" y="1959390"/>
-              <a:ext cx="557171" cy="697758"/>
-            </a:xfrm>
-            <a:prstGeom prst="rect">
-              <a:avLst/>
-            </a:prstGeom>
-            <a:solidFill>
-              <a:schemeClr val="bg1"/>
-            </a:solidFill>
-            <a:ln>
-              <a:noFill/>
-            </a:ln>
-          </p:spPr>
-          <p:style>
-            <a:lnRef idx="2">
-              <a:schemeClr val="accent1">
-                <a:shade val="15000"/>
-              </a:schemeClr>
-            </a:lnRef>
-            <a:fillRef idx="1">
-              <a:schemeClr val="accent1"/>
-            </a:fillRef>
-            <a:effectRef idx="0">
-              <a:schemeClr val="accent1"/>
-            </a:effectRef>
-            <a:fontRef idx="minor">
-              <a:schemeClr val="lt1"/>
-            </a:fontRef>
-          </p:style>
-          <p:txBody>
-            <a:bodyPr rtlCol="0" anchor="ctr"/>
-            <a:lstStyle/>
-            <a:p>
-              <a:pPr algn="ctr"/>
-              <a:r>
-                <a:rPr lang="nl-NL" sz="1100" dirty="0">
-                  <a:solidFill>
-                    <a:schemeClr val="tx1"/>
-                  </a:solidFill>
-                  <a:latin typeface="+mj-lt"/>
-                </a:rPr>
-                <a:t>BU 2</a:t>
-              </a:r>
-              <a:endParaRPr lang="LID4096" sz="1100" dirty="0">
-                <a:solidFill>
-                  <a:schemeClr val="tx1"/>
-                </a:solidFill>
-                <a:latin typeface="+mj-lt"/>
-              </a:endParaRPr>
-            </a:p>
-          </p:txBody>
-        </p:sp>
-        <p:sp>
-          <p:nvSpPr>
-            <p:cNvPr id="30" name="Rectangle 42">
-              <a:extLst>
-                <a:ext uri="{FF2B5EF4-FFF2-40B4-BE49-F238E27FC236}">
-                  <a16:creationId xmlns:a16="http://schemas.microsoft.com/office/drawing/2014/main" id="{66F9516B-8552-CDAF-75C4-8A281C36B6F8}"/>
-                </a:ext>
-              </a:extLst>
-            </p:cNvPr>
-            <p:cNvSpPr/>
-            <p:nvPr/>
-          </p:nvSpPr>
-          <p:spPr>
-            <a:xfrm>
-              <a:off x="7351101" y="1959390"/>
-              <a:ext cx="557171" cy="697758"/>
-            </a:xfrm>
-            <a:prstGeom prst="rect">
-              <a:avLst/>
-            </a:prstGeom>
-            <a:solidFill>
-              <a:schemeClr val="bg1"/>
-            </a:solidFill>
-            <a:ln>
-              <a:noFill/>
-            </a:ln>
-          </p:spPr>
-          <p:style>
-            <a:lnRef idx="2">
-              <a:schemeClr val="accent1">
-                <a:shade val="15000"/>
-              </a:schemeClr>
-            </a:lnRef>
-            <a:fillRef idx="1">
-              <a:schemeClr val="accent1"/>
-            </a:fillRef>
-            <a:effectRef idx="0">
-              <a:schemeClr val="accent1"/>
-            </a:effectRef>
-            <a:fontRef idx="minor">
-              <a:schemeClr val="lt1"/>
-            </a:fontRef>
-          </p:style>
-          <p:txBody>
-            <a:bodyPr rtlCol="0" anchor="ctr"/>
-            <a:lstStyle/>
-            <a:p>
-              <a:pPr algn="ctr"/>
-              <a:r>
-                <a:rPr lang="nl-NL" sz="1100" dirty="0">
-                  <a:solidFill>
-                    <a:schemeClr val="tx1"/>
-                  </a:solidFill>
-                  <a:latin typeface="+mj-lt"/>
-                </a:rPr>
-                <a:t>BU 3</a:t>
-              </a:r>
-              <a:endParaRPr lang="LID4096" sz="1100" dirty="0">
-                <a:solidFill>
-                  <a:schemeClr val="tx1"/>
-                </a:solidFill>
-                <a:latin typeface="+mj-lt"/>
-              </a:endParaRPr>
-            </a:p>
-          </p:txBody>
-        </p:sp>
-        <p:sp>
-          <p:nvSpPr>
-            <p:cNvPr id="32" name="Rectangle 43">
-              <a:extLst>
-                <a:ext uri="{FF2B5EF4-FFF2-40B4-BE49-F238E27FC236}">
-                  <a16:creationId xmlns:a16="http://schemas.microsoft.com/office/drawing/2014/main" id="{005EA54E-A05B-E9A5-FE26-09518F608969}"/>
-                </a:ext>
-              </a:extLst>
-            </p:cNvPr>
-            <p:cNvSpPr/>
-            <p:nvPr/>
-          </p:nvSpPr>
-          <p:spPr>
-            <a:xfrm>
-              <a:off x="7982046" y="1959390"/>
-              <a:ext cx="557171" cy="697758"/>
-            </a:xfrm>
-            <a:prstGeom prst="rect">
-              <a:avLst/>
-            </a:prstGeom>
-            <a:solidFill>
-              <a:schemeClr val="bg1"/>
-            </a:solidFill>
-            <a:ln>
-              <a:noFill/>
-            </a:ln>
-          </p:spPr>
-          <p:style>
-            <a:lnRef idx="2">
-              <a:schemeClr val="accent1">
-                <a:shade val="15000"/>
-              </a:schemeClr>
-            </a:lnRef>
-            <a:fillRef idx="1">
-              <a:schemeClr val="accent1"/>
-            </a:fillRef>
-            <a:effectRef idx="0">
-              <a:schemeClr val="accent1"/>
-            </a:effectRef>
-            <a:fontRef idx="minor">
-              <a:schemeClr val="lt1"/>
-            </a:fontRef>
-          </p:style>
-          <p:txBody>
-            <a:bodyPr rtlCol="0" anchor="ctr"/>
-            <a:lstStyle/>
-            <a:p>
-              <a:pPr algn="ctr"/>
-              <a:r>
-                <a:rPr lang="nl-NL" sz="1100" dirty="0">
-                  <a:solidFill>
-                    <a:schemeClr val="tx1"/>
-                  </a:solidFill>
-                  <a:latin typeface="+mj-lt"/>
-                </a:rPr>
-                <a:t>BU 4</a:t>
-              </a:r>
-              <a:endParaRPr lang="LID4096" sz="1100" dirty="0">
-                <a:solidFill>
-                  <a:schemeClr val="tx1"/>
-                </a:solidFill>
-                <a:latin typeface="+mj-lt"/>
-              </a:endParaRPr>
-            </a:p>
-          </p:txBody>
-        </p:sp>
       </p:grpSp>
       <p:grpSp>
         <p:nvGrpSpPr>
@@ -6028,7 +6448,7 @@
                 </a:pPr>
                 <a:r>
                   <a:rPr lang="en-US" sz="1200" b="1" dirty="0">
-                    <a:latin typeface="+mj-lt"/>
+                    <a:latin typeface="DM Sans" pitchFamily="2" charset="0"/>
                   </a:rPr>
                   <a:t>Value</a:t>
                 </a:r>
@@ -6147,7 +6567,7 @@
                 </a:pPr>
                 <a:r>
                   <a:rPr lang="en-US" sz="1200" b="1" dirty="0">
-                    <a:latin typeface="+mj-lt"/>
+                    <a:latin typeface="DM Sans" pitchFamily="2" charset="0"/>
                   </a:rPr>
                   <a:t>Capabilities</a:t>
                 </a:r>
@@ -6266,7 +6686,7 @@
                 </a:pPr>
                 <a:r>
                   <a:rPr lang="en-US" sz="1200" b="1" dirty="0">
-                    <a:latin typeface="+mj-lt"/>
+                    <a:latin typeface="DM Sans" pitchFamily="2" charset="0"/>
                   </a:rPr>
                   <a:t>Trust</a:t>
                 </a:r>
@@ -6281,7 +6701,417 @@
     </p:spTree>
     <p:extLst>
       <p:ext uri="{BB962C8B-B14F-4D97-AF65-F5344CB8AC3E}">
-        <p14:creationId xmlns:p14="http://schemas.microsoft.com/office/powerpoint/2010/main" val="3155234622"/>
+        <p14:creationId xmlns:p14="http://schemas.microsoft.com/office/powerpoint/2010/main" val="3418198643"/>
+      </p:ext>
+    </p:extLst>
+  </p:cSld>
+  <p:clrMapOvr>
+    <a:masterClrMapping/>
+  </p:clrMapOvr>
+</p:sld>
+</file>
+
+<file path=ppt/slides/slide3.xml><?xml version="1.0" encoding="utf-8"?>
+<p:sld xmlns:a="http://schemas.openxmlformats.org/drawingml/2006/main" xmlns:r="http://schemas.openxmlformats.org/officeDocument/2006/relationships" xmlns:p="http://schemas.openxmlformats.org/presentationml/2006/main">
+  <p:cSld>
+    <p:spTree>
+      <p:nvGrpSpPr>
+        <p:cNvPr id="1" name="">
+          <a:extLst>
+            <a:ext uri="{FF2B5EF4-FFF2-40B4-BE49-F238E27FC236}">
+              <a16:creationId xmlns:a16="http://schemas.microsoft.com/office/drawing/2014/main" id="{43EB92B7-EBBB-29B1-D2DF-A9F3C5FCA28C}"/>
+            </a:ext>
+          </a:extLst>
+        </p:cNvPr>
+        <p:cNvGrpSpPr/>
+        <p:nvPr/>
+      </p:nvGrpSpPr>
+      <p:grpSpPr>
+        <a:xfrm>
+          <a:off x="0" y="0"/>
+          <a:ext cx="0" cy="0"/>
+          <a:chOff x="0" y="0"/>
+          <a:chExt cx="0" cy="0"/>
+        </a:xfrm>
+      </p:grpSpPr>
+      <p:sp>
+        <p:nvSpPr>
+          <p:cNvPr id="9" name="Rechthoek 8">
+            <a:extLst>
+              <a:ext uri="{FF2B5EF4-FFF2-40B4-BE49-F238E27FC236}">
+                <a16:creationId xmlns:a16="http://schemas.microsoft.com/office/drawing/2014/main" id="{CC84EF3A-5EB3-5F47-BFEE-826AAB71E932}"/>
+              </a:ext>
+            </a:extLst>
+          </p:cNvPr>
+          <p:cNvSpPr/>
+          <p:nvPr/>
+        </p:nvSpPr>
+        <p:spPr>
+          <a:xfrm>
+            <a:off x="2293749" y="1363851"/>
+            <a:ext cx="3802251" cy="4339525"/>
+          </a:xfrm>
+          <a:prstGeom prst="rect">
+            <a:avLst/>
+          </a:prstGeom>
+          <a:solidFill>
+            <a:schemeClr val="bg1"/>
+          </a:solidFill>
+        </p:spPr>
+        <p:style>
+          <a:lnRef idx="2">
+            <a:schemeClr val="accent1">
+              <a:shade val="15000"/>
+            </a:schemeClr>
+          </a:lnRef>
+          <a:fillRef idx="1">
+            <a:schemeClr val="accent1"/>
+          </a:fillRef>
+          <a:effectRef idx="0">
+            <a:schemeClr val="accent1"/>
+          </a:effectRef>
+          <a:fontRef idx="minor">
+            <a:schemeClr val="lt1"/>
+          </a:fontRef>
+        </p:style>
+        <p:txBody>
+          <a:bodyPr rtlCol="0" anchor="ctr"/>
+          <a:lstStyle/>
+          <a:p>
+            <a:pPr algn="ctr"/>
+            <a:endParaRPr lang="en-GB"/>
+          </a:p>
+        </p:txBody>
+      </p:sp>
+      <p:sp>
+        <p:nvSpPr>
+          <p:cNvPr id="15" name="Rechthoek 14">
+            <a:extLst>
+              <a:ext uri="{FF2B5EF4-FFF2-40B4-BE49-F238E27FC236}">
+                <a16:creationId xmlns:a16="http://schemas.microsoft.com/office/drawing/2014/main" id="{DDABBDDD-55CB-C8EF-4B10-3E83B9F407D5}"/>
+              </a:ext>
+            </a:extLst>
+          </p:cNvPr>
+          <p:cNvSpPr/>
+          <p:nvPr/>
+        </p:nvSpPr>
+        <p:spPr>
+          <a:xfrm>
+            <a:off x="2293749" y="2060575"/>
+            <a:ext cx="3802251" cy="1486847"/>
+          </a:xfrm>
+          <a:prstGeom prst="rect">
+            <a:avLst/>
+          </a:prstGeom>
+        </p:spPr>
+        <p:style>
+          <a:lnRef idx="2">
+            <a:schemeClr val="accent1">
+              <a:shade val="15000"/>
+            </a:schemeClr>
+          </a:lnRef>
+          <a:fillRef idx="1">
+            <a:schemeClr val="accent1"/>
+          </a:fillRef>
+          <a:effectRef idx="0">
+            <a:schemeClr val="accent1"/>
+          </a:effectRef>
+          <a:fontRef idx="minor">
+            <a:schemeClr val="lt1"/>
+          </a:fontRef>
+        </p:style>
+        <p:txBody>
+          <a:bodyPr rtlCol="0" anchor="ctr"/>
+          <a:lstStyle/>
+          <a:p>
+            <a:pPr algn="ctr"/>
+            <a:endParaRPr lang="en-GB"/>
+          </a:p>
+        </p:txBody>
+      </p:sp>
+      <p:sp>
+        <p:nvSpPr>
+          <p:cNvPr id="16" name="Rechthoek 15">
+            <a:extLst>
+              <a:ext uri="{FF2B5EF4-FFF2-40B4-BE49-F238E27FC236}">
+                <a16:creationId xmlns:a16="http://schemas.microsoft.com/office/drawing/2014/main" id="{AA37D329-A903-3766-3C06-CB0CED2DA033}"/>
+              </a:ext>
+            </a:extLst>
+          </p:cNvPr>
+          <p:cNvSpPr/>
+          <p:nvPr/>
+        </p:nvSpPr>
+        <p:spPr>
+          <a:xfrm>
+            <a:off x="2293749" y="5145437"/>
+            <a:ext cx="3802251" cy="557939"/>
+          </a:xfrm>
+          <a:prstGeom prst="rect">
+            <a:avLst/>
+          </a:prstGeom>
+        </p:spPr>
+        <p:style>
+          <a:lnRef idx="2">
+            <a:schemeClr val="accent1">
+              <a:shade val="15000"/>
+            </a:schemeClr>
+          </a:lnRef>
+          <a:fillRef idx="1">
+            <a:schemeClr val="accent1"/>
+          </a:fillRef>
+          <a:effectRef idx="0">
+            <a:schemeClr val="accent1"/>
+          </a:effectRef>
+          <a:fontRef idx="minor">
+            <a:schemeClr val="lt1"/>
+          </a:fontRef>
+        </p:style>
+        <p:txBody>
+          <a:bodyPr rtlCol="0" anchor="ctr"/>
+          <a:lstStyle/>
+          <a:p>
+            <a:pPr algn="ctr"/>
+            <a:endParaRPr lang="en-GB"/>
+          </a:p>
+        </p:txBody>
+      </p:sp>
+      <p:sp>
+        <p:nvSpPr>
+          <p:cNvPr id="3" name="Title 2">
+            <a:extLst>
+              <a:ext uri="{FF2B5EF4-FFF2-40B4-BE49-F238E27FC236}">
+                <a16:creationId xmlns:a16="http://schemas.microsoft.com/office/drawing/2014/main" id="{3435802E-CA5A-8ED3-1E31-A1B56D91934B}"/>
+              </a:ext>
+            </a:extLst>
+          </p:cNvPr>
+          <p:cNvSpPr>
+            <a:spLocks noGrp="1"/>
+          </p:cNvSpPr>
+          <p:nvPr>
+            <p:ph type="title"/>
+          </p:nvPr>
+        </p:nvSpPr>
+        <p:spPr/>
+        <p:txBody>
+          <a:bodyPr>
+            <a:normAutofit/>
+          </a:bodyPr>
+          <a:lstStyle/>
+          <a:p>
+            <a:r>
+              <a:rPr lang="en-US" dirty="0"/>
+              <a:t>Book cover</a:t>
+            </a:r>
+          </a:p>
+        </p:txBody>
+      </p:sp>
+      <p:sp>
+        <p:nvSpPr>
+          <p:cNvPr id="4" name="Text Placeholder 3">
+            <a:extLst>
+              <a:ext uri="{FF2B5EF4-FFF2-40B4-BE49-F238E27FC236}">
+                <a16:creationId xmlns:a16="http://schemas.microsoft.com/office/drawing/2014/main" id="{FB27AA5F-D60F-AD07-0D15-90F766B21BF7}"/>
+              </a:ext>
+            </a:extLst>
+          </p:cNvPr>
+          <p:cNvSpPr>
+            <a:spLocks noGrp="1"/>
+          </p:cNvSpPr>
+          <p:nvPr>
+            <p:ph type="body" sz="quarter" idx="10"/>
+          </p:nvPr>
+        </p:nvSpPr>
+        <p:spPr/>
+        <p:txBody>
+          <a:bodyPr/>
+          <a:lstStyle/>
+          <a:p>
+            <a:r>
+              <a:rPr lang="en-US" dirty="0"/>
+              <a:t>The Agentic </a:t>
+            </a:r>
+            <a:r>
+              <a:rPr lang="en-US" dirty="0" err="1"/>
+              <a:t>Organisation</a:t>
+            </a:r>
+            <a:endParaRPr lang="en-US" dirty="0"/>
+          </a:p>
+        </p:txBody>
+      </p:sp>
+      <p:sp>
+        <p:nvSpPr>
+          <p:cNvPr id="11" name="Tekstvak 10">
+            <a:extLst>
+              <a:ext uri="{FF2B5EF4-FFF2-40B4-BE49-F238E27FC236}">
+                <a16:creationId xmlns:a16="http://schemas.microsoft.com/office/drawing/2014/main" id="{CC95AE2B-BF3B-3A3F-5485-0A7F2025FD71}"/>
+              </a:ext>
+            </a:extLst>
+          </p:cNvPr>
+          <p:cNvSpPr txBox="1"/>
+          <p:nvPr/>
+        </p:nvSpPr>
+        <p:spPr>
+          <a:xfrm>
+            <a:off x="3555917" y="5301295"/>
+            <a:ext cx="1277914" cy="246221"/>
+          </a:xfrm>
+          <a:prstGeom prst="rect">
+            <a:avLst/>
+          </a:prstGeom>
+          <a:noFill/>
+          <a:effectLst>
+            <a:outerShdw blurRad="12700" dist="12700" dir="2700000" algn="tl" rotWithShape="0">
+              <a:prstClr val="black">
+                <a:alpha val="16000"/>
+              </a:prstClr>
+            </a:outerShdw>
+          </a:effectLst>
+        </p:spPr>
+        <p:txBody>
+          <a:bodyPr wrap="none" rtlCol="0">
+            <a:spAutoFit/>
+          </a:bodyPr>
+          <a:lstStyle/>
+          <a:p>
+            <a:pPr algn="ctr"/>
+            <a:r>
+              <a:rPr lang="en-GB" sz="1000" dirty="0">
+                <a:latin typeface="Garamond" panose="02020404030301010803" pitchFamily="18" charset="0"/>
+              </a:rPr>
+              <a:t>Stephan Hartgers-Rus</a:t>
+            </a:r>
+          </a:p>
+        </p:txBody>
+      </p:sp>
+      <p:pic>
+        <p:nvPicPr>
+          <p:cNvPr id="20" name="Afbeelding 19" descr="Afbeelding met schoeisel, kleding, person, persoon&#10;&#10;Door AI gegenereerde inhoud is mogelijk onjuist.">
+            <a:extLst>
+              <a:ext uri="{FF2B5EF4-FFF2-40B4-BE49-F238E27FC236}">
+                <a16:creationId xmlns:a16="http://schemas.microsoft.com/office/drawing/2014/main" id="{131CC11A-5448-A817-E1C6-68413F845848}"/>
+              </a:ext>
+            </a:extLst>
+          </p:cNvPr>
+          <p:cNvPicPr>
+            <a:picLocks noChangeAspect="1"/>
+          </p:cNvPicPr>
+          <p:nvPr/>
+        </p:nvPicPr>
+        <p:blipFill>
+          <a:blip r:embed="rId3">
+            <a:extLst>
+              <a:ext uri="{28A0092B-C50C-407E-A947-70E740481C1C}">
+                <a14:useLocalDpi xmlns:a14="http://schemas.microsoft.com/office/drawing/2010/main" val="0"/>
+              </a:ext>
+            </a:extLst>
+          </a:blip>
+          <a:stretch>
+            <a:fillRect/>
+          </a:stretch>
+        </p:blipFill>
+        <p:spPr>
+          <a:xfrm>
+            <a:off x="6601654" y="1363851"/>
+            <a:ext cx="2903284" cy="4354926"/>
+          </a:xfrm>
+          <a:prstGeom prst="rect">
+            <a:avLst/>
+          </a:prstGeom>
+        </p:spPr>
+      </p:pic>
+      <p:sp>
+        <p:nvSpPr>
+          <p:cNvPr id="6" name="Tekstvak 5">
+            <a:extLst>
+              <a:ext uri="{FF2B5EF4-FFF2-40B4-BE49-F238E27FC236}">
+                <a16:creationId xmlns:a16="http://schemas.microsoft.com/office/drawing/2014/main" id="{011CADC5-0494-041A-23A1-8C77774988E9}"/>
+              </a:ext>
+            </a:extLst>
+          </p:cNvPr>
+          <p:cNvSpPr txBox="1"/>
+          <p:nvPr/>
+        </p:nvSpPr>
+        <p:spPr>
+          <a:xfrm>
+            <a:off x="6728976" y="1488311"/>
+            <a:ext cx="2648640" cy="819263"/>
+          </a:xfrm>
+          <a:prstGeom prst="rect">
+            <a:avLst/>
+          </a:prstGeom>
+          <a:noFill/>
+          <a:effectLst/>
+        </p:spPr>
+        <p:txBody>
+          <a:bodyPr wrap="square" rtlCol="0">
+            <a:spAutoFit/>
+          </a:bodyPr>
+          <a:lstStyle/>
+          <a:p>
+            <a:pPr algn="ctr">
+              <a:lnSpc>
+                <a:spcPts val="2900"/>
+              </a:lnSpc>
+            </a:pPr>
+            <a:r>
+              <a:rPr lang="en-GB" sz="2400" b="1" dirty="0">
+                <a:solidFill>
+                  <a:srgbClr val="4B5B6B"/>
+                </a:solidFill>
+                <a:latin typeface="Avenir Next LT Pro" panose="020B0504020202020204" pitchFamily="34" charset="0"/>
+              </a:rPr>
+              <a:t>THE AGENTIC ORGANISATION</a:t>
+            </a:r>
+          </a:p>
+        </p:txBody>
+      </p:sp>
+      <p:sp>
+        <p:nvSpPr>
+          <p:cNvPr id="7" name="Tekstvak 6">
+            <a:extLst>
+              <a:ext uri="{FF2B5EF4-FFF2-40B4-BE49-F238E27FC236}">
+                <a16:creationId xmlns:a16="http://schemas.microsoft.com/office/drawing/2014/main" id="{2DE3A319-CEAC-921D-D6E0-4F2919039E15}"/>
+              </a:ext>
+            </a:extLst>
+          </p:cNvPr>
+          <p:cNvSpPr txBox="1"/>
+          <p:nvPr/>
+        </p:nvSpPr>
+        <p:spPr>
+          <a:xfrm>
+            <a:off x="6615806" y="2226798"/>
+            <a:ext cx="2874980" cy="369332"/>
+          </a:xfrm>
+          <a:prstGeom prst="rect">
+            <a:avLst/>
+          </a:prstGeom>
+          <a:noFill/>
+          <a:effectLst/>
+        </p:spPr>
+        <p:txBody>
+          <a:bodyPr wrap="square" rtlCol="0">
+            <a:spAutoFit/>
+          </a:bodyPr>
+          <a:lstStyle/>
+          <a:p>
+            <a:pPr algn="ctr"/>
+            <a:r>
+              <a:rPr lang="en-GB" sz="900" dirty="0">
+                <a:solidFill>
+                  <a:srgbClr val="4B5B6B"/>
+                </a:solidFill>
+                <a:latin typeface="Avenir Next LT Pro Demi" panose="020B0704020202020204" pitchFamily="34" charset="0"/>
+                <a:cs typeface="Segoe UI" panose="020B0502040204020203" pitchFamily="34" charset="0"/>
+              </a:rPr>
+              <a:t>A TRANSFORMATION FRAMEWORK FOR EUROPEAN COMPANIES</a:t>
+            </a:r>
+          </a:p>
+        </p:txBody>
+      </p:sp>
+    </p:spTree>
+    <p:extLst>
+      <p:ext uri="{BB962C8B-B14F-4D97-AF65-F5344CB8AC3E}">
+        <p14:creationId xmlns:p14="http://schemas.microsoft.com/office/powerpoint/2010/main" val="2876593574"/>
       </p:ext>
     </p:extLst>
   </p:cSld>

</xml_diff>

<commit_message>
Created chapters 5-9 full
</commit_message>
<xml_diff>
--- a/input/AI Transformation framework for European CEO’s.pptx
+++ b/input/AI Transformation framework for European CEO’s.pptx
@@ -6736,214 +6736,155 @@
       </p:grpSpPr>
       <p:sp>
         <p:nvSpPr>
-          <p:cNvPr id="9" name="Rechthoek 8">
-            <a:extLst>
-              <a:ext uri="{FF2B5EF4-FFF2-40B4-BE49-F238E27FC236}">
-                <a16:creationId xmlns:a16="http://schemas.microsoft.com/office/drawing/2014/main" id="{CC84EF3A-5EB3-5F47-BFEE-826AAB71E932}"/>
-              </a:ext>
-            </a:extLst>
-          </p:cNvPr>
-          <p:cNvSpPr/>
+          <p:cNvPr id="3" name="Title 2">
+            <a:extLst>
+              <a:ext uri="{FF2B5EF4-FFF2-40B4-BE49-F238E27FC236}">
+                <a16:creationId xmlns:a16="http://schemas.microsoft.com/office/drawing/2014/main" id="{3435802E-CA5A-8ED3-1E31-A1B56D91934B}"/>
+              </a:ext>
+            </a:extLst>
+          </p:cNvPr>
+          <p:cNvSpPr>
+            <a:spLocks noGrp="1"/>
+          </p:cNvSpPr>
+          <p:nvPr>
+            <p:ph type="title"/>
+          </p:nvPr>
+        </p:nvSpPr>
+        <p:spPr/>
+        <p:txBody>
+          <a:bodyPr>
+            <a:normAutofit/>
+          </a:bodyPr>
+          <a:lstStyle/>
+          <a:p>
+            <a:r>
+              <a:rPr lang="en-US" dirty="0"/>
+              <a:t>Book cover</a:t>
+            </a:r>
+          </a:p>
+        </p:txBody>
+      </p:sp>
+      <p:sp>
+        <p:nvSpPr>
+          <p:cNvPr id="4" name="Text Placeholder 3">
+            <a:extLst>
+              <a:ext uri="{FF2B5EF4-FFF2-40B4-BE49-F238E27FC236}">
+                <a16:creationId xmlns:a16="http://schemas.microsoft.com/office/drawing/2014/main" id="{FB27AA5F-D60F-AD07-0D15-90F766B21BF7}"/>
+              </a:ext>
+            </a:extLst>
+          </p:cNvPr>
+          <p:cNvSpPr>
+            <a:spLocks noGrp="1"/>
+          </p:cNvSpPr>
+          <p:nvPr>
+            <p:ph type="body" sz="quarter" idx="10"/>
+          </p:nvPr>
+        </p:nvSpPr>
+        <p:spPr/>
+        <p:txBody>
+          <a:bodyPr/>
+          <a:lstStyle/>
+          <a:p>
+            <a:r>
+              <a:rPr lang="en-US" dirty="0"/>
+              <a:t>The Agentic </a:t>
+            </a:r>
+            <a:r>
+              <a:rPr lang="en-US" dirty="0" err="1"/>
+              <a:t>Organisation</a:t>
+            </a:r>
+            <a:endParaRPr lang="en-US" dirty="0"/>
+          </a:p>
+        </p:txBody>
+      </p:sp>
+      <p:pic>
+        <p:nvPicPr>
+          <p:cNvPr id="20" name="Afbeelding 19" descr="Afbeelding met schoeisel, kleding, person, persoon&#10;&#10;Door AI gegenereerde inhoud is mogelijk onjuist.">
+            <a:extLst>
+              <a:ext uri="{FF2B5EF4-FFF2-40B4-BE49-F238E27FC236}">
+                <a16:creationId xmlns:a16="http://schemas.microsoft.com/office/drawing/2014/main" id="{131CC11A-5448-A817-E1C6-68413F845848}"/>
+              </a:ext>
+            </a:extLst>
+          </p:cNvPr>
+          <p:cNvPicPr>
+            <a:picLocks noChangeAspect="1"/>
+          </p:cNvPicPr>
           <p:nvPr/>
-        </p:nvSpPr>
+        </p:nvPicPr>
+        <p:blipFill>
+          <a:blip r:embed="rId3">
+            <a:extLst>
+              <a:ext uri="{28A0092B-C50C-407E-A947-70E740481C1C}">
+                <a14:useLocalDpi xmlns:a14="http://schemas.microsoft.com/office/drawing/2010/main" val="0"/>
+              </a:ext>
+            </a:extLst>
+          </a:blip>
+          <a:stretch>
+            <a:fillRect/>
+          </a:stretch>
+        </p:blipFill>
         <p:spPr>
           <a:xfrm>
-            <a:off x="2293749" y="1363851"/>
-            <a:ext cx="3802251" cy="4339525"/>
-          </a:xfrm>
-          <a:prstGeom prst="rect">
-            <a:avLst/>
-          </a:prstGeom>
-          <a:solidFill>
-            <a:schemeClr val="bg1"/>
-          </a:solidFill>
-        </p:spPr>
-        <p:style>
-          <a:lnRef idx="2">
-            <a:schemeClr val="accent1">
-              <a:shade val="15000"/>
-            </a:schemeClr>
-          </a:lnRef>
-          <a:fillRef idx="1">
-            <a:schemeClr val="accent1"/>
-          </a:fillRef>
-          <a:effectRef idx="0">
-            <a:schemeClr val="accent1"/>
-          </a:effectRef>
-          <a:fontRef idx="minor">
-            <a:schemeClr val="lt1"/>
-          </a:fontRef>
-        </p:style>
-        <p:txBody>
-          <a:bodyPr rtlCol="0" anchor="ctr"/>
-          <a:lstStyle/>
-          <a:p>
-            <a:pPr algn="ctr"/>
-            <a:endParaRPr lang="en-GB"/>
-          </a:p>
-        </p:txBody>
-      </p:sp>
-      <p:sp>
-        <p:nvSpPr>
-          <p:cNvPr id="15" name="Rechthoek 14">
-            <a:extLst>
-              <a:ext uri="{FF2B5EF4-FFF2-40B4-BE49-F238E27FC236}">
-                <a16:creationId xmlns:a16="http://schemas.microsoft.com/office/drawing/2014/main" id="{DDABBDDD-55CB-C8EF-4B10-3E83B9F407D5}"/>
-              </a:ext>
-            </a:extLst>
-          </p:cNvPr>
-          <p:cNvSpPr/>
-          <p:nvPr/>
-        </p:nvSpPr>
-        <p:spPr>
-          <a:xfrm>
-            <a:off x="2293749" y="2060575"/>
-            <a:ext cx="3802251" cy="1486847"/>
+            <a:off x="490538" y="1363851"/>
+            <a:ext cx="2903284" cy="4354926"/>
           </a:xfrm>
           <a:prstGeom prst="rect">
             <a:avLst/>
           </a:prstGeom>
         </p:spPr>
-        <p:style>
-          <a:lnRef idx="2">
-            <a:schemeClr val="accent1">
-              <a:shade val="15000"/>
-            </a:schemeClr>
-          </a:lnRef>
-          <a:fillRef idx="1">
-            <a:schemeClr val="accent1"/>
-          </a:fillRef>
-          <a:effectRef idx="0">
-            <a:schemeClr val="accent1"/>
-          </a:effectRef>
-          <a:fontRef idx="minor">
-            <a:schemeClr val="lt1"/>
-          </a:fontRef>
-        </p:style>
-        <p:txBody>
-          <a:bodyPr rtlCol="0" anchor="ctr"/>
-          <a:lstStyle/>
-          <a:p>
-            <a:pPr algn="ctr"/>
-            <a:endParaRPr lang="en-GB"/>
-          </a:p>
-        </p:txBody>
-      </p:sp>
-      <p:sp>
-        <p:nvSpPr>
-          <p:cNvPr id="16" name="Rechthoek 15">
-            <a:extLst>
-              <a:ext uri="{FF2B5EF4-FFF2-40B4-BE49-F238E27FC236}">
-                <a16:creationId xmlns:a16="http://schemas.microsoft.com/office/drawing/2014/main" id="{AA37D329-A903-3766-3C06-CB0CED2DA033}"/>
-              </a:ext>
-            </a:extLst>
-          </p:cNvPr>
-          <p:cNvSpPr/>
+      </p:pic>
+      <p:sp>
+        <p:nvSpPr>
+          <p:cNvPr id="6" name="Tekstvak 5">
+            <a:extLst>
+              <a:ext uri="{FF2B5EF4-FFF2-40B4-BE49-F238E27FC236}">
+                <a16:creationId xmlns:a16="http://schemas.microsoft.com/office/drawing/2014/main" id="{011CADC5-0494-041A-23A1-8C77774988E9}"/>
+              </a:ext>
+            </a:extLst>
+          </p:cNvPr>
+          <p:cNvSpPr txBox="1"/>
           <p:nvPr/>
         </p:nvSpPr>
         <p:spPr>
           <a:xfrm>
-            <a:off x="2293749" y="5145437"/>
-            <a:ext cx="3802251" cy="557939"/>
+            <a:off x="504690" y="1450211"/>
+            <a:ext cx="2874980" cy="819199"/>
           </a:xfrm>
           <a:prstGeom prst="rect">
             <a:avLst/>
           </a:prstGeom>
+          <a:noFill/>
+          <a:effectLst/>
         </p:spPr>
-        <p:style>
-          <a:lnRef idx="2">
-            <a:schemeClr val="accent1">
-              <a:shade val="15000"/>
-            </a:schemeClr>
-          </a:lnRef>
-          <a:fillRef idx="1">
-            <a:schemeClr val="accent1"/>
-          </a:fillRef>
-          <a:effectRef idx="0">
-            <a:schemeClr val="accent1"/>
-          </a:effectRef>
-          <a:fontRef idx="minor">
-            <a:schemeClr val="lt1"/>
-          </a:fontRef>
-        </p:style>
-        <p:txBody>
-          <a:bodyPr rtlCol="0" anchor="ctr"/>
-          <a:lstStyle/>
-          <a:p>
-            <a:pPr algn="ctr"/>
-            <a:endParaRPr lang="en-GB"/>
-          </a:p>
-        </p:txBody>
-      </p:sp>
-      <p:sp>
-        <p:nvSpPr>
-          <p:cNvPr id="3" name="Title 2">
-            <a:extLst>
-              <a:ext uri="{FF2B5EF4-FFF2-40B4-BE49-F238E27FC236}">
-                <a16:creationId xmlns:a16="http://schemas.microsoft.com/office/drawing/2014/main" id="{3435802E-CA5A-8ED3-1E31-A1B56D91934B}"/>
-              </a:ext>
-            </a:extLst>
-          </p:cNvPr>
-          <p:cNvSpPr>
-            <a:spLocks noGrp="1"/>
-          </p:cNvSpPr>
-          <p:nvPr>
-            <p:ph type="title"/>
-          </p:nvPr>
-        </p:nvSpPr>
-        <p:spPr/>
-        <p:txBody>
-          <a:bodyPr>
-            <a:normAutofit/>
+        <p:txBody>
+          <a:bodyPr wrap="square" rtlCol="0">
+            <a:spAutoFit/>
           </a:bodyPr>
           <a:lstStyle/>
           <a:p>
-            <a:r>
-              <a:rPr lang="en-US" dirty="0"/>
-              <a:t>Book cover</a:t>
-            </a:r>
-          </a:p>
-        </p:txBody>
-      </p:sp>
-      <p:sp>
-        <p:nvSpPr>
-          <p:cNvPr id="4" name="Text Placeholder 3">
-            <a:extLst>
-              <a:ext uri="{FF2B5EF4-FFF2-40B4-BE49-F238E27FC236}">
-                <a16:creationId xmlns:a16="http://schemas.microsoft.com/office/drawing/2014/main" id="{FB27AA5F-D60F-AD07-0D15-90F766B21BF7}"/>
-              </a:ext>
-            </a:extLst>
-          </p:cNvPr>
-          <p:cNvSpPr>
-            <a:spLocks noGrp="1"/>
-          </p:cNvSpPr>
-          <p:nvPr>
-            <p:ph type="body" sz="quarter" idx="10"/>
-          </p:nvPr>
-        </p:nvSpPr>
-        <p:spPr/>
-        <p:txBody>
-          <a:bodyPr/>
-          <a:lstStyle/>
-          <a:p>
-            <a:r>
-              <a:rPr lang="en-US" dirty="0"/>
-              <a:t>The Agentic </a:t>
-            </a:r>
-            <a:r>
-              <a:rPr lang="en-US" dirty="0" err="1"/>
-              <a:t>Organisation</a:t>
-            </a:r>
-            <a:endParaRPr lang="en-US" dirty="0"/>
-          </a:p>
-        </p:txBody>
-      </p:sp>
-      <p:sp>
-        <p:nvSpPr>
-          <p:cNvPr id="11" name="Tekstvak 10">
-            <a:extLst>
-              <a:ext uri="{FF2B5EF4-FFF2-40B4-BE49-F238E27FC236}">
-                <a16:creationId xmlns:a16="http://schemas.microsoft.com/office/drawing/2014/main" id="{CC95AE2B-BF3B-3A3F-5485-0A7F2025FD71}"/>
+            <a:pPr algn="ctr">
+              <a:lnSpc>
+                <a:spcPts val="2900"/>
+              </a:lnSpc>
+            </a:pPr>
+            <a:r>
+              <a:rPr lang="en-GB" sz="2400" b="1" dirty="0">
+                <a:solidFill>
+                  <a:srgbClr val="4B5B6B"/>
+                </a:solidFill>
+                <a:latin typeface="Montserrat" pitchFamily="2" charset="0"/>
+              </a:rPr>
+              <a:t>THE AGENTIC ORGANISATION</a:t>
+            </a:r>
+          </a:p>
+        </p:txBody>
+      </p:sp>
+      <p:sp>
+        <p:nvSpPr>
+          <p:cNvPr id="7" name="Tekstvak 6">
+            <a:extLst>
+              <a:ext uri="{FF2B5EF4-FFF2-40B4-BE49-F238E27FC236}">
+                <a16:creationId xmlns:a16="http://schemas.microsoft.com/office/drawing/2014/main" id="{2DE3A319-CEAC-921D-D6E0-4F2919039E15}"/>
               </a:ext>
             </a:extLst>
           </p:cNvPr>
@@ -6952,7 +6893,69 @@
         </p:nvSpPr>
         <p:spPr>
           <a:xfrm>
-            <a:off x="3555917" y="5301295"/>
+            <a:off x="504690" y="2173458"/>
+            <a:ext cx="2874980" cy="338554"/>
+          </a:xfrm>
+          <a:prstGeom prst="rect">
+            <a:avLst/>
+          </a:prstGeom>
+          <a:noFill/>
+          <a:effectLst/>
+        </p:spPr>
+        <p:txBody>
+          <a:bodyPr wrap="square" rtlCol="0">
+            <a:spAutoFit/>
+          </a:bodyPr>
+          <a:lstStyle/>
+          <a:p>
+            <a:pPr algn="ctr"/>
+            <a:r>
+              <a:rPr lang="en-GB" sz="800" dirty="0">
+                <a:solidFill>
+                  <a:srgbClr val="4B5B6B"/>
+                </a:solidFill>
+                <a:latin typeface="Montserrat" pitchFamily="2" charset="0"/>
+                <a:cs typeface="Segoe UI" panose="020B0502040204020203" pitchFamily="34" charset="0"/>
+              </a:rPr>
+              <a:t>A complete AI transformation </a:t>
+            </a:r>
+            <a:br>
+              <a:rPr lang="en-GB" sz="800" dirty="0">
+                <a:solidFill>
+                  <a:srgbClr val="4B5B6B"/>
+                </a:solidFill>
+                <a:latin typeface="Montserrat" pitchFamily="2" charset="0"/>
+                <a:cs typeface="Segoe UI" panose="020B0502040204020203" pitchFamily="34" charset="0"/>
+              </a:rPr>
+            </a:br>
+            <a:r>
+              <a:rPr lang="en-GB" sz="800" dirty="0">
+                <a:solidFill>
+                  <a:srgbClr val="4B5B6B"/>
+                </a:solidFill>
+                <a:latin typeface="Montserrat" pitchFamily="2" charset="0"/>
+                <a:cs typeface="Segoe UI" panose="020B0502040204020203" pitchFamily="34" charset="0"/>
+              </a:rPr>
+              <a:t>framework for European CEO's</a:t>
+            </a:r>
+          </a:p>
+        </p:txBody>
+      </p:sp>
+      <p:sp>
+        <p:nvSpPr>
+          <p:cNvPr id="2" name="Tekstvak 1">
+            <a:extLst>
+              <a:ext uri="{FF2B5EF4-FFF2-40B4-BE49-F238E27FC236}">
+                <a16:creationId xmlns:a16="http://schemas.microsoft.com/office/drawing/2014/main" id="{7A35202E-6D93-F357-54FA-5F2F03585E0B}"/>
+              </a:ext>
+            </a:extLst>
+          </p:cNvPr>
+          <p:cNvSpPr txBox="1"/>
+          <p:nvPr/>
+        </p:nvSpPr>
+        <p:spPr>
+          <a:xfrm>
+            <a:off x="1303223" y="5301295"/>
             <a:ext cx="1277914" cy="246221"/>
           </a:xfrm>
           <a:prstGeom prst="rect">
@@ -6976,134 +6979,12 @@
             <a:pPr algn="ctr"/>
             <a:r>
               <a:rPr lang="en-GB" sz="1000" dirty="0">
+                <a:solidFill>
+                  <a:schemeClr val="bg1"/>
+                </a:solidFill>
                 <a:latin typeface="Garamond" panose="02020404030301010803" pitchFamily="18" charset="0"/>
               </a:rPr>
               <a:t>Stephan Hartgers-Rus</a:t>
-            </a:r>
-          </a:p>
-        </p:txBody>
-      </p:sp>
-      <p:pic>
-        <p:nvPicPr>
-          <p:cNvPr id="20" name="Afbeelding 19" descr="Afbeelding met schoeisel, kleding, person, persoon&#10;&#10;Door AI gegenereerde inhoud is mogelijk onjuist.">
-            <a:extLst>
-              <a:ext uri="{FF2B5EF4-FFF2-40B4-BE49-F238E27FC236}">
-                <a16:creationId xmlns:a16="http://schemas.microsoft.com/office/drawing/2014/main" id="{131CC11A-5448-A817-E1C6-68413F845848}"/>
-              </a:ext>
-            </a:extLst>
-          </p:cNvPr>
-          <p:cNvPicPr>
-            <a:picLocks noChangeAspect="1"/>
-          </p:cNvPicPr>
-          <p:nvPr/>
-        </p:nvPicPr>
-        <p:blipFill>
-          <a:blip r:embed="rId3">
-            <a:extLst>
-              <a:ext uri="{28A0092B-C50C-407E-A947-70E740481C1C}">
-                <a14:useLocalDpi xmlns:a14="http://schemas.microsoft.com/office/drawing/2010/main" val="0"/>
-              </a:ext>
-            </a:extLst>
-          </a:blip>
-          <a:stretch>
-            <a:fillRect/>
-          </a:stretch>
-        </p:blipFill>
-        <p:spPr>
-          <a:xfrm>
-            <a:off x="6601654" y="1363851"/>
-            <a:ext cx="2903284" cy="4354926"/>
-          </a:xfrm>
-          <a:prstGeom prst="rect">
-            <a:avLst/>
-          </a:prstGeom>
-        </p:spPr>
-      </p:pic>
-      <p:sp>
-        <p:nvSpPr>
-          <p:cNvPr id="6" name="Tekstvak 5">
-            <a:extLst>
-              <a:ext uri="{FF2B5EF4-FFF2-40B4-BE49-F238E27FC236}">
-                <a16:creationId xmlns:a16="http://schemas.microsoft.com/office/drawing/2014/main" id="{011CADC5-0494-041A-23A1-8C77774988E9}"/>
-              </a:ext>
-            </a:extLst>
-          </p:cNvPr>
-          <p:cNvSpPr txBox="1"/>
-          <p:nvPr/>
-        </p:nvSpPr>
-        <p:spPr>
-          <a:xfrm>
-            <a:off x="6728976" y="1488311"/>
-            <a:ext cx="2648640" cy="819263"/>
-          </a:xfrm>
-          <a:prstGeom prst="rect">
-            <a:avLst/>
-          </a:prstGeom>
-          <a:noFill/>
-          <a:effectLst/>
-        </p:spPr>
-        <p:txBody>
-          <a:bodyPr wrap="square" rtlCol="0">
-            <a:spAutoFit/>
-          </a:bodyPr>
-          <a:lstStyle/>
-          <a:p>
-            <a:pPr algn="ctr">
-              <a:lnSpc>
-                <a:spcPts val="2900"/>
-              </a:lnSpc>
-            </a:pPr>
-            <a:r>
-              <a:rPr lang="en-GB" sz="2400" b="1" dirty="0">
-                <a:solidFill>
-                  <a:srgbClr val="4B5B6B"/>
-                </a:solidFill>
-                <a:latin typeface="Avenir Next LT Pro" panose="020B0504020202020204" pitchFamily="34" charset="0"/>
-              </a:rPr>
-              <a:t>THE AGENTIC ORGANISATION</a:t>
-            </a:r>
-          </a:p>
-        </p:txBody>
-      </p:sp>
-      <p:sp>
-        <p:nvSpPr>
-          <p:cNvPr id="7" name="Tekstvak 6">
-            <a:extLst>
-              <a:ext uri="{FF2B5EF4-FFF2-40B4-BE49-F238E27FC236}">
-                <a16:creationId xmlns:a16="http://schemas.microsoft.com/office/drawing/2014/main" id="{2DE3A319-CEAC-921D-D6E0-4F2919039E15}"/>
-              </a:ext>
-            </a:extLst>
-          </p:cNvPr>
-          <p:cNvSpPr txBox="1"/>
-          <p:nvPr/>
-        </p:nvSpPr>
-        <p:spPr>
-          <a:xfrm>
-            <a:off x="6615806" y="2226798"/>
-            <a:ext cx="2874980" cy="369332"/>
-          </a:xfrm>
-          <a:prstGeom prst="rect">
-            <a:avLst/>
-          </a:prstGeom>
-          <a:noFill/>
-          <a:effectLst/>
-        </p:spPr>
-        <p:txBody>
-          <a:bodyPr wrap="square" rtlCol="0">
-            <a:spAutoFit/>
-          </a:bodyPr>
-          <a:lstStyle/>
-          <a:p>
-            <a:pPr algn="ctr"/>
-            <a:r>
-              <a:rPr lang="en-GB" sz="900" dirty="0">
-                <a:solidFill>
-                  <a:srgbClr val="4B5B6B"/>
-                </a:solidFill>
-                <a:latin typeface="Avenir Next LT Pro Demi" panose="020B0704020202020204" pitchFamily="34" charset="0"/>
-                <a:cs typeface="Segoe UI" panose="020B0502040204020203" pitchFamily="34" charset="0"/>
-              </a:rPr>
-              <a:t>A TRANSFORMATION FRAMEWORK FOR EUROPEAN COMPANIES</a:t>
             </a:r>
           </a:p>
         </p:txBody>

</xml_diff>

<commit_message>
Added chapter on Product Layer
</commit_message>
<xml_diff>
--- a/input/AI Transformation framework for European CEO’s.pptx
+++ b/input/AI Transformation framework for European CEO’s.pptx
@@ -5,15 +5,16 @@
     <p:sldMasterId id="2147483648" r:id="rId1"/>
   </p:sldMasterIdLst>
   <p:notesMasterIdLst>
-    <p:notesMasterId r:id="rId8"/>
+    <p:notesMasterId r:id="rId9"/>
   </p:notesMasterIdLst>
   <p:sldIdLst>
     <p:sldId id="2147480368" r:id="rId2"/>
     <p:sldId id="2147480366" r:id="rId3"/>
     <p:sldId id="2147480381" r:id="rId4"/>
-    <p:sldId id="2147480372" r:id="rId5"/>
-    <p:sldId id="2147480380" r:id="rId6"/>
-    <p:sldId id="2147480367" r:id="rId7"/>
+    <p:sldId id="2147480382" r:id="rId5"/>
+    <p:sldId id="2147480372" r:id="rId6"/>
+    <p:sldId id="2147480380" r:id="rId7"/>
+    <p:sldId id="2147480367" r:id="rId8"/>
   </p:sldIdLst>
   <p:sldSz cx="12192000" cy="6858000"/>
   <p:notesSz cx="6858000" cy="9144000"/>
@@ -330,7 +331,7 @@
           <a:p>
             <a:fld id="{FAB7A3DB-122E-499C-AAFB-3D4665CBCADB}" type="datetimeFigureOut">
               <a:rPr lang="en-GB" smtClean="0"/>
-              <a:t>04/03/2026</a:t>
+              <a:t>16/03/2026</a:t>
             </a:fld>
             <a:endParaRPr lang="en-GB"/>
           </a:p>
@@ -906,6 +907,114 @@
         <p:cNvPr id="1" name="">
           <a:extLst>
             <a:ext uri="{FF2B5EF4-FFF2-40B4-BE49-F238E27FC236}">
+              <a16:creationId xmlns:a16="http://schemas.microsoft.com/office/drawing/2014/main" id="{41CF22E4-FA30-2B59-D474-BBAB9E25685E}"/>
+            </a:ext>
+          </a:extLst>
+        </p:cNvPr>
+        <p:cNvGrpSpPr/>
+        <p:nvPr/>
+      </p:nvGrpSpPr>
+      <p:grpSpPr>
+        <a:xfrm>
+          <a:off x="0" y="0"/>
+          <a:ext cx="0" cy="0"/>
+          <a:chOff x="0" y="0"/>
+          <a:chExt cx="0" cy="0"/>
+        </a:xfrm>
+      </p:grpSpPr>
+      <p:sp>
+        <p:nvSpPr>
+          <p:cNvPr id="2" name="Slide Image Placeholder 1">
+            <a:extLst>
+              <a:ext uri="{FF2B5EF4-FFF2-40B4-BE49-F238E27FC236}">
+                <a16:creationId xmlns:a16="http://schemas.microsoft.com/office/drawing/2014/main" id="{0BA54A3B-3B69-3A33-FAF6-C774D37CDE54}"/>
+              </a:ext>
+            </a:extLst>
+          </p:cNvPr>
+          <p:cNvSpPr>
+            <a:spLocks noGrp="1" noRot="1" noChangeAspect="1"/>
+          </p:cNvSpPr>
+          <p:nvPr>
+            <p:ph type="sldImg"/>
+          </p:nvPr>
+        </p:nvSpPr>
+        <p:spPr/>
+      </p:sp>
+      <p:sp>
+        <p:nvSpPr>
+          <p:cNvPr id="3" name="Notes Placeholder 2">
+            <a:extLst>
+              <a:ext uri="{FF2B5EF4-FFF2-40B4-BE49-F238E27FC236}">
+                <a16:creationId xmlns:a16="http://schemas.microsoft.com/office/drawing/2014/main" id="{19E6AD24-7AC9-7116-B3D0-5A10C9A8AB72}"/>
+              </a:ext>
+            </a:extLst>
+          </p:cNvPr>
+          <p:cNvSpPr>
+            <a:spLocks noGrp="1"/>
+          </p:cNvSpPr>
+          <p:nvPr>
+            <p:ph type="body" idx="1"/>
+          </p:nvPr>
+        </p:nvSpPr>
+        <p:spPr/>
+        <p:txBody>
+          <a:bodyPr/>
+          <a:lstStyle/>
+          <a:p>
+            <a:endParaRPr lang="en-GB"/>
+          </a:p>
+        </p:txBody>
+      </p:sp>
+      <p:sp>
+        <p:nvSpPr>
+          <p:cNvPr id="4" name="Slide Number Placeholder 3">
+            <a:extLst>
+              <a:ext uri="{FF2B5EF4-FFF2-40B4-BE49-F238E27FC236}">
+                <a16:creationId xmlns:a16="http://schemas.microsoft.com/office/drawing/2014/main" id="{55E05A93-6EA3-EE2C-1B02-62CCB8FBB3A3}"/>
+              </a:ext>
+            </a:extLst>
+          </p:cNvPr>
+          <p:cNvSpPr>
+            <a:spLocks noGrp="1"/>
+          </p:cNvSpPr>
+          <p:nvPr>
+            <p:ph type="sldNum" sz="quarter" idx="5"/>
+          </p:nvPr>
+        </p:nvSpPr>
+        <p:spPr/>
+        <p:txBody>
+          <a:bodyPr/>
+          <a:lstStyle/>
+          <a:p>
+            <a:fld id="{BA1AFD66-2597-4960-86E3-D00E2B43A69D}" type="slidenum">
+              <a:rPr lang="en-GB" smtClean="0"/>
+              <a:t>4</a:t>
+            </a:fld>
+            <a:endParaRPr lang="en-GB"/>
+          </a:p>
+        </p:txBody>
+      </p:sp>
+    </p:spTree>
+    <p:extLst>
+      <p:ext uri="{BB962C8B-B14F-4D97-AF65-F5344CB8AC3E}">
+        <p14:creationId xmlns:p14="http://schemas.microsoft.com/office/powerpoint/2010/main" val="984859052"/>
+      </p:ext>
+    </p:extLst>
+  </p:cSld>
+  <p:clrMapOvr>
+    <a:masterClrMapping/>
+  </p:clrMapOvr>
+</p:notes>
+</file>
+
+<file path=ppt/notesSlides/notesSlide5.xml><?xml version="1.0" encoding="utf-8"?>
+<p:notes xmlns:a="http://schemas.openxmlformats.org/drawingml/2006/main" xmlns:r="http://schemas.openxmlformats.org/officeDocument/2006/relationships" xmlns:p="http://schemas.openxmlformats.org/presentationml/2006/main">
+  <p:cSld>
+    <p:spTree>
+      <p:nvGrpSpPr>
+        <p:cNvPr id="1" name="">
+          <a:extLst>
+            <a:ext uri="{FF2B5EF4-FFF2-40B4-BE49-F238E27FC236}">
               <a16:creationId xmlns:a16="http://schemas.microsoft.com/office/drawing/2014/main" id="{9ACE62BF-62B2-82DC-C376-73CE77938791}"/>
             </a:ext>
           </a:extLst>
@@ -987,7 +1096,7 @@
           <a:p>
             <a:fld id="{BA1AFD66-2597-4960-86E3-D00E2B43A69D}" type="slidenum">
               <a:rPr lang="en-GB" smtClean="0"/>
-              <a:t>4</a:t>
+              <a:t>5</a:t>
             </a:fld>
             <a:endParaRPr lang="en-GB"/>
           </a:p>
@@ -1006,7 +1115,7 @@
 </p:notes>
 </file>
 
-<file path=ppt/notesSlides/notesSlide5.xml><?xml version="1.0" encoding="utf-8"?>
+<file path=ppt/notesSlides/notesSlide6.xml><?xml version="1.0" encoding="utf-8"?>
 <p:notes xmlns:a="http://schemas.openxmlformats.org/drawingml/2006/main" xmlns:r="http://schemas.openxmlformats.org/officeDocument/2006/relationships" xmlns:p="http://schemas.openxmlformats.org/presentationml/2006/main">
   <p:cSld>
     <p:spTree>
@@ -1095,7 +1204,7 @@
           <a:p>
             <a:fld id="{BA1AFD66-2597-4960-86E3-D00E2B43A69D}" type="slidenum">
               <a:rPr lang="en-GB" smtClean="0"/>
-              <a:t>5</a:t>
+              <a:t>6</a:t>
             </a:fld>
             <a:endParaRPr lang="en-GB"/>
           </a:p>
@@ -1114,7 +1223,7 @@
 </p:notes>
 </file>
 
-<file path=ppt/notesSlides/notesSlide6.xml><?xml version="1.0" encoding="utf-8"?>
+<file path=ppt/notesSlides/notesSlide7.xml><?xml version="1.0" encoding="utf-8"?>
 <p:notes xmlns:a="http://schemas.openxmlformats.org/drawingml/2006/main" xmlns:r="http://schemas.openxmlformats.org/officeDocument/2006/relationships" xmlns:p="http://schemas.openxmlformats.org/presentationml/2006/main">
   <p:cSld>
     <p:spTree>
@@ -1203,7 +1312,7 @@
           <a:p>
             <a:fld id="{BA1AFD66-2597-4960-86E3-D00E2B43A69D}" type="slidenum">
               <a:rPr lang="en-GB" smtClean="0"/>
-              <a:t>6</a:t>
+              <a:t>7</a:t>
             </a:fld>
             <a:endParaRPr lang="en-GB"/>
           </a:p>
@@ -1371,7 +1480,7 @@
           <a:p>
             <a:fld id="{7E530143-BC45-40DA-908E-84B30ACFDA34}" type="datetimeFigureOut">
               <a:rPr lang="en-GB" smtClean="0"/>
-              <a:t>04/03/2026</a:t>
+              <a:t>16/03/2026</a:t>
             </a:fld>
             <a:endParaRPr lang="en-GB"/>
           </a:p>
@@ -1571,7 +1680,7 @@
           <a:p>
             <a:fld id="{7E530143-BC45-40DA-908E-84B30ACFDA34}" type="datetimeFigureOut">
               <a:rPr lang="en-GB" smtClean="0"/>
-              <a:t>04/03/2026</a:t>
+              <a:t>16/03/2026</a:t>
             </a:fld>
             <a:endParaRPr lang="en-GB"/>
           </a:p>
@@ -1781,7 +1890,7 @@
           <a:p>
             <a:fld id="{7E530143-BC45-40DA-908E-84B30ACFDA34}" type="datetimeFigureOut">
               <a:rPr lang="en-GB" smtClean="0"/>
-              <a:t>04/03/2026</a:t>
+              <a:t>16/03/2026</a:t>
             </a:fld>
             <a:endParaRPr lang="en-GB"/>
           </a:p>
@@ -2405,7 +2514,7 @@
           <a:p>
             <a:fld id="{7E530143-BC45-40DA-908E-84B30ACFDA34}" type="datetimeFigureOut">
               <a:rPr lang="en-GB" smtClean="0"/>
-              <a:t>04/03/2026</a:t>
+              <a:t>16/03/2026</a:t>
             </a:fld>
             <a:endParaRPr lang="en-GB"/>
           </a:p>
@@ -2681,7 +2790,7 @@
           <a:p>
             <a:fld id="{7E530143-BC45-40DA-908E-84B30ACFDA34}" type="datetimeFigureOut">
               <a:rPr lang="en-GB" smtClean="0"/>
-              <a:t>04/03/2026</a:t>
+              <a:t>16/03/2026</a:t>
             </a:fld>
             <a:endParaRPr lang="en-GB"/>
           </a:p>
@@ -2949,7 +3058,7 @@
           <a:p>
             <a:fld id="{7E530143-BC45-40DA-908E-84B30ACFDA34}" type="datetimeFigureOut">
               <a:rPr lang="en-GB" smtClean="0"/>
-              <a:t>04/03/2026</a:t>
+              <a:t>16/03/2026</a:t>
             </a:fld>
             <a:endParaRPr lang="en-GB"/>
           </a:p>
@@ -3364,7 +3473,7 @@
           <a:p>
             <a:fld id="{7E530143-BC45-40DA-908E-84B30ACFDA34}" type="datetimeFigureOut">
               <a:rPr lang="en-GB" smtClean="0"/>
-              <a:t>04/03/2026</a:t>
+              <a:t>16/03/2026</a:t>
             </a:fld>
             <a:endParaRPr lang="en-GB"/>
           </a:p>
@@ -3506,7 +3615,7 @@
           <a:p>
             <a:fld id="{7E530143-BC45-40DA-908E-84B30ACFDA34}" type="datetimeFigureOut">
               <a:rPr lang="en-GB" smtClean="0"/>
-              <a:t>04/03/2026</a:t>
+              <a:t>16/03/2026</a:t>
             </a:fld>
             <a:endParaRPr lang="en-GB"/>
           </a:p>
@@ -3619,7 +3728,7 @@
           <a:p>
             <a:fld id="{7E530143-BC45-40DA-908E-84B30ACFDA34}" type="datetimeFigureOut">
               <a:rPr lang="en-GB" smtClean="0"/>
-              <a:t>04/03/2026</a:t>
+              <a:t>16/03/2026</a:t>
             </a:fld>
             <a:endParaRPr lang="en-GB"/>
           </a:p>
@@ -3932,7 +4041,7 @@
           <a:p>
             <a:fld id="{7E530143-BC45-40DA-908E-84B30ACFDA34}" type="datetimeFigureOut">
               <a:rPr lang="en-GB" smtClean="0"/>
-              <a:t>04/03/2026</a:t>
+              <a:t>16/03/2026</a:t>
             </a:fld>
             <a:endParaRPr lang="en-GB"/>
           </a:p>
@@ -4221,7 +4330,7 @@
           <a:p>
             <a:fld id="{7E530143-BC45-40DA-908E-84B30ACFDA34}" type="datetimeFigureOut">
               <a:rPr lang="en-GB" smtClean="0"/>
-              <a:t>04/03/2026</a:t>
+              <a:t>16/03/2026</a:t>
             </a:fld>
             <a:endParaRPr lang="en-GB"/>
           </a:p>
@@ -4464,7 +4573,7 @@
           <a:p>
             <a:fld id="{7E530143-BC45-40DA-908E-84B30ACFDA34}" type="datetimeFigureOut">
               <a:rPr lang="en-GB" smtClean="0"/>
-              <a:t>04/03/2026</a:t>
+              <a:t>16/03/2026</a:t>
             </a:fld>
             <a:endParaRPr lang="en-GB"/>
           </a:p>
@@ -8195,6 +8304,1324 @@
         <p:cNvPr id="1" name="">
           <a:extLst>
             <a:ext uri="{FF2B5EF4-FFF2-40B4-BE49-F238E27FC236}">
+              <a16:creationId xmlns:a16="http://schemas.microsoft.com/office/drawing/2014/main" id="{7D8BA248-EF49-F51A-CBDA-CDB536E050A4}"/>
+            </a:ext>
+          </a:extLst>
+        </p:cNvPr>
+        <p:cNvGrpSpPr/>
+        <p:nvPr/>
+      </p:nvGrpSpPr>
+      <p:grpSpPr>
+        <a:xfrm>
+          <a:off x="0" y="0"/>
+          <a:ext cx="0" cy="0"/>
+          <a:chOff x="0" y="0"/>
+          <a:chExt cx="0" cy="0"/>
+        </a:xfrm>
+      </p:grpSpPr>
+      <p:sp>
+        <p:nvSpPr>
+          <p:cNvPr id="2" name="Rechthoek 1">
+            <a:extLst>
+              <a:ext uri="{FF2B5EF4-FFF2-40B4-BE49-F238E27FC236}">
+                <a16:creationId xmlns:a16="http://schemas.microsoft.com/office/drawing/2014/main" id="{6CED7A95-861C-C15B-BDC7-8EFDB6F02F4F}"/>
+              </a:ext>
+            </a:extLst>
+          </p:cNvPr>
+          <p:cNvSpPr/>
+          <p:nvPr/>
+        </p:nvSpPr>
+        <p:spPr>
+          <a:xfrm>
+            <a:off x="1947041" y="409251"/>
+            <a:ext cx="8442435" cy="4690889"/>
+          </a:xfrm>
+          <a:prstGeom prst="rect">
+            <a:avLst/>
+          </a:prstGeom>
+          <a:solidFill>
+            <a:schemeClr val="bg1"/>
+          </a:solidFill>
+          <a:ln>
+            <a:noFill/>
+          </a:ln>
+        </p:spPr>
+        <p:style>
+          <a:lnRef idx="2">
+            <a:schemeClr val="accent1">
+              <a:shade val="15000"/>
+            </a:schemeClr>
+          </a:lnRef>
+          <a:fillRef idx="1">
+            <a:schemeClr val="accent1"/>
+          </a:fillRef>
+          <a:effectRef idx="0">
+            <a:schemeClr val="accent1"/>
+          </a:effectRef>
+          <a:fontRef idx="minor">
+            <a:schemeClr val="lt1"/>
+          </a:fontRef>
+        </p:style>
+        <p:txBody>
+          <a:bodyPr rtlCol="0" anchor="ctr"/>
+          <a:lstStyle/>
+          <a:p>
+            <a:pPr algn="ctr"/>
+            <a:endParaRPr lang="en-GB"/>
+          </a:p>
+        </p:txBody>
+      </p:sp>
+      <p:sp>
+        <p:nvSpPr>
+          <p:cNvPr id="3" name="Title 2">
+            <a:extLst>
+              <a:ext uri="{FF2B5EF4-FFF2-40B4-BE49-F238E27FC236}">
+                <a16:creationId xmlns:a16="http://schemas.microsoft.com/office/drawing/2014/main" id="{BF651015-06D4-F8F3-4AC0-6C159D0D7FDC}"/>
+              </a:ext>
+            </a:extLst>
+          </p:cNvPr>
+          <p:cNvSpPr>
+            <a:spLocks noGrp="1"/>
+          </p:cNvSpPr>
+          <p:nvPr>
+            <p:ph type="title"/>
+          </p:nvPr>
+        </p:nvSpPr>
+        <p:spPr>
+          <a:xfrm>
+            <a:off x="3652782" y="629113"/>
+            <a:ext cx="4886436" cy="360099"/>
+          </a:xfrm>
+        </p:spPr>
+        <p:txBody>
+          <a:bodyPr>
+            <a:normAutofit/>
+          </a:bodyPr>
+          <a:lstStyle/>
+          <a:p>
+            <a:pPr algn="ctr"/>
+            <a:r>
+              <a:rPr lang="en-GB" noProof="0" dirty="0">
+                <a:solidFill>
+                  <a:schemeClr val="tx1">
+                    <a:lumMod val="85000"/>
+                    <a:lumOff val="15000"/>
+                  </a:schemeClr>
+                </a:solidFill>
+              </a:rPr>
+              <a:t>AI Transformation Framework</a:t>
+            </a:r>
+          </a:p>
+        </p:txBody>
+      </p:sp>
+      <p:sp>
+        <p:nvSpPr>
+          <p:cNvPr id="17" name="Rectangle 16">
+            <a:extLst>
+              <a:ext uri="{FF2B5EF4-FFF2-40B4-BE49-F238E27FC236}">
+                <a16:creationId xmlns:a16="http://schemas.microsoft.com/office/drawing/2014/main" id="{854FBC05-8076-835B-A51A-382B2C7273FA}"/>
+              </a:ext>
+            </a:extLst>
+          </p:cNvPr>
+          <p:cNvSpPr/>
+          <p:nvPr/>
+        </p:nvSpPr>
+        <p:spPr>
+          <a:xfrm>
+            <a:off x="2265680" y="1273145"/>
+            <a:ext cx="7658112" cy="569848"/>
+          </a:xfrm>
+          <a:prstGeom prst="roundRect">
+            <a:avLst/>
+          </a:prstGeom>
+          <a:noFill/>
+          <a:ln>
+            <a:solidFill>
+              <a:schemeClr val="tx1">
+                <a:lumMod val="85000"/>
+                <a:lumOff val="15000"/>
+              </a:schemeClr>
+            </a:solidFill>
+          </a:ln>
+        </p:spPr>
+        <p:style>
+          <a:lnRef idx="2">
+            <a:schemeClr val="accent1">
+              <a:shade val="15000"/>
+            </a:schemeClr>
+          </a:lnRef>
+          <a:fillRef idx="1">
+            <a:schemeClr val="accent1"/>
+          </a:fillRef>
+          <a:effectRef idx="0">
+            <a:schemeClr val="accent1"/>
+          </a:effectRef>
+          <a:fontRef idx="minor">
+            <a:schemeClr val="lt1"/>
+          </a:fontRef>
+        </p:style>
+        <p:txBody>
+          <a:bodyPr rtlCol="0" anchor="ctr"/>
+          <a:lstStyle/>
+          <a:p>
+            <a:pPr algn="ctr"/>
+            <a:endParaRPr lang="en-GB" noProof="0" dirty="0"/>
+          </a:p>
+        </p:txBody>
+      </p:sp>
+      <p:sp>
+        <p:nvSpPr>
+          <p:cNvPr id="20" name="TextBox 19">
+            <a:extLst>
+              <a:ext uri="{FF2B5EF4-FFF2-40B4-BE49-F238E27FC236}">
+                <a16:creationId xmlns:a16="http://schemas.microsoft.com/office/drawing/2014/main" id="{79702F44-A03C-80FC-8FB0-0826BA42DE86}"/>
+              </a:ext>
+            </a:extLst>
+          </p:cNvPr>
+          <p:cNvSpPr txBox="1"/>
+          <p:nvPr/>
+        </p:nvSpPr>
+        <p:spPr>
+          <a:xfrm>
+            <a:off x="2418950" y="1343051"/>
+            <a:ext cx="3874310" cy="383054"/>
+          </a:xfrm>
+          <a:prstGeom prst="rect">
+            <a:avLst/>
+          </a:prstGeom>
+          <a:noFill/>
+        </p:spPr>
+        <p:txBody>
+          <a:bodyPr wrap="square" lIns="0" tIns="0" rIns="0" bIns="0" rtlCol="0">
+            <a:spAutoFit/>
+          </a:bodyPr>
+          <a:lstStyle/>
+          <a:p>
+            <a:pPr>
+              <a:buSzPct val="100000"/>
+            </a:pPr>
+            <a:r>
+              <a:rPr lang="en-GB" sz="1400" b="1" noProof="0" dirty="0">
+                <a:solidFill>
+                  <a:schemeClr val="tx1">
+                    <a:lumMod val="85000"/>
+                    <a:lumOff val="15000"/>
+                  </a:schemeClr>
+                </a:solidFill>
+                <a:latin typeface="DM Sans" pitchFamily="2" charset="0"/>
+              </a:rPr>
+              <a:t>VISION</a:t>
+            </a:r>
+            <a:endParaRPr lang="en-GB" sz="1200" b="1" noProof="0" dirty="0">
+              <a:solidFill>
+                <a:schemeClr val="tx1">
+                  <a:lumMod val="85000"/>
+                  <a:lumOff val="15000"/>
+                </a:schemeClr>
+              </a:solidFill>
+              <a:latin typeface="DM Sans" pitchFamily="2" charset="0"/>
+            </a:endParaRPr>
+          </a:p>
+          <a:p>
+            <a:pPr>
+              <a:lnSpc>
+                <a:spcPts val="1300"/>
+              </a:lnSpc>
+              <a:buSzPct val="100000"/>
+            </a:pPr>
+            <a:r>
+              <a:rPr lang="en-GB" sz="1200" noProof="0" dirty="0">
+                <a:solidFill>
+                  <a:schemeClr val="tx1">
+                    <a:lumMod val="85000"/>
+                    <a:lumOff val="15000"/>
+                  </a:schemeClr>
+                </a:solidFill>
+                <a:latin typeface="+mj-lt"/>
+              </a:rPr>
+              <a:t>Vision</a:t>
+            </a:r>
+            <a:r>
+              <a:rPr lang="en-GB" sz="1200" b="1" noProof="0" dirty="0">
+                <a:solidFill>
+                  <a:schemeClr val="tx1">
+                    <a:lumMod val="85000"/>
+                    <a:lumOff val="15000"/>
+                  </a:schemeClr>
+                </a:solidFill>
+                <a:latin typeface="+mj-lt"/>
+              </a:rPr>
+              <a:t>, </a:t>
+            </a:r>
+            <a:r>
+              <a:rPr lang="en-GB" sz="1200" noProof="0" dirty="0">
+                <a:solidFill>
+                  <a:schemeClr val="tx1">
+                    <a:lumMod val="85000"/>
+                    <a:lumOff val="15000"/>
+                  </a:schemeClr>
+                </a:solidFill>
+                <a:latin typeface="+mj-lt"/>
+              </a:rPr>
+              <a:t>strategy, values, objectives</a:t>
+            </a:r>
+          </a:p>
+        </p:txBody>
+      </p:sp>
+      <p:sp>
+        <p:nvSpPr>
+          <p:cNvPr id="151" name="Rectangle 150">
+            <a:extLst>
+              <a:ext uri="{FF2B5EF4-FFF2-40B4-BE49-F238E27FC236}">
+                <a16:creationId xmlns:a16="http://schemas.microsoft.com/office/drawing/2014/main" id="{41F7B64D-5435-407E-622F-30D44BB5CD32}"/>
+              </a:ext>
+            </a:extLst>
+          </p:cNvPr>
+          <p:cNvSpPr/>
+          <p:nvPr/>
+        </p:nvSpPr>
+        <p:spPr>
+          <a:xfrm>
+            <a:off x="2271959" y="3028093"/>
+            <a:ext cx="2480582" cy="908874"/>
+          </a:xfrm>
+          <a:prstGeom prst="roundRect">
+            <a:avLst/>
+          </a:prstGeom>
+          <a:noFill/>
+          <a:ln>
+            <a:solidFill>
+              <a:schemeClr val="tx1">
+                <a:lumMod val="85000"/>
+                <a:lumOff val="15000"/>
+              </a:schemeClr>
+            </a:solidFill>
+          </a:ln>
+        </p:spPr>
+        <p:style>
+          <a:lnRef idx="2">
+            <a:schemeClr val="accent1">
+              <a:shade val="15000"/>
+            </a:schemeClr>
+          </a:lnRef>
+          <a:fillRef idx="1">
+            <a:schemeClr val="accent1"/>
+          </a:fillRef>
+          <a:effectRef idx="0">
+            <a:schemeClr val="accent1"/>
+          </a:effectRef>
+          <a:fontRef idx="minor">
+            <a:schemeClr val="lt1"/>
+          </a:fontRef>
+        </p:style>
+        <p:txBody>
+          <a:bodyPr rtlCol="0" anchor="ctr"/>
+          <a:lstStyle/>
+          <a:p>
+            <a:pPr algn="ctr"/>
+            <a:endParaRPr lang="en-GB" noProof="0" dirty="0"/>
+          </a:p>
+        </p:txBody>
+      </p:sp>
+      <p:sp>
+        <p:nvSpPr>
+          <p:cNvPr id="154" name="Rectangle 153">
+            <a:extLst>
+              <a:ext uri="{FF2B5EF4-FFF2-40B4-BE49-F238E27FC236}">
+                <a16:creationId xmlns:a16="http://schemas.microsoft.com/office/drawing/2014/main" id="{D5BBACB4-7591-438A-25EA-79E642E138D4}"/>
+              </a:ext>
+            </a:extLst>
+          </p:cNvPr>
+          <p:cNvSpPr/>
+          <p:nvPr/>
+        </p:nvSpPr>
+        <p:spPr>
+          <a:xfrm>
+            <a:off x="4858848" y="3028093"/>
+            <a:ext cx="2480582" cy="908874"/>
+          </a:xfrm>
+          <a:prstGeom prst="roundRect">
+            <a:avLst/>
+          </a:prstGeom>
+          <a:noFill/>
+          <a:ln>
+            <a:solidFill>
+              <a:schemeClr val="tx1">
+                <a:lumMod val="85000"/>
+                <a:lumOff val="15000"/>
+              </a:schemeClr>
+            </a:solidFill>
+          </a:ln>
+        </p:spPr>
+        <p:style>
+          <a:lnRef idx="2">
+            <a:schemeClr val="accent1">
+              <a:shade val="15000"/>
+            </a:schemeClr>
+          </a:lnRef>
+          <a:fillRef idx="1">
+            <a:schemeClr val="accent1"/>
+          </a:fillRef>
+          <a:effectRef idx="0">
+            <a:schemeClr val="accent1"/>
+          </a:effectRef>
+          <a:fontRef idx="minor">
+            <a:schemeClr val="lt1"/>
+          </a:fontRef>
+        </p:style>
+        <p:txBody>
+          <a:bodyPr rtlCol="0" anchor="ctr"/>
+          <a:lstStyle/>
+          <a:p>
+            <a:pPr algn="ctr"/>
+            <a:endParaRPr lang="en-GB" noProof="0" dirty="0"/>
+          </a:p>
+        </p:txBody>
+      </p:sp>
+      <p:sp>
+        <p:nvSpPr>
+          <p:cNvPr id="156" name="Rectangle 155">
+            <a:extLst>
+              <a:ext uri="{FF2B5EF4-FFF2-40B4-BE49-F238E27FC236}">
+                <a16:creationId xmlns:a16="http://schemas.microsoft.com/office/drawing/2014/main" id="{41A130F9-0930-C628-981A-7758A9ACE534}"/>
+              </a:ext>
+            </a:extLst>
+          </p:cNvPr>
+          <p:cNvSpPr/>
+          <p:nvPr/>
+        </p:nvSpPr>
+        <p:spPr>
+          <a:xfrm>
+            <a:off x="7445738" y="3028093"/>
+            <a:ext cx="2480582" cy="908874"/>
+          </a:xfrm>
+          <a:prstGeom prst="roundRect">
+            <a:avLst/>
+          </a:prstGeom>
+          <a:noFill/>
+          <a:ln>
+            <a:solidFill>
+              <a:schemeClr val="tx1">
+                <a:lumMod val="85000"/>
+                <a:lumOff val="15000"/>
+              </a:schemeClr>
+            </a:solidFill>
+          </a:ln>
+        </p:spPr>
+        <p:style>
+          <a:lnRef idx="2">
+            <a:schemeClr val="accent1">
+              <a:shade val="15000"/>
+            </a:schemeClr>
+          </a:lnRef>
+          <a:fillRef idx="1">
+            <a:schemeClr val="accent1"/>
+          </a:fillRef>
+          <a:effectRef idx="0">
+            <a:schemeClr val="accent1"/>
+          </a:effectRef>
+          <a:fontRef idx="minor">
+            <a:schemeClr val="lt1"/>
+          </a:fontRef>
+        </p:style>
+        <p:txBody>
+          <a:bodyPr rtlCol="0" anchor="ctr"/>
+          <a:lstStyle/>
+          <a:p>
+            <a:pPr algn="ctr"/>
+            <a:endParaRPr lang="en-GB" noProof="0" dirty="0"/>
+          </a:p>
+        </p:txBody>
+      </p:sp>
+      <p:sp>
+        <p:nvSpPr>
+          <p:cNvPr id="152" name="TextBox 151">
+            <a:extLst>
+              <a:ext uri="{FF2B5EF4-FFF2-40B4-BE49-F238E27FC236}">
+                <a16:creationId xmlns:a16="http://schemas.microsoft.com/office/drawing/2014/main" id="{61BC1662-D73D-BAB8-E82C-9675A5C2652B}"/>
+              </a:ext>
+            </a:extLst>
+          </p:cNvPr>
+          <p:cNvSpPr txBox="1"/>
+          <p:nvPr/>
+        </p:nvSpPr>
+        <p:spPr>
+          <a:xfrm>
+            <a:off x="2418949" y="3094599"/>
+            <a:ext cx="2306191" cy="769441"/>
+          </a:xfrm>
+          <a:prstGeom prst="rect">
+            <a:avLst/>
+          </a:prstGeom>
+          <a:noFill/>
+        </p:spPr>
+        <p:txBody>
+          <a:bodyPr wrap="square" lIns="0" tIns="0" rIns="0" bIns="0" rtlCol="0">
+            <a:spAutoFit/>
+          </a:bodyPr>
+          <a:lstStyle/>
+          <a:p>
+            <a:pPr>
+              <a:buSzPct val="100000"/>
+            </a:pPr>
+            <a:r>
+              <a:rPr lang="en-GB" sz="1400" b="1" noProof="0" dirty="0">
+                <a:solidFill>
+                  <a:schemeClr val="tx1">
+                    <a:lumMod val="85000"/>
+                    <a:lumOff val="15000"/>
+                  </a:schemeClr>
+                </a:solidFill>
+                <a:latin typeface="DM Sans" pitchFamily="2" charset="0"/>
+              </a:rPr>
+              <a:t>PEOPLE</a:t>
+            </a:r>
+          </a:p>
+          <a:p>
+            <a:pPr>
+              <a:buSzPct val="100000"/>
+            </a:pPr>
+            <a:r>
+              <a:rPr lang="en-GB" sz="1200" noProof="0" dirty="0">
+                <a:solidFill>
+                  <a:schemeClr val="tx1">
+                    <a:lumMod val="85000"/>
+                    <a:lumOff val="15000"/>
+                  </a:schemeClr>
+                </a:solidFill>
+                <a:latin typeface="+mj-lt"/>
+              </a:rPr>
+              <a:t>Roles, target skills &amp; gaps, org sizing, talent journey, training, team incentives</a:t>
+            </a:r>
+          </a:p>
+        </p:txBody>
+      </p:sp>
+      <p:sp>
+        <p:nvSpPr>
+          <p:cNvPr id="155" name="TextBox 154">
+            <a:extLst>
+              <a:ext uri="{FF2B5EF4-FFF2-40B4-BE49-F238E27FC236}">
+                <a16:creationId xmlns:a16="http://schemas.microsoft.com/office/drawing/2014/main" id="{D6773BBC-2B68-F3FD-662D-3FDFA5E700A0}"/>
+              </a:ext>
+            </a:extLst>
+          </p:cNvPr>
+          <p:cNvSpPr txBox="1"/>
+          <p:nvPr/>
+        </p:nvSpPr>
+        <p:spPr>
+          <a:xfrm>
+            <a:off x="5010186" y="3094599"/>
+            <a:ext cx="2044410" cy="549766"/>
+          </a:xfrm>
+          <a:prstGeom prst="rect">
+            <a:avLst/>
+          </a:prstGeom>
+          <a:noFill/>
+        </p:spPr>
+        <p:txBody>
+          <a:bodyPr wrap="square" lIns="0" tIns="0" rIns="0" bIns="0" rtlCol="0">
+            <a:spAutoFit/>
+          </a:bodyPr>
+          <a:lstStyle/>
+          <a:p>
+            <a:pPr>
+              <a:buSzPct val="100000"/>
+            </a:pPr>
+            <a:r>
+              <a:rPr lang="en-GB" sz="1400" b="1" dirty="0">
+                <a:solidFill>
+                  <a:schemeClr val="tx1">
+                    <a:lumMod val="85000"/>
+                    <a:lumOff val="15000"/>
+                  </a:schemeClr>
+                </a:solidFill>
+                <a:latin typeface="DM Sans" pitchFamily="2" charset="0"/>
+              </a:rPr>
+              <a:t>PROCESS</a:t>
+            </a:r>
+          </a:p>
+          <a:p>
+            <a:pPr>
+              <a:lnSpc>
+                <a:spcPts val="1300"/>
+              </a:lnSpc>
+              <a:buSzPct val="100000"/>
+            </a:pPr>
+            <a:r>
+              <a:rPr lang="en-GB" sz="1200" dirty="0">
+                <a:solidFill>
+                  <a:schemeClr val="tx1">
+                    <a:lumMod val="85000"/>
+                    <a:lumOff val="15000"/>
+                  </a:schemeClr>
+                </a:solidFill>
+                <a:latin typeface="+mj-lt"/>
+              </a:rPr>
+              <a:t>Org. design, cross-functional teams, product way-of-working</a:t>
+            </a:r>
+          </a:p>
+        </p:txBody>
+      </p:sp>
+      <p:sp>
+        <p:nvSpPr>
+          <p:cNvPr id="157" name="TextBox 156">
+            <a:extLst>
+              <a:ext uri="{FF2B5EF4-FFF2-40B4-BE49-F238E27FC236}">
+                <a16:creationId xmlns:a16="http://schemas.microsoft.com/office/drawing/2014/main" id="{8666AC02-3F8E-E754-C3F1-B208CBEF0099}"/>
+              </a:ext>
+            </a:extLst>
+          </p:cNvPr>
+          <p:cNvSpPr txBox="1"/>
+          <p:nvPr/>
+        </p:nvSpPr>
+        <p:spPr>
+          <a:xfrm>
+            <a:off x="7590340" y="3094599"/>
+            <a:ext cx="2050934" cy="518988"/>
+          </a:xfrm>
+          <a:prstGeom prst="rect">
+            <a:avLst/>
+          </a:prstGeom>
+          <a:noFill/>
+        </p:spPr>
+        <p:txBody>
+          <a:bodyPr wrap="square" lIns="0" tIns="0" rIns="0" bIns="0" rtlCol="0">
+            <a:spAutoFit/>
+          </a:bodyPr>
+          <a:lstStyle/>
+          <a:p>
+            <a:pPr>
+              <a:buSzPct val="100000"/>
+            </a:pPr>
+            <a:r>
+              <a:rPr lang="en-GB" sz="1200" b="1" noProof="0" dirty="0">
+                <a:solidFill>
+                  <a:schemeClr val="tx1">
+                    <a:lumMod val="85000"/>
+                    <a:lumOff val="15000"/>
+                  </a:schemeClr>
+                </a:solidFill>
+                <a:latin typeface="DM Sans" pitchFamily="2" charset="0"/>
+              </a:rPr>
+              <a:t>ENABLEMENT</a:t>
+            </a:r>
+          </a:p>
+          <a:p>
+            <a:pPr>
+              <a:lnSpc>
+                <a:spcPts val="1300"/>
+              </a:lnSpc>
+              <a:buSzPct val="100000"/>
+            </a:pPr>
+            <a:r>
+              <a:rPr lang="en-GB" sz="1200" noProof="0" dirty="0">
+                <a:solidFill>
+                  <a:schemeClr val="tx1">
+                    <a:lumMod val="85000"/>
+                    <a:lumOff val="15000"/>
+                  </a:schemeClr>
+                </a:solidFill>
+                <a:latin typeface="+mj-lt"/>
+              </a:rPr>
+              <a:t>Culture, AI &amp; engineering toolbox, automation, agents, skills</a:t>
+            </a:r>
+          </a:p>
+        </p:txBody>
+      </p:sp>
+      <p:sp>
+        <p:nvSpPr>
+          <p:cNvPr id="162" name="Rectangle 161">
+            <a:extLst>
+              <a:ext uri="{FF2B5EF4-FFF2-40B4-BE49-F238E27FC236}">
+                <a16:creationId xmlns:a16="http://schemas.microsoft.com/office/drawing/2014/main" id="{DFE2ED97-2E3F-FA70-0C4E-672C48D375F5}"/>
+              </a:ext>
+            </a:extLst>
+          </p:cNvPr>
+          <p:cNvSpPr/>
+          <p:nvPr/>
+        </p:nvSpPr>
+        <p:spPr>
+          <a:xfrm>
+            <a:off x="2271959" y="4075080"/>
+            <a:ext cx="3771823" cy="908874"/>
+          </a:xfrm>
+          <a:prstGeom prst="roundRect">
+            <a:avLst/>
+          </a:prstGeom>
+          <a:noFill/>
+          <a:ln>
+            <a:solidFill>
+              <a:schemeClr val="tx1">
+                <a:lumMod val="85000"/>
+                <a:lumOff val="15000"/>
+              </a:schemeClr>
+            </a:solidFill>
+          </a:ln>
+        </p:spPr>
+        <p:style>
+          <a:lnRef idx="2">
+            <a:schemeClr val="accent1">
+              <a:shade val="15000"/>
+            </a:schemeClr>
+          </a:lnRef>
+          <a:fillRef idx="1">
+            <a:schemeClr val="accent1"/>
+          </a:fillRef>
+          <a:effectRef idx="0">
+            <a:schemeClr val="accent1"/>
+          </a:effectRef>
+          <a:fontRef idx="minor">
+            <a:schemeClr val="lt1"/>
+          </a:fontRef>
+        </p:style>
+        <p:txBody>
+          <a:bodyPr rtlCol="0" anchor="ctr"/>
+          <a:lstStyle/>
+          <a:p>
+            <a:pPr algn="ctr"/>
+            <a:endParaRPr lang="en-GB" noProof="0" dirty="0"/>
+          </a:p>
+        </p:txBody>
+      </p:sp>
+      <p:sp>
+        <p:nvSpPr>
+          <p:cNvPr id="165" name="Rectangle 164">
+            <a:extLst>
+              <a:ext uri="{FF2B5EF4-FFF2-40B4-BE49-F238E27FC236}">
+                <a16:creationId xmlns:a16="http://schemas.microsoft.com/office/drawing/2014/main" id="{385E0A92-67D8-D588-5217-B92EF10469E0}"/>
+              </a:ext>
+            </a:extLst>
+          </p:cNvPr>
+          <p:cNvSpPr/>
+          <p:nvPr/>
+        </p:nvSpPr>
+        <p:spPr>
+          <a:xfrm>
+            <a:off x="6151970" y="4075080"/>
+            <a:ext cx="3771823" cy="908874"/>
+          </a:xfrm>
+          <a:prstGeom prst="roundRect">
+            <a:avLst/>
+          </a:prstGeom>
+          <a:noFill/>
+          <a:ln>
+            <a:solidFill>
+              <a:schemeClr val="tx1">
+                <a:lumMod val="85000"/>
+                <a:lumOff val="15000"/>
+              </a:schemeClr>
+            </a:solidFill>
+          </a:ln>
+        </p:spPr>
+        <p:style>
+          <a:lnRef idx="2">
+            <a:schemeClr val="accent1">
+              <a:shade val="15000"/>
+            </a:schemeClr>
+          </a:lnRef>
+          <a:fillRef idx="1">
+            <a:schemeClr val="accent1"/>
+          </a:fillRef>
+          <a:effectRef idx="0">
+            <a:schemeClr val="accent1"/>
+          </a:effectRef>
+          <a:fontRef idx="minor">
+            <a:schemeClr val="lt1"/>
+          </a:fontRef>
+        </p:style>
+        <p:txBody>
+          <a:bodyPr rtlCol="0" anchor="ctr"/>
+          <a:lstStyle/>
+          <a:p>
+            <a:pPr algn="ctr"/>
+            <a:endParaRPr lang="en-GB" noProof="0" dirty="0"/>
+          </a:p>
+        </p:txBody>
+      </p:sp>
+      <p:sp>
+        <p:nvSpPr>
+          <p:cNvPr id="163" name="TextBox 162">
+            <a:extLst>
+              <a:ext uri="{FF2B5EF4-FFF2-40B4-BE49-F238E27FC236}">
+                <a16:creationId xmlns:a16="http://schemas.microsoft.com/office/drawing/2014/main" id="{80DC8BB1-3935-E17A-25BB-74A2F1D33D3A}"/>
+              </a:ext>
+            </a:extLst>
+          </p:cNvPr>
+          <p:cNvSpPr txBox="1"/>
+          <p:nvPr/>
+        </p:nvSpPr>
+        <p:spPr>
+          <a:xfrm>
+            <a:off x="2418952" y="4141586"/>
+            <a:ext cx="2792111" cy="556947"/>
+          </a:xfrm>
+          <a:prstGeom prst="rect">
+            <a:avLst/>
+          </a:prstGeom>
+          <a:noFill/>
+        </p:spPr>
+        <p:txBody>
+          <a:bodyPr wrap="square" lIns="0" tIns="0" rIns="0" bIns="0" rtlCol="0">
+            <a:spAutoFit/>
+          </a:bodyPr>
+          <a:lstStyle/>
+          <a:p>
+            <a:pPr>
+              <a:buSzPct val="100000"/>
+            </a:pPr>
+            <a:r>
+              <a:rPr lang="en-GB" sz="1400" b="1" dirty="0">
+                <a:solidFill>
+                  <a:schemeClr val="tx1">
+                    <a:lumMod val="85000"/>
+                    <a:lumOff val="15000"/>
+                  </a:schemeClr>
+                </a:solidFill>
+                <a:latin typeface="DM Sans" pitchFamily="2" charset="0"/>
+              </a:rPr>
+              <a:t>DATA</a:t>
+            </a:r>
+          </a:p>
+          <a:p>
+            <a:pPr>
+              <a:lnSpc>
+                <a:spcPts val="1300"/>
+              </a:lnSpc>
+              <a:buSzPct val="100000"/>
+            </a:pPr>
+            <a:r>
+              <a:rPr lang="en-GB" sz="1200" dirty="0">
+                <a:solidFill>
+                  <a:schemeClr val="tx1">
+                    <a:lumMod val="85000"/>
+                    <a:lumOff val="15000"/>
+                  </a:schemeClr>
+                </a:solidFill>
+                <a:latin typeface="+mj-lt"/>
+              </a:rPr>
+              <a:t>Reusable data products, analytics, architecture, monetization</a:t>
+            </a:r>
+          </a:p>
+        </p:txBody>
+      </p:sp>
+      <p:sp>
+        <p:nvSpPr>
+          <p:cNvPr id="166" name="TextBox 165">
+            <a:extLst>
+              <a:ext uri="{FF2B5EF4-FFF2-40B4-BE49-F238E27FC236}">
+                <a16:creationId xmlns:a16="http://schemas.microsoft.com/office/drawing/2014/main" id="{10166978-2E96-E3A3-95B8-30EF5CAF9525}"/>
+              </a:ext>
+            </a:extLst>
+          </p:cNvPr>
+          <p:cNvSpPr txBox="1"/>
+          <p:nvPr/>
+        </p:nvSpPr>
+        <p:spPr>
+          <a:xfrm>
+            <a:off x="6293260" y="4141586"/>
+            <a:ext cx="2548336" cy="556947"/>
+          </a:xfrm>
+          <a:prstGeom prst="rect">
+            <a:avLst/>
+          </a:prstGeom>
+          <a:noFill/>
+        </p:spPr>
+        <p:txBody>
+          <a:bodyPr wrap="square" lIns="0" tIns="0" rIns="0" bIns="0" rtlCol="0">
+            <a:spAutoFit/>
+          </a:bodyPr>
+          <a:lstStyle/>
+          <a:p>
+            <a:pPr>
+              <a:buSzPct val="100000"/>
+            </a:pPr>
+            <a:r>
+              <a:rPr lang="en-GB" sz="1400" b="1" dirty="0">
+                <a:solidFill>
+                  <a:schemeClr val="tx1">
+                    <a:lumMod val="85000"/>
+                    <a:lumOff val="15000"/>
+                  </a:schemeClr>
+                </a:solidFill>
+                <a:latin typeface="DM Sans" pitchFamily="2" charset="0"/>
+              </a:rPr>
+              <a:t>TECHNOLOGY</a:t>
+            </a:r>
+          </a:p>
+          <a:p>
+            <a:pPr>
+              <a:lnSpc>
+                <a:spcPts val="1300"/>
+              </a:lnSpc>
+              <a:buSzPct val="100000"/>
+            </a:pPr>
+            <a:r>
+              <a:rPr lang="en-GB" sz="1200" dirty="0">
+                <a:solidFill>
+                  <a:schemeClr val="tx1">
+                    <a:lumMod val="85000"/>
+                    <a:lumOff val="15000"/>
+                  </a:schemeClr>
+                </a:solidFill>
+                <a:latin typeface="+mj-lt"/>
+              </a:rPr>
+              <a:t>Target architecture, platforms &amp; solutions, integration </a:t>
+            </a:r>
+          </a:p>
+        </p:txBody>
+      </p:sp>
+      <p:sp>
+        <p:nvSpPr>
+          <p:cNvPr id="140" name="Rectangle 139">
+            <a:extLst>
+              <a:ext uri="{FF2B5EF4-FFF2-40B4-BE49-F238E27FC236}">
+                <a16:creationId xmlns:a16="http://schemas.microsoft.com/office/drawing/2014/main" id="{408780A7-24D1-5FA9-1D03-00F17CEDD27F}"/>
+              </a:ext>
+            </a:extLst>
+          </p:cNvPr>
+          <p:cNvSpPr/>
+          <p:nvPr/>
+        </p:nvSpPr>
+        <p:spPr>
+          <a:xfrm>
+            <a:off x="2271958" y="1981106"/>
+            <a:ext cx="7651834" cy="908874"/>
+          </a:xfrm>
+          <a:prstGeom prst="roundRect">
+            <a:avLst/>
+          </a:prstGeom>
+          <a:noFill/>
+          <a:ln>
+            <a:solidFill>
+              <a:schemeClr val="tx1">
+                <a:lumMod val="85000"/>
+                <a:lumOff val="15000"/>
+              </a:schemeClr>
+            </a:solidFill>
+          </a:ln>
+        </p:spPr>
+        <p:style>
+          <a:lnRef idx="2">
+            <a:schemeClr val="accent1">
+              <a:shade val="15000"/>
+            </a:schemeClr>
+          </a:lnRef>
+          <a:fillRef idx="1">
+            <a:schemeClr val="accent1"/>
+          </a:fillRef>
+          <a:effectRef idx="0">
+            <a:schemeClr val="accent1"/>
+          </a:effectRef>
+          <a:fontRef idx="minor">
+            <a:schemeClr val="lt1"/>
+          </a:fontRef>
+        </p:style>
+        <p:txBody>
+          <a:bodyPr rtlCol="0" anchor="ctr"/>
+          <a:lstStyle/>
+          <a:p>
+            <a:pPr algn="ctr"/>
+            <a:endParaRPr lang="en-GB" noProof="0" dirty="0"/>
+          </a:p>
+        </p:txBody>
+      </p:sp>
+      <p:sp>
+        <p:nvSpPr>
+          <p:cNvPr id="141" name="TextBox 140">
+            <a:extLst>
+              <a:ext uri="{FF2B5EF4-FFF2-40B4-BE49-F238E27FC236}">
+                <a16:creationId xmlns:a16="http://schemas.microsoft.com/office/drawing/2014/main" id="{0F7C620F-BBEE-7637-3EFD-6F8FCA9B7A17}"/>
+              </a:ext>
+            </a:extLst>
+          </p:cNvPr>
+          <p:cNvSpPr txBox="1"/>
+          <p:nvPr/>
+        </p:nvSpPr>
+        <p:spPr>
+          <a:xfrm>
+            <a:off x="2418950" y="2047612"/>
+            <a:ext cx="3874310" cy="549766"/>
+          </a:xfrm>
+          <a:prstGeom prst="rect">
+            <a:avLst/>
+          </a:prstGeom>
+          <a:noFill/>
+        </p:spPr>
+        <p:txBody>
+          <a:bodyPr wrap="square" lIns="0" tIns="0" rIns="0" bIns="0" rtlCol="0">
+            <a:spAutoFit/>
+          </a:bodyPr>
+          <a:lstStyle/>
+          <a:p>
+            <a:pPr>
+              <a:buSzPct val="100000"/>
+            </a:pPr>
+            <a:r>
+              <a:rPr lang="en-GB" sz="1400" b="1" noProof="0" dirty="0">
+                <a:solidFill>
+                  <a:schemeClr val="tx1">
+                    <a:lumMod val="85000"/>
+                    <a:lumOff val="15000"/>
+                  </a:schemeClr>
+                </a:solidFill>
+                <a:latin typeface="DM Sans" pitchFamily="2" charset="0"/>
+              </a:rPr>
+              <a:t>PRODUCTS</a:t>
+            </a:r>
+            <a:r>
+              <a:rPr lang="en-GB" sz="1400" noProof="0" dirty="0">
+                <a:solidFill>
+                  <a:schemeClr val="tx1">
+                    <a:lumMod val="85000"/>
+                    <a:lumOff val="15000"/>
+                  </a:schemeClr>
+                </a:solidFill>
+                <a:latin typeface="DM Sans" pitchFamily="2" charset="0"/>
+              </a:rPr>
+              <a:t> -  by business unit</a:t>
+            </a:r>
+          </a:p>
+          <a:p>
+            <a:pPr>
+              <a:lnSpc>
+                <a:spcPts val="1300"/>
+              </a:lnSpc>
+              <a:buSzPct val="100000"/>
+            </a:pPr>
+            <a:r>
+              <a:rPr lang="en-GB" sz="1200" noProof="0" dirty="0">
+                <a:solidFill>
+                  <a:schemeClr val="tx1">
+                    <a:lumMod val="85000"/>
+                    <a:lumOff val="15000"/>
+                  </a:schemeClr>
+                </a:solidFill>
+                <a:latin typeface="+mj-lt"/>
+              </a:rPr>
+              <a:t>Product vision &amp; objectives, products, persona’s, customer journeys, frictions</a:t>
+            </a:r>
+          </a:p>
+        </p:txBody>
+      </p:sp>
+      <p:sp>
+        <p:nvSpPr>
+          <p:cNvPr id="43" name="Rectangle 42">
+            <a:extLst>
+              <a:ext uri="{FF2B5EF4-FFF2-40B4-BE49-F238E27FC236}">
+                <a16:creationId xmlns:a16="http://schemas.microsoft.com/office/drawing/2014/main" id="{E0F4E9CB-0A0E-4690-0FA6-9ED54FEC3B60}"/>
+              </a:ext>
+            </a:extLst>
+          </p:cNvPr>
+          <p:cNvSpPr/>
+          <p:nvPr/>
+        </p:nvSpPr>
+        <p:spPr>
+          <a:xfrm>
+            <a:off x="6857075" y="2084448"/>
+            <a:ext cx="606304" cy="697758"/>
+          </a:xfrm>
+          <a:prstGeom prst="rect">
+            <a:avLst/>
+          </a:prstGeom>
+          <a:solidFill>
+            <a:schemeClr val="tx1">
+              <a:lumMod val="65000"/>
+              <a:lumOff val="35000"/>
+              <a:alpha val="20000"/>
+            </a:schemeClr>
+          </a:solidFill>
+          <a:ln>
+            <a:noFill/>
+          </a:ln>
+        </p:spPr>
+        <p:style>
+          <a:lnRef idx="2">
+            <a:schemeClr val="accent1">
+              <a:shade val="15000"/>
+            </a:schemeClr>
+          </a:lnRef>
+          <a:fillRef idx="1">
+            <a:schemeClr val="accent1"/>
+          </a:fillRef>
+          <a:effectRef idx="0">
+            <a:schemeClr val="accent1"/>
+          </a:effectRef>
+          <a:fontRef idx="minor">
+            <a:schemeClr val="lt1"/>
+          </a:fontRef>
+        </p:style>
+        <p:txBody>
+          <a:bodyPr rtlCol="0" anchor="ctr"/>
+          <a:lstStyle/>
+          <a:p>
+            <a:pPr algn="ctr"/>
+            <a:r>
+              <a:rPr lang="en-GB" sz="1100" noProof="0" dirty="0">
+                <a:solidFill>
+                  <a:schemeClr val="tx1">
+                    <a:lumMod val="85000"/>
+                    <a:lumOff val="15000"/>
+                  </a:schemeClr>
+                </a:solidFill>
+                <a:latin typeface="DM Sans" pitchFamily="2" charset="0"/>
+              </a:rPr>
+              <a:t>BU 1</a:t>
+            </a:r>
+          </a:p>
+        </p:txBody>
+      </p:sp>
+      <p:sp>
+        <p:nvSpPr>
+          <p:cNvPr id="44" name="Rectangle 43">
+            <a:extLst>
+              <a:ext uri="{FF2B5EF4-FFF2-40B4-BE49-F238E27FC236}">
+                <a16:creationId xmlns:a16="http://schemas.microsoft.com/office/drawing/2014/main" id="{BF71C01D-C3EC-7385-38F5-111CD7EAAE7D}"/>
+              </a:ext>
+            </a:extLst>
+          </p:cNvPr>
+          <p:cNvSpPr/>
+          <p:nvPr/>
+        </p:nvSpPr>
+        <p:spPr>
+          <a:xfrm>
+            <a:off x="7543657" y="2084448"/>
+            <a:ext cx="606304" cy="697758"/>
+          </a:xfrm>
+          <a:prstGeom prst="rect">
+            <a:avLst/>
+          </a:prstGeom>
+          <a:solidFill>
+            <a:schemeClr val="tx1">
+              <a:lumMod val="65000"/>
+              <a:lumOff val="35000"/>
+              <a:alpha val="20000"/>
+            </a:schemeClr>
+          </a:solidFill>
+          <a:ln>
+            <a:noFill/>
+          </a:ln>
+        </p:spPr>
+        <p:style>
+          <a:lnRef idx="2">
+            <a:schemeClr val="accent1">
+              <a:shade val="15000"/>
+            </a:schemeClr>
+          </a:lnRef>
+          <a:fillRef idx="1">
+            <a:schemeClr val="accent1"/>
+          </a:fillRef>
+          <a:effectRef idx="0">
+            <a:schemeClr val="accent1"/>
+          </a:effectRef>
+          <a:fontRef idx="minor">
+            <a:schemeClr val="lt1"/>
+          </a:fontRef>
+        </p:style>
+        <p:txBody>
+          <a:bodyPr rtlCol="0" anchor="ctr"/>
+          <a:lstStyle/>
+          <a:p>
+            <a:pPr algn="ctr"/>
+            <a:r>
+              <a:rPr lang="en-GB" sz="1100" noProof="0" dirty="0">
+                <a:solidFill>
+                  <a:schemeClr val="tx1">
+                    <a:lumMod val="85000"/>
+                    <a:lumOff val="15000"/>
+                  </a:schemeClr>
+                </a:solidFill>
+                <a:latin typeface="DM Sans" pitchFamily="2" charset="0"/>
+              </a:rPr>
+              <a:t>BU 2</a:t>
+            </a:r>
+          </a:p>
+        </p:txBody>
+      </p:sp>
+      <p:sp>
+        <p:nvSpPr>
+          <p:cNvPr id="30" name="Rectangle 42">
+            <a:extLst>
+              <a:ext uri="{FF2B5EF4-FFF2-40B4-BE49-F238E27FC236}">
+                <a16:creationId xmlns:a16="http://schemas.microsoft.com/office/drawing/2014/main" id="{7505B10F-04F0-C6AA-EB31-F410AA01EEBA}"/>
+              </a:ext>
+            </a:extLst>
+          </p:cNvPr>
+          <p:cNvSpPr/>
+          <p:nvPr/>
+        </p:nvSpPr>
+        <p:spPr>
+          <a:xfrm>
+            <a:off x="8230239" y="2084448"/>
+            <a:ext cx="606304" cy="697758"/>
+          </a:xfrm>
+          <a:prstGeom prst="rect">
+            <a:avLst/>
+          </a:prstGeom>
+          <a:solidFill>
+            <a:schemeClr val="tx1">
+              <a:lumMod val="65000"/>
+              <a:lumOff val="35000"/>
+              <a:alpha val="20000"/>
+            </a:schemeClr>
+          </a:solidFill>
+          <a:ln>
+            <a:noFill/>
+          </a:ln>
+        </p:spPr>
+        <p:style>
+          <a:lnRef idx="2">
+            <a:schemeClr val="accent1">
+              <a:shade val="15000"/>
+            </a:schemeClr>
+          </a:lnRef>
+          <a:fillRef idx="1">
+            <a:schemeClr val="accent1"/>
+          </a:fillRef>
+          <a:effectRef idx="0">
+            <a:schemeClr val="accent1"/>
+          </a:effectRef>
+          <a:fontRef idx="minor">
+            <a:schemeClr val="lt1"/>
+          </a:fontRef>
+        </p:style>
+        <p:txBody>
+          <a:bodyPr rtlCol="0" anchor="ctr"/>
+          <a:lstStyle/>
+          <a:p>
+            <a:pPr algn="ctr"/>
+            <a:r>
+              <a:rPr lang="en-GB" sz="1100" noProof="0" dirty="0">
+                <a:solidFill>
+                  <a:schemeClr val="tx1">
+                    <a:lumMod val="85000"/>
+                    <a:lumOff val="15000"/>
+                  </a:schemeClr>
+                </a:solidFill>
+                <a:latin typeface="DM Sans" pitchFamily="2" charset="0"/>
+              </a:rPr>
+              <a:t>BU 3</a:t>
+            </a:r>
+          </a:p>
+        </p:txBody>
+      </p:sp>
+      <p:sp>
+        <p:nvSpPr>
+          <p:cNvPr id="32" name="Rectangle 43">
+            <a:extLst>
+              <a:ext uri="{FF2B5EF4-FFF2-40B4-BE49-F238E27FC236}">
+                <a16:creationId xmlns:a16="http://schemas.microsoft.com/office/drawing/2014/main" id="{4109848C-6F06-818E-FE0D-EF820C4C18F5}"/>
+              </a:ext>
+            </a:extLst>
+          </p:cNvPr>
+          <p:cNvSpPr/>
+          <p:nvPr/>
+        </p:nvSpPr>
+        <p:spPr>
+          <a:xfrm>
+            <a:off x="8916822" y="2084448"/>
+            <a:ext cx="606304" cy="697758"/>
+          </a:xfrm>
+          <a:prstGeom prst="rect">
+            <a:avLst/>
+          </a:prstGeom>
+          <a:solidFill>
+            <a:schemeClr val="tx1">
+              <a:lumMod val="65000"/>
+              <a:lumOff val="35000"/>
+              <a:alpha val="20000"/>
+            </a:schemeClr>
+          </a:solidFill>
+          <a:ln>
+            <a:noFill/>
+          </a:ln>
+        </p:spPr>
+        <p:style>
+          <a:lnRef idx="2">
+            <a:schemeClr val="accent1">
+              <a:shade val="15000"/>
+            </a:schemeClr>
+          </a:lnRef>
+          <a:fillRef idx="1">
+            <a:schemeClr val="accent1"/>
+          </a:fillRef>
+          <a:effectRef idx="0">
+            <a:schemeClr val="accent1"/>
+          </a:effectRef>
+          <a:fontRef idx="minor">
+            <a:schemeClr val="lt1"/>
+          </a:fontRef>
+        </p:style>
+        <p:txBody>
+          <a:bodyPr rtlCol="0" anchor="ctr"/>
+          <a:lstStyle/>
+          <a:p>
+            <a:pPr algn="ctr"/>
+            <a:r>
+              <a:rPr lang="en-GB" sz="1100" noProof="0" dirty="0">
+                <a:solidFill>
+                  <a:schemeClr val="tx1">
+                    <a:lumMod val="85000"/>
+                    <a:lumOff val="15000"/>
+                  </a:schemeClr>
+                </a:solidFill>
+                <a:latin typeface="DM Sans" pitchFamily="2" charset="0"/>
+              </a:rPr>
+              <a:t>BU 4</a:t>
+            </a:r>
+          </a:p>
+        </p:txBody>
+      </p:sp>
+      <p:pic>
+        <p:nvPicPr>
+          <p:cNvPr id="33" name="Afbeelding 32" descr="Afbeelding met tekst, schermopname, Lettertype, lijn&#10;&#10;Door AI gegenereerde inhoud is mogelijk onjuist.">
+            <a:extLst>
+              <a:ext uri="{FF2B5EF4-FFF2-40B4-BE49-F238E27FC236}">
+                <a16:creationId xmlns:a16="http://schemas.microsoft.com/office/drawing/2014/main" id="{14DF526F-073F-3342-E25A-644CF951ED34}"/>
+              </a:ext>
+            </a:extLst>
+          </p:cNvPr>
+          <p:cNvPicPr>
+            <a:picLocks noChangeAspect="1"/>
+          </p:cNvPicPr>
+          <p:nvPr/>
+        </p:nvPicPr>
+        <p:blipFill>
+          <a:blip r:embed="rId3"/>
+          <a:stretch>
+            <a:fillRect/>
+          </a:stretch>
+        </p:blipFill>
+        <p:spPr>
+          <a:xfrm>
+            <a:off x="12333890" y="551145"/>
+            <a:ext cx="8051107" cy="4602677"/>
+          </a:xfrm>
+          <a:prstGeom prst="rect">
+            <a:avLst/>
+          </a:prstGeom>
+        </p:spPr>
+      </p:pic>
+    </p:spTree>
+    <p:extLst>
+      <p:ext uri="{BB962C8B-B14F-4D97-AF65-F5344CB8AC3E}">
+        <p14:creationId xmlns:p14="http://schemas.microsoft.com/office/powerpoint/2010/main" val="3928762808"/>
+      </p:ext>
+    </p:extLst>
+  </p:cSld>
+  <p:clrMapOvr>
+    <a:masterClrMapping/>
+  </p:clrMapOvr>
+</p:sld>
+</file>
+
+<file path=ppt/slides/slide5.xml><?xml version="1.0" encoding="utf-8"?>
+<p:sld xmlns:a="http://schemas.openxmlformats.org/drawingml/2006/main" xmlns:r="http://schemas.openxmlformats.org/officeDocument/2006/relationships" xmlns:p="http://schemas.openxmlformats.org/presentationml/2006/main">
+  <p:cSld>
+    <p:spTree>
+      <p:nvGrpSpPr>
+        <p:cNvPr id="1" name="">
+          <a:extLst>
+            <a:ext uri="{FF2B5EF4-FFF2-40B4-BE49-F238E27FC236}">
               <a16:creationId xmlns:a16="http://schemas.microsoft.com/office/drawing/2014/main" id="{80C594DE-F555-AE44-E672-38D3D916365B}"/>
             </a:ext>
           </a:extLst>
@@ -8714,7 +10141,7 @@
 </p:sld>
 </file>
 
-<file path=ppt/slides/slide5.xml><?xml version="1.0" encoding="utf-8"?>
+<file path=ppt/slides/slide6.xml><?xml version="1.0" encoding="utf-8"?>
 <p:sld xmlns:a="http://schemas.openxmlformats.org/drawingml/2006/main" xmlns:r="http://schemas.openxmlformats.org/officeDocument/2006/relationships" xmlns:p="http://schemas.openxmlformats.org/presentationml/2006/main">
   <p:cSld>
     <p:spTree>
@@ -9498,7 +10925,7 @@
 </p:sld>
 </file>
 
-<file path=ppt/slides/slide6.xml><?xml version="1.0" encoding="utf-8"?>
+<file path=ppt/slides/slide7.xml><?xml version="1.0" encoding="utf-8"?>
 <p:sld xmlns:a="http://schemas.openxmlformats.org/drawingml/2006/main" xmlns:r="http://schemas.openxmlformats.org/officeDocument/2006/relationships" xmlns:p="http://schemas.openxmlformats.org/presentationml/2006/main">
   <p:cSld>
     <p:spTree>

</xml_diff>

<commit_message>
FINAL VERSION FOR PUBLICATION
</commit_message>
<xml_diff>
--- a/input/AI Transformation framework for European CEO’s.pptx
+++ b/input/AI Transformation framework for European CEO’s.pptx
@@ -331,7 +331,7 @@
           <a:p>
             <a:fld id="{FAB7A3DB-122E-499C-AAFB-3D4665CBCADB}" type="datetimeFigureOut">
               <a:rPr lang="en-GB" smtClean="0"/>
-              <a:t>05/04/2026</a:t>
+              <a:t>06/04/2026</a:t>
             </a:fld>
             <a:endParaRPr lang="en-GB"/>
           </a:p>
@@ -1480,7 +1480,7 @@
           <a:p>
             <a:fld id="{7E530143-BC45-40DA-908E-84B30ACFDA34}" type="datetimeFigureOut">
               <a:rPr lang="en-GB" smtClean="0"/>
-              <a:t>05/04/2026</a:t>
+              <a:t>06/04/2026</a:t>
             </a:fld>
             <a:endParaRPr lang="en-GB"/>
           </a:p>
@@ -1680,7 +1680,7 @@
           <a:p>
             <a:fld id="{7E530143-BC45-40DA-908E-84B30ACFDA34}" type="datetimeFigureOut">
               <a:rPr lang="en-GB" smtClean="0"/>
-              <a:t>05/04/2026</a:t>
+              <a:t>06/04/2026</a:t>
             </a:fld>
             <a:endParaRPr lang="en-GB"/>
           </a:p>
@@ -1890,7 +1890,7 @@
           <a:p>
             <a:fld id="{7E530143-BC45-40DA-908E-84B30ACFDA34}" type="datetimeFigureOut">
               <a:rPr lang="en-GB" smtClean="0"/>
-              <a:t>05/04/2026</a:t>
+              <a:t>06/04/2026</a:t>
             </a:fld>
             <a:endParaRPr lang="en-GB"/>
           </a:p>
@@ -2514,7 +2514,7 @@
           <a:p>
             <a:fld id="{7E530143-BC45-40DA-908E-84B30ACFDA34}" type="datetimeFigureOut">
               <a:rPr lang="en-GB" smtClean="0"/>
-              <a:t>05/04/2026</a:t>
+              <a:t>06/04/2026</a:t>
             </a:fld>
             <a:endParaRPr lang="en-GB"/>
           </a:p>
@@ -2790,7 +2790,7 @@
           <a:p>
             <a:fld id="{7E530143-BC45-40DA-908E-84B30ACFDA34}" type="datetimeFigureOut">
               <a:rPr lang="en-GB" smtClean="0"/>
-              <a:t>05/04/2026</a:t>
+              <a:t>06/04/2026</a:t>
             </a:fld>
             <a:endParaRPr lang="en-GB"/>
           </a:p>
@@ -3058,7 +3058,7 @@
           <a:p>
             <a:fld id="{7E530143-BC45-40DA-908E-84B30ACFDA34}" type="datetimeFigureOut">
               <a:rPr lang="en-GB" smtClean="0"/>
-              <a:t>05/04/2026</a:t>
+              <a:t>06/04/2026</a:t>
             </a:fld>
             <a:endParaRPr lang="en-GB"/>
           </a:p>
@@ -3473,7 +3473,7 @@
           <a:p>
             <a:fld id="{7E530143-BC45-40DA-908E-84B30ACFDA34}" type="datetimeFigureOut">
               <a:rPr lang="en-GB" smtClean="0"/>
-              <a:t>05/04/2026</a:t>
+              <a:t>06/04/2026</a:t>
             </a:fld>
             <a:endParaRPr lang="en-GB"/>
           </a:p>
@@ -3615,7 +3615,7 @@
           <a:p>
             <a:fld id="{7E530143-BC45-40DA-908E-84B30ACFDA34}" type="datetimeFigureOut">
               <a:rPr lang="en-GB" smtClean="0"/>
-              <a:t>05/04/2026</a:t>
+              <a:t>06/04/2026</a:t>
             </a:fld>
             <a:endParaRPr lang="en-GB"/>
           </a:p>
@@ -3728,7 +3728,7 @@
           <a:p>
             <a:fld id="{7E530143-BC45-40DA-908E-84B30ACFDA34}" type="datetimeFigureOut">
               <a:rPr lang="en-GB" smtClean="0"/>
-              <a:t>05/04/2026</a:t>
+              <a:t>06/04/2026</a:t>
             </a:fld>
             <a:endParaRPr lang="en-GB"/>
           </a:p>
@@ -4041,7 +4041,7 @@
           <a:p>
             <a:fld id="{7E530143-BC45-40DA-908E-84B30ACFDA34}" type="datetimeFigureOut">
               <a:rPr lang="en-GB" smtClean="0"/>
-              <a:t>05/04/2026</a:t>
+              <a:t>06/04/2026</a:t>
             </a:fld>
             <a:endParaRPr lang="en-GB"/>
           </a:p>
@@ -4330,7 +4330,7 @@
           <a:p>
             <a:fld id="{7E530143-BC45-40DA-908E-84B30ACFDA34}" type="datetimeFigureOut">
               <a:rPr lang="en-GB" smtClean="0"/>
-              <a:t>05/04/2026</a:t>
+              <a:t>06/04/2026</a:t>
             </a:fld>
             <a:endParaRPr lang="en-GB"/>
           </a:p>
@@ -4573,7 +4573,7 @@
           <a:p>
             <a:fld id="{7E530143-BC45-40DA-908E-84B30ACFDA34}" type="datetimeFigureOut">
               <a:rPr lang="en-GB" smtClean="0"/>
-              <a:t>05/04/2026</a:t>
+              <a:t>06/04/2026</a:t>
             </a:fld>
             <a:endParaRPr lang="en-GB"/>
           </a:p>
@@ -9279,10 +9279,10 @@
       </p:grpSpPr>
       <p:sp>
         <p:nvSpPr>
-          <p:cNvPr id="2" name="Rechthoek 1">
-            <a:extLst>
-              <a:ext uri="{FF2B5EF4-FFF2-40B4-BE49-F238E27FC236}">
-                <a16:creationId xmlns:a16="http://schemas.microsoft.com/office/drawing/2014/main" id="{4F281C37-C738-14E4-D9BA-372E8CE62DC3}"/>
+          <p:cNvPr id="4" name="Rechthoek 3">
+            <a:extLst>
+              <a:ext uri="{FF2B5EF4-FFF2-40B4-BE49-F238E27FC236}">
+                <a16:creationId xmlns:a16="http://schemas.microsoft.com/office/drawing/2014/main" id="{E656BF4B-30F9-BF3D-DBA2-480FF3018B94}"/>
               </a:ext>
             </a:extLst>
           </p:cNvPr>
@@ -9291,8 +9291,8 @@
         </p:nvSpPr>
         <p:spPr>
           <a:xfrm>
-            <a:off x="2509695" y="409251"/>
-            <a:ext cx="7162450" cy="4619949"/>
+            <a:off x="2103120" y="409251"/>
+            <a:ext cx="8006080" cy="4769872"/>
           </a:xfrm>
           <a:prstGeom prst="rect">
             <a:avLst/>

</xml_diff>